<commit_message>
Address self-review: bigger bank, honest claims, competitors, stronger tests
- Question bank 52 -> 102 (6 per topic); practice serves unseen questions first
- Replace two weak tests with deterministic ones; add bank and practice tests (16 total)
- Report simulation on a held-out set not used for tuning
- Remove unsourced claims and the '2x fewer questions' comparison
- Add competitor comparison (README, pitch Q&A, new slide)

Co-Authored-By: Claude Opus 5 <noreply@anthropic.com>
</commit_message>
<xml_diff>
--- a/docs/Tamyr_VentureHack2026.pptx
+++ b/docs/Tamyr_VentureHack2026.pptx
@@ -15,6 +15,7 @@
     <p:sldId id="263" r:id="rId15"/>
     <p:sldId id="264" r:id="rId16"/>
     <p:sldId id="265" r:id="rId17"/>
+    <p:sldId id="266" r:id="rId18"/>
   </p:sldIdLst>
   <p:sldSz cx="12191695" cy="6858000" type="screen4x3"/>
   <p:notesSz cx="6858000" cy="9144000"/>
@@ -817,6 +818,76 @@
 </file>
 
 <file path=ppt/notesSlides/notesSlide6.xml><?xml version="1.0" encoding="utf-8"?>
+<p:notes xmlns:a="http://schemas.openxmlformats.org/drawingml/2006/main" xmlns:p="http://schemas.openxmlformats.org/presentationml/2006/main" xmlns:r="http://schemas.openxmlformats.org/officeDocument/2006/relationships">
+  <p:cSld>
+    <p:spTree>
+      <p:nvGrpSpPr>
+        <p:cNvPr id="1" name=""/>
+        <p:cNvGrpSpPr/>
+        <p:nvPr/>
+      </p:nvGrpSpPr>
+      <p:grpSpPr>
+        <a:xfrm>
+          <a:off x="0" y="0"/>
+          <a:ext cx="0" cy="0"/>
+          <a:chOff x="0" y="0"/>
+          <a:chExt cx="0" cy="0"/>
+        </a:xfrm>
+      </p:grpSpPr>
+      <p:sp>
+        <p:nvSpPr>
+          <p:cNvPr id="2" name="Slide Image Placeholder 1"/>
+          <p:cNvSpPr>
+            <a:spLocks noGrp="1"/>
+          </p:cNvSpPr>
+          <p:nvPr>
+            <p:ph type="sldImg" idx="2"/>
+          </p:nvPr>
+        </p:nvSpPr>
+        <p:spPr/>
+      </p:sp>
+      <p:sp>
+        <p:nvSpPr>
+          <p:cNvPr id="3" name="Notes Placeholder 2"/>
+          <p:cNvSpPr>
+            <a:spLocks noGrp="1"/>
+          </p:cNvSpPr>
+          <p:nvPr>
+            <p:ph type="body" idx="3" sz="quarter"/>
+          </p:nvPr>
+        </p:nvSpPr>
+        <p:spPr/>
+        <p:txBody>
+          <a:bodyPr/>
+          <a:lstStyle/>
+          <a:p>
+            <a:r>
+              <a:t>Не утверждайте, что идея уникальна: жюри может знать ALEKS и Eedi. Перед защитой проверьте актуальные описания конкурентов на их сайтах.</a:t>
+            </a:r>
+          </a:p>
+        </p:txBody>
+      </p:sp>
+      <p:sp>
+        <p:nvSpPr>
+          <p:cNvPr id="4" name="Slide Number Placeholder 3"/>
+          <p:cNvSpPr>
+            <a:spLocks noGrp="1"/>
+          </p:cNvSpPr>
+          <p:nvPr>
+            <p:ph type="sldNum" idx="5" sz="quarter"/>
+          </p:nvPr>
+        </p:nvSpPr>
+        <p:spPr/>
+      </p:sp>
+    </p:spTree>
+  </p:cSld>
+  <p:clrMapOvr>
+    <a:masterClrMapping/>
+  </p:clrMapOvr>
+</p:notes>
+</file>
+
+<file path=ppt/notesSlides/notesSlide7.xml><?xml version="1.0" encoding="utf-8"?>
 <p:notes xmlns:a="http://schemas.openxmlformats.org/drawingml/2006/main" xmlns:p="http://schemas.openxmlformats.org/presentationml/2006/main" xmlns:r="http://schemas.openxmlformats.org/officeDocument/2006/relationships">
   <p:cSld>
     <p:spTree>
@@ -4257,6 +4328,601 @@
     <p:bg>
       <p:bgPr>
         <a:solidFill>
+          <a:srgbClr val="FFFFFF"/>
+        </a:solidFill>
+        <a:effectLst/>
+      </p:bgPr>
+    </p:bg>
+    <p:spTree>
+      <p:nvGrpSpPr>
+        <p:cNvPr id="1" name=""/>
+        <p:cNvGrpSpPr/>
+        <p:nvPr/>
+      </p:nvGrpSpPr>
+      <p:grpSpPr/>
+      <p:sp>
+        <p:nvSpPr>
+          <p:cNvPr id="2" name="TextBox 1"/>
+          <p:cNvSpPr txBox="1"/>
+          <p:nvPr/>
+        </p:nvSpPr>
+        <p:spPr>
+          <a:xfrm>
+            <a:off x="640080" y="502920"/>
+            <a:ext cx="10881360" cy="320040"/>
+          </a:xfrm>
+          <a:prstGeom prst="rect">
+            <a:avLst/>
+          </a:prstGeom>
+          <a:noFill/>
+        </p:spPr>
+        <p:txBody>
+          <a:bodyPr wrap="square" lIns="0" rIns="0" tIns="0" bIns="0" anchor="t">
+            <a:spAutoFit/>
+          </a:bodyPr>
+          <a:lstStyle/>
+          <a:p>
+            <a:pPr algn="l"/>
+            <a:r>
+              <a:rPr sz="1200" b="1" i="0">
+                <a:solidFill>
+                  <a:srgbClr val="1F6F5C"/>
+                </a:solidFill>
+                <a:latin typeface="Calibri"/>
+              </a:rPr>
+              <a:t>ВНЕДРЕНИЕ И МОДЕЛЬ</a:t>
+            </a:r>
+          </a:p>
+        </p:txBody>
+      </p:sp>
+      <p:sp>
+        <p:nvSpPr>
+          <p:cNvPr id="3" name="TextBox 2"/>
+          <p:cNvSpPr txBox="1"/>
+          <p:nvPr/>
+        </p:nvSpPr>
+        <p:spPr>
+          <a:xfrm>
+            <a:off x="640080" y="822960"/>
+            <a:ext cx="10881360" cy="822960"/>
+          </a:xfrm>
+          <a:prstGeom prst="rect">
+            <a:avLst/>
+          </a:prstGeom>
+          <a:noFill/>
+        </p:spPr>
+        <p:txBody>
+          <a:bodyPr wrap="square" lIns="0" rIns="0" tIns="0" bIns="0" anchor="t">
+            <a:spAutoFit/>
+          </a:bodyPr>
+          <a:lstStyle/>
+          <a:p>
+            <a:pPr algn="l"/>
+            <a:r>
+              <a:rPr sz="3600" b="1" i="0">
+                <a:solidFill>
+                  <a:srgbClr val="1D1F1C"/>
+                </a:solidFill>
+                <a:latin typeface="Cambria"/>
+              </a:rPr>
+              <a:t>Реализуемо уже сейчас</a:t>
+            </a:r>
+          </a:p>
+        </p:txBody>
+      </p:sp>
+      <p:sp>
+        <p:nvSpPr>
+          <p:cNvPr id="4" name="Rounded Rectangle 3"/>
+          <p:cNvSpPr/>
+          <p:nvPr/>
+        </p:nvSpPr>
+        <p:spPr>
+          <a:xfrm>
+            <a:off x="640080" y="1920240"/>
+            <a:ext cx="3474720" cy="4114800"/>
+          </a:xfrm>
+          <a:prstGeom prst="roundRect">
+            <a:avLst>
+              <a:gd name="adj" fmla="val 5000"/>
+            </a:avLst>
+          </a:prstGeom>
+          <a:solidFill>
+            <a:srgbClr val="F3F5F2"/>
+          </a:solidFill>
+          <a:ln>
+            <a:noFill/>
+          </a:ln>
+          <a:effectLst/>
+        </p:spPr>
+        <p:style>
+          <a:lnRef idx="1">
+            <a:schemeClr val="accent1"/>
+          </a:lnRef>
+          <a:fillRef idx="3">
+            <a:schemeClr val="accent1"/>
+          </a:fillRef>
+          <a:effectRef idx="2">
+            <a:schemeClr val="accent1"/>
+          </a:effectRef>
+          <a:fontRef idx="minor">
+            <a:schemeClr val="lt1"/>
+          </a:fontRef>
+        </p:style>
+        <p:txBody>
+          <a:bodyPr rtlCol="0" anchor="ctr" lIns="109728" rIns="109728"/>
+          <a:lstStyle/>
+          <a:p>
+            <a:pPr algn="ctr"/>
+          </a:p>
+        </p:txBody>
+      </p:sp>
+      <p:sp>
+        <p:nvSpPr>
+          <p:cNvPr id="5" name="TextBox 4"/>
+          <p:cNvSpPr txBox="1"/>
+          <p:nvPr/>
+        </p:nvSpPr>
+        <p:spPr>
+          <a:xfrm>
+            <a:off x="914400" y="2148840"/>
+            <a:ext cx="2926080" cy="457200"/>
+          </a:xfrm>
+          <a:prstGeom prst="rect">
+            <a:avLst/>
+          </a:prstGeom>
+          <a:noFill/>
+        </p:spPr>
+        <p:txBody>
+          <a:bodyPr wrap="square" lIns="0" rIns="0" tIns="0" bIns="0" anchor="t">
+            <a:spAutoFit/>
+          </a:bodyPr>
+          <a:lstStyle/>
+          <a:p>
+            <a:pPr algn="l"/>
+            <a:r>
+              <a:rPr sz="2100" b="1" i="0">
+                <a:solidFill>
+                  <a:srgbClr val="1F6F5C"/>
+                </a:solidFill>
+                <a:latin typeface="Cambria"/>
+              </a:rPr>
+              <a:t>Технологии</a:t>
+            </a:r>
+          </a:p>
+        </p:txBody>
+      </p:sp>
+      <p:sp>
+        <p:nvSpPr>
+          <p:cNvPr id="6" name="TextBox 5"/>
+          <p:cNvSpPr txBox="1"/>
+          <p:nvPr/>
+        </p:nvSpPr>
+        <p:spPr>
+          <a:xfrm>
+            <a:off x="914400" y="2743200"/>
+            <a:ext cx="2971800" cy="3200400"/>
+          </a:xfrm>
+          <a:prstGeom prst="rect">
+            <a:avLst/>
+          </a:prstGeom>
+          <a:noFill/>
+        </p:spPr>
+        <p:txBody>
+          <a:bodyPr wrap="square" lIns="0" rIns="0" tIns="0" bIns="0" anchor="t">
+            <a:spAutoFit/>
+          </a:bodyPr>
+          <a:lstStyle/>
+          <a:p>
+            <a:pPr algn="l" marL="201168" indent="-201168">
+              <a:spcAft>
+                <a:spcPts val="1000"/>
+              </a:spcAft>
+              <a:buChar char="•"/>
+            </a:pPr>
+            <a:r>
+              <a:rPr sz="1500" b="0" i="0">
+                <a:solidFill>
+                  <a:srgbClr val="1D1F1C"/>
+                </a:solidFill>
+                <a:latin typeface="Calibri"/>
+              </a:rPr>
+              <a:t>HTML/CSS/JS без зависимостей</a:t>
+            </a:r>
+          </a:p>
+          <a:p>
+            <a:pPr algn="l" marL="201168" indent="-201168">
+              <a:spcAft>
+                <a:spcPts val="1000"/>
+              </a:spcAft>
+              <a:buChar char="•"/>
+            </a:pPr>
+            <a:r>
+              <a:rPr sz="1500" b="0" i="0">
+                <a:solidFill>
+                  <a:srgbClr val="1D1F1C"/>
+                </a:solidFill>
+                <a:latin typeface="Calibri"/>
+              </a:rPr>
+              <a:t>Работает офлайн на любом телефоне</a:t>
+            </a:r>
+          </a:p>
+          <a:p>
+            <a:pPr algn="l" marL="201168" indent="-201168">
+              <a:spcAft>
+                <a:spcPts val="1000"/>
+              </a:spcAft>
+              <a:buChar char="•"/>
+            </a:pPr>
+            <a:r>
+              <a:rPr sz="1500" b="0" i="0">
+                <a:solidFill>
+                  <a:srgbClr val="1D1F1C"/>
+                </a:solidFill>
+                <a:latin typeface="Calibri"/>
+              </a:rPr>
+              <a:t>Граф и банк заданий — данные: новый предмет = новый файл</a:t>
+            </a:r>
+          </a:p>
+          <a:p>
+            <a:pPr algn="l" marL="201168" indent="-201168">
+              <a:spcAft>
+                <a:spcPts val="1000"/>
+              </a:spcAft>
+              <a:buChar char="•"/>
+            </a:pPr>
+            <a:r>
+              <a:rPr sz="1500" b="0" i="0">
+                <a:solidFill>
+                  <a:srgbClr val="1D1F1C"/>
+                </a:solidFill>
+                <a:latin typeface="Calibri"/>
+              </a:rPr>
+              <a:t>Персональные данные остаются на устройстве</a:t>
+            </a:r>
+          </a:p>
+        </p:txBody>
+      </p:sp>
+      <p:sp>
+        <p:nvSpPr>
+          <p:cNvPr id="7" name="Rounded Rectangle 6"/>
+          <p:cNvSpPr/>
+          <p:nvPr/>
+        </p:nvSpPr>
+        <p:spPr>
+          <a:xfrm>
+            <a:off x="4389120" y="1920240"/>
+            <a:ext cx="3474720" cy="4114800"/>
+          </a:xfrm>
+          <a:prstGeom prst="roundRect">
+            <a:avLst>
+              <a:gd name="adj" fmla="val 5000"/>
+            </a:avLst>
+          </a:prstGeom>
+          <a:solidFill>
+            <a:srgbClr val="F3F5F2"/>
+          </a:solidFill>
+          <a:ln>
+            <a:noFill/>
+          </a:ln>
+          <a:effectLst/>
+        </p:spPr>
+        <p:style>
+          <a:lnRef idx="1">
+            <a:schemeClr val="accent1"/>
+          </a:lnRef>
+          <a:fillRef idx="3">
+            <a:schemeClr val="accent1"/>
+          </a:fillRef>
+          <a:effectRef idx="2">
+            <a:schemeClr val="accent1"/>
+          </a:effectRef>
+          <a:fontRef idx="minor">
+            <a:schemeClr val="lt1"/>
+          </a:fontRef>
+        </p:style>
+        <p:txBody>
+          <a:bodyPr rtlCol="0" anchor="ctr" lIns="109728" rIns="109728"/>
+          <a:lstStyle/>
+          <a:p>
+            <a:pPr algn="ctr"/>
+          </a:p>
+        </p:txBody>
+      </p:sp>
+      <p:sp>
+        <p:nvSpPr>
+          <p:cNvPr id="8" name="TextBox 7"/>
+          <p:cNvSpPr txBox="1"/>
+          <p:nvPr/>
+        </p:nvSpPr>
+        <p:spPr>
+          <a:xfrm>
+            <a:off x="4663440" y="2148840"/>
+            <a:ext cx="2926080" cy="457200"/>
+          </a:xfrm>
+          <a:prstGeom prst="rect">
+            <a:avLst/>
+          </a:prstGeom>
+          <a:noFill/>
+        </p:spPr>
+        <p:txBody>
+          <a:bodyPr wrap="square" lIns="0" rIns="0" tIns="0" bIns="0" anchor="t">
+            <a:spAutoFit/>
+          </a:bodyPr>
+          <a:lstStyle/>
+          <a:p>
+            <a:pPr algn="l"/>
+            <a:r>
+              <a:rPr sz="2100" b="1" i="0">
+                <a:solidFill>
+                  <a:srgbClr val="1F6F5C"/>
+                </a:solidFill>
+                <a:latin typeface="Cambria"/>
+              </a:rPr>
+              <a:t>Кому и за сколько</a:t>
+            </a:r>
+          </a:p>
+        </p:txBody>
+      </p:sp>
+      <p:sp>
+        <p:nvSpPr>
+          <p:cNvPr id="9" name="TextBox 8"/>
+          <p:cNvSpPr txBox="1"/>
+          <p:nvPr/>
+        </p:nvSpPr>
+        <p:spPr>
+          <a:xfrm>
+            <a:off x="4663440" y="2743200"/>
+            <a:ext cx="2971800" cy="3200400"/>
+          </a:xfrm>
+          <a:prstGeom prst="rect">
+            <a:avLst/>
+          </a:prstGeom>
+          <a:noFill/>
+        </p:spPr>
+        <p:txBody>
+          <a:bodyPr wrap="square" lIns="0" rIns="0" tIns="0" bIns="0" anchor="t">
+            <a:spAutoFit/>
+          </a:bodyPr>
+          <a:lstStyle/>
+          <a:p>
+            <a:pPr algn="l" marL="201168" indent="-201168">
+              <a:spcAft>
+                <a:spcPts val="1000"/>
+              </a:spcAft>
+              <a:buChar char="•"/>
+            </a:pPr>
+            <a:r>
+              <a:rPr sz="1500" b="0" i="0">
+                <a:solidFill>
+                  <a:srgbClr val="1D1F1C"/>
+                </a:solidFill>
+                <a:latin typeface="Calibri"/>
+              </a:rPr>
+              <a:t>Ученикам: бесплатная диагностика, платные банки (геометрия, мат. грамотность)</a:t>
+            </a:r>
+          </a:p>
+          <a:p>
+            <a:pPr algn="l" marL="201168" indent="-201168">
+              <a:spcAft>
+                <a:spcPts val="1000"/>
+              </a:spcAft>
+              <a:buChar char="•"/>
+            </a:pPr>
+            <a:r>
+              <a:rPr sz="1500" b="0" i="0">
+                <a:solidFill>
+                  <a:srgbClr val="1D1F1C"/>
+                </a:solidFill>
+                <a:latin typeface="Calibri"/>
+              </a:rPr>
+              <a:t>Школам: панель учителя, подписка за класс</a:t>
+            </a:r>
+          </a:p>
+          <a:p>
+            <a:pPr algn="l" marL="201168" indent="-201168">
+              <a:spcAft>
+                <a:spcPts val="1000"/>
+              </a:spcAft>
+              <a:buChar char="•"/>
+            </a:pPr>
+            <a:r>
+              <a:rPr sz="1500" b="0" i="0">
+                <a:solidFill>
+                  <a:srgbClr val="1D1F1C"/>
+                </a:solidFill>
+                <a:latin typeface="Calibri"/>
+              </a:rPr>
+              <a:t>Учебным центрам: входная диагностика новых учеников</a:t>
+            </a:r>
+          </a:p>
+        </p:txBody>
+      </p:sp>
+      <p:sp>
+        <p:nvSpPr>
+          <p:cNvPr id="10" name="Rounded Rectangle 9"/>
+          <p:cNvSpPr/>
+          <p:nvPr/>
+        </p:nvSpPr>
+        <p:spPr>
+          <a:xfrm>
+            <a:off x="8138159" y="1920240"/>
+            <a:ext cx="3474720" cy="4114800"/>
+          </a:xfrm>
+          <a:prstGeom prst="roundRect">
+            <a:avLst>
+              <a:gd name="adj" fmla="val 5000"/>
+            </a:avLst>
+          </a:prstGeom>
+          <a:solidFill>
+            <a:srgbClr val="F3F5F2"/>
+          </a:solidFill>
+          <a:ln>
+            <a:noFill/>
+          </a:ln>
+          <a:effectLst/>
+        </p:spPr>
+        <p:style>
+          <a:lnRef idx="1">
+            <a:schemeClr val="accent1"/>
+          </a:lnRef>
+          <a:fillRef idx="3">
+            <a:schemeClr val="accent1"/>
+          </a:fillRef>
+          <a:effectRef idx="2">
+            <a:schemeClr val="accent1"/>
+          </a:effectRef>
+          <a:fontRef idx="minor">
+            <a:schemeClr val="lt1"/>
+          </a:fontRef>
+        </p:style>
+        <p:txBody>
+          <a:bodyPr rtlCol="0" anchor="ctr" lIns="109728" rIns="109728"/>
+          <a:lstStyle/>
+          <a:p>
+            <a:pPr algn="ctr"/>
+          </a:p>
+        </p:txBody>
+      </p:sp>
+      <p:sp>
+        <p:nvSpPr>
+          <p:cNvPr id="11" name="TextBox 10"/>
+          <p:cNvSpPr txBox="1"/>
+          <p:nvPr/>
+        </p:nvSpPr>
+        <p:spPr>
+          <a:xfrm>
+            <a:off x="8412480" y="2148840"/>
+            <a:ext cx="2926080" cy="457200"/>
+          </a:xfrm>
+          <a:prstGeom prst="rect">
+            <a:avLst/>
+          </a:prstGeom>
+          <a:noFill/>
+        </p:spPr>
+        <p:txBody>
+          <a:bodyPr wrap="square" lIns="0" rIns="0" tIns="0" bIns="0" anchor="t">
+            <a:spAutoFit/>
+          </a:bodyPr>
+          <a:lstStyle/>
+          <a:p>
+            <a:pPr algn="l"/>
+            <a:r>
+              <a:rPr sz="2100" b="1" i="0">
+                <a:solidFill>
+                  <a:srgbClr val="1F6F5C"/>
+                </a:solidFill>
+                <a:latin typeface="Cambria"/>
+              </a:rPr>
+              <a:t>Для запуска</a:t>
+            </a:r>
+          </a:p>
+        </p:txBody>
+      </p:sp>
+      <p:sp>
+        <p:nvSpPr>
+          <p:cNvPr id="12" name="TextBox 11"/>
+          <p:cNvSpPr txBox="1"/>
+          <p:nvPr/>
+        </p:nvSpPr>
+        <p:spPr>
+          <a:xfrm>
+            <a:off x="8412480" y="2743200"/>
+            <a:ext cx="2971800" cy="3200400"/>
+          </a:xfrm>
+          <a:prstGeom prst="rect">
+            <a:avLst/>
+          </a:prstGeom>
+          <a:noFill/>
+        </p:spPr>
+        <p:txBody>
+          <a:bodyPr wrap="square" lIns="0" rIns="0" tIns="0" bIns="0" anchor="t">
+            <a:spAutoFit/>
+          </a:bodyPr>
+          <a:lstStyle/>
+          <a:p>
+            <a:pPr algn="l" marL="201168" indent="-201168">
+              <a:spcAft>
+                <a:spcPts val="1000"/>
+              </a:spcAft>
+              <a:buChar char="•"/>
+            </a:pPr>
+            <a:r>
+              <a:rPr sz="1500" b="0" i="0">
+                <a:solidFill>
+                  <a:srgbClr val="1D1F1C"/>
+                </a:solidFill>
+                <a:latin typeface="Calibri"/>
+              </a:rPr>
+              <a:t>Проверка графа 2–3 учителями</a:t>
+            </a:r>
+          </a:p>
+          <a:p>
+            <a:pPr algn="l" marL="201168" indent="-201168">
+              <a:spcAft>
+                <a:spcPts val="1000"/>
+              </a:spcAft>
+              <a:buChar char="•"/>
+            </a:pPr>
+            <a:r>
+              <a:rPr sz="1500" b="0" i="0">
+                <a:solidFill>
+                  <a:srgbClr val="1D1F1C"/>
+                </a:solidFill>
+                <a:latin typeface="Calibri"/>
+              </a:rPr>
+              <a:t>Банк 10+ вопросов на тему</a:t>
+            </a:r>
+          </a:p>
+          <a:p>
+            <a:pPr algn="l" marL="201168" indent="-201168">
+              <a:spcAft>
+                <a:spcPts val="1000"/>
+              </a:spcAft>
+              <a:buChar char="•"/>
+            </a:pPr>
+            <a:r>
+              <a:rPr sz="1500" b="0" i="0">
+                <a:solidFill>
+                  <a:srgbClr val="1D1F1C"/>
+                </a:solidFill>
+                <a:latin typeface="Calibri"/>
+              </a:rPr>
+              <a:t>Казахская версия</a:t>
+            </a:r>
+          </a:p>
+          <a:p>
+            <a:pPr algn="l" marL="201168" indent="-201168">
+              <a:spcAft>
+                <a:spcPts val="1000"/>
+              </a:spcAft>
+              <a:buChar char="•"/>
+            </a:pPr>
+            <a:r>
+              <a:rPr sz="1500" b="0" i="0">
+                <a:solidFill>
+                  <a:srgbClr val="1D1F1C"/>
+                </a:solidFill>
+                <a:latin typeface="Calibri"/>
+              </a:rPr>
+              <a:t>Пилот в 2–3 классах</a:t>
+            </a:r>
+          </a:p>
+        </p:txBody>
+      </p:sp>
+    </p:spTree>
+  </p:cSld>
+  <p:clrMapOvr>
+    <a:masterClrMapping/>
+  </p:clrMapOvr>
+</p:sld>
+</file>
+
+<file path=ppt/slides/slide11.xml><?xml version="1.0" encoding="utf-8"?>
+<p:sld xmlns:a="http://schemas.openxmlformats.org/drawingml/2006/main" xmlns:p="http://schemas.openxmlformats.org/presentationml/2006/main" xmlns:r="http://schemas.openxmlformats.org/officeDocument/2006/relationships">
+  <p:cSld>
+    <p:bg>
+      <p:bgPr>
+        <a:solidFill>
           <a:srgbClr val="142B25"/>
         </a:solidFill>
         <a:effectLst/>
@@ -4658,7 +5324,7 @@
                 </a:solidFill>
                 <a:latin typeface="Calibri"/>
               </a:rPr>
-              <a:t>MVP: 17 тем, 52 задания, 43 ошибки мышления, панель учителя</a:t>
+              <a:t>MVP: 17 тем, 102 задания, 43 ошибки мышления, панель учителя</a:t>
             </a:r>
           </a:p>
         </p:txBody>
@@ -4956,7 +5622,7 @@
                 </a:solidFill>
                 <a:latin typeface="Calibri"/>
               </a:rPr>
-              <a:t>Байесовская модель освоения, 5–6 вопросов на тему</a:t>
+              <a:t>Байесовская модель освоения, 10+ вопросов на тему</a:t>
             </a:r>
           </a:p>
         </p:txBody>
@@ -5271,11 +5937,20 @@
             <a:r>
               <a:rPr sz="1800" b="1" i="0">
                 <a:solidFill>
+                  <a:srgbClr val="1F6F5C"/>
+                </a:solidFill>
+                <a:latin typeface="Calibri"/>
+              </a:rPr>
+              <a:t>Пример: </a:t>
+            </a:r>
+            <a:r>
+              <a:rPr sz="1800" b="1" i="0">
+                <a:solidFill>
                   <a:srgbClr val="1D1F1C"/>
                 </a:solidFill>
                 <a:latin typeface="Calibri"/>
               </a:rPr>
-              <a:t>Айгерим готовится к ЕНТ и ошибается в квадратных уравнениях.</a:t>
+              <a:t>ученица готовится к ЕНТ и ошибается в квадратных уравнениях.</a:t>
             </a:r>
           </a:p>
           <a:p>
@@ -5954,7 +6629,7 @@
                 </a:solidFill>
                 <a:latin typeface="Calibri"/>
               </a:rPr>
-              <a:t>Каждая тема держится на предыдущих. Пробел 5–6 класса всплывает через 2–4 года в другой теме.</a:t>
+              <a:t>Каждая тема держится на предыдущих. Пробел в базовой теме всплывает позже — в теме, которая на ней держится.</a:t>
             </a:r>
           </a:p>
         </p:txBody>
@@ -6591,7 +7266,7 @@
                 </a:solidFill>
                 <a:latin typeface="Calibri"/>
               </a:rPr>
-              <a:t>Начинаем со сложной темы. При ошибке спускаемся по графу из 17 тем. Примерно вдвое меньше вопросов, чем в полном тесте.</a:t>
+              <a:t>Начинаем со сложной темы и спускаемся по графу из 17 тем только там, где есть ошибки. Без пробелов — около 9 вопросов.</a:t>
             </a:r>
           </a:p>
         </p:txBody>
@@ -9247,7 +9922,7 @@
     <p:bg>
       <p:bgPr>
         <a:solidFill>
-          <a:srgbClr val="142B25"/>
+          <a:srgbClr val="FFFFFF"/>
         </a:solidFill>
         <a:effectLst/>
       </p:bgPr>
@@ -9285,11 +9960,11 @@
             <a:r>
               <a:rPr sz="1200" b="1" i="0">
                 <a:solidFill>
-                  <a:srgbClr val="9FD9C4"/>
-                </a:solidFill>
-                <a:latin typeface="Calibri"/>
-              </a:rPr>
-              <a:t>ВАЛИДАЦИЯ</a:t>
+                  <a:srgbClr val="1F6F5C"/>
+                </a:solidFill>
+                <a:latin typeface="Calibri"/>
+              </a:rPr>
+              <a:t>ПОХОЖИЕ РЕШЕНИЯ</a:t>
             </a:r>
           </a:p>
         </p:txBody>
@@ -9320,11 +9995,11 @@
             <a:r>
               <a:rPr sz="3600" b="1" i="0">
                 <a:solidFill>
-                  <a:srgbClr val="FFFFFF"/>
+                  <a:srgbClr val="1D1F1C"/>
                 </a:solidFill>
                 <a:latin typeface="Cambria"/>
               </a:rPr>
-              <a:t>Что уже проверено</a:t>
+              <a:t>Идея не новая — новое в связке и в месте</a:t>
             </a:r>
           </a:p>
         </p:txBody>
@@ -9337,8 +10012,8 @@
         </p:nvSpPr>
         <p:spPr>
           <a:xfrm>
-            <a:off x="640080" y="1965960"/>
-            <a:ext cx="2651760" cy="914400"/>
+            <a:off x="2926080" y="1783080"/>
+            <a:ext cx="3931920" cy="320040"/>
           </a:xfrm>
           <a:prstGeom prst="rect">
             <a:avLst/>
@@ -9353,13 +10028,13 @@
           <a:p>
             <a:pPr algn="l"/>
             <a:r>
-              <a:rPr sz="4800" b="1" i="0">
-                <a:solidFill>
-                  <a:srgbClr val="9FD9C4"/>
-                </a:solidFill>
-                <a:latin typeface="Cambria"/>
-              </a:rPr>
-              <a:t>81%</a:t>
+              <a:rPr sz="1100" b="1" i="0">
+                <a:solidFill>
+                  <a:srgbClr val="5B5F58"/>
+                </a:solidFill>
+                <a:latin typeface="Calibri"/>
+              </a:rPr>
+              <a:t>ЧТО ДЕЛАЕТ</a:t>
             </a:r>
           </a:p>
         </p:txBody>
@@ -9372,8 +10047,8 @@
         </p:nvSpPr>
         <p:spPr>
           <a:xfrm>
-            <a:off x="640080" y="2926080"/>
-            <a:ext cx="2651760" cy="822960"/>
+            <a:off x="7223760" y="1783080"/>
+            <a:ext cx="4297680" cy="320040"/>
           </a:xfrm>
           <a:prstGeom prst="rect">
             <a:avLst/>
@@ -9388,290 +10063,38 @@
           <a:p>
             <a:pPr algn="l"/>
             <a:r>
-              <a:rPr sz="1500" b="0" i="0">
-                <a:solidFill>
-                  <a:srgbClr val="D8E6E0"/>
-                </a:solidFill>
-                <a:latin typeface="Calibri"/>
-              </a:rPr>
-              <a:t>настоящих корней
-найдено (полнота)</a:t>
-            </a:r>
-          </a:p>
-        </p:txBody>
-      </p:sp>
-      <p:sp>
-        <p:nvSpPr>
-          <p:cNvPr id="6" name="TextBox 5"/>
-          <p:cNvSpPr txBox="1"/>
-          <p:nvPr/>
-        </p:nvSpPr>
-        <p:spPr>
-          <a:xfrm>
-            <a:off x="3474720" y="1965960"/>
-            <a:ext cx="2651760" cy="914400"/>
-          </a:xfrm>
-          <a:prstGeom prst="rect">
-            <a:avLst/>
-          </a:prstGeom>
-          <a:noFill/>
-        </p:spPr>
-        <p:txBody>
-          <a:bodyPr wrap="square" lIns="0" rIns="0" tIns="0" bIns="0" anchor="t">
-            <a:spAutoFit/>
-          </a:bodyPr>
-          <a:lstStyle/>
-          <a:p>
-            <a:pPr algn="l"/>
-            <a:r>
-              <a:rPr sz="4800" b="1" i="0">
-                <a:solidFill>
-                  <a:srgbClr val="9FD9C4"/>
-                </a:solidFill>
-                <a:latin typeface="Cambria"/>
-              </a:rPr>
-              <a:t>75%</a:t>
-            </a:r>
-          </a:p>
-        </p:txBody>
-      </p:sp>
-      <p:sp>
-        <p:nvSpPr>
-          <p:cNvPr id="7" name="TextBox 6"/>
-          <p:cNvSpPr txBox="1"/>
-          <p:nvPr/>
-        </p:nvSpPr>
-        <p:spPr>
-          <a:xfrm>
-            <a:off x="3474720" y="2926080"/>
-            <a:ext cx="2651760" cy="822960"/>
-          </a:xfrm>
-          <a:prstGeom prst="rect">
-            <a:avLst/>
-          </a:prstGeom>
-          <a:noFill/>
-        </p:spPr>
-        <p:txBody>
-          <a:bodyPr wrap="square" lIns="0" rIns="0" tIns="0" bIns="0" anchor="t">
-            <a:spAutoFit/>
-          </a:bodyPr>
-          <a:lstStyle/>
-          <a:p>
-            <a:pPr algn="l"/>
-            <a:r>
-              <a:rPr sz="1500" b="0" i="0">
-                <a:solidFill>
-                  <a:srgbClr val="D8E6E0"/>
-                </a:solidFill>
-                <a:latin typeface="Calibri"/>
-              </a:rPr>
-              <a:t>найденных корней
-верны (точность)</a:t>
-            </a:r>
-          </a:p>
-        </p:txBody>
-      </p:sp>
-      <p:sp>
-        <p:nvSpPr>
-          <p:cNvPr id="8" name="TextBox 7"/>
-          <p:cNvSpPr txBox="1"/>
-          <p:nvPr/>
-        </p:nvSpPr>
-        <p:spPr>
-          <a:xfrm>
-            <a:off x="6309360" y="1965960"/>
-            <a:ext cx="2651760" cy="914400"/>
-          </a:xfrm>
-          <a:prstGeom prst="rect">
-            <a:avLst/>
-          </a:prstGeom>
-          <a:noFill/>
-        </p:spPr>
-        <p:txBody>
-          <a:bodyPr wrap="square" lIns="0" rIns="0" tIns="0" bIns="0" anchor="t">
-            <a:spAutoFit/>
-          </a:bodyPr>
-          <a:lstStyle/>
-          <a:p>
-            <a:pPr algn="l"/>
-            <a:r>
-              <a:rPr sz="4800" b="1" i="0">
-                <a:solidFill>
-                  <a:srgbClr val="9FD9C4"/>
-                </a:solidFill>
-                <a:latin typeface="Cambria"/>
-              </a:rPr>
-              <a:t>25 / 51</a:t>
-            </a:r>
-          </a:p>
-        </p:txBody>
-      </p:sp>
-      <p:sp>
-        <p:nvSpPr>
-          <p:cNvPr id="9" name="TextBox 8"/>
-          <p:cNvSpPr txBox="1"/>
-          <p:nvPr/>
-        </p:nvSpPr>
-        <p:spPr>
-          <a:xfrm>
-            <a:off x="6309360" y="2926080"/>
-            <a:ext cx="2651760" cy="822960"/>
-          </a:xfrm>
-          <a:prstGeom prst="rect">
-            <a:avLst/>
-          </a:prstGeom>
-          <a:noFill/>
-        </p:spPr>
-        <p:txBody>
-          <a:bodyPr wrap="square" lIns="0" rIns="0" tIns="0" bIns="0" anchor="t">
-            <a:spAutoFit/>
-          </a:bodyPr>
-          <a:lstStyle/>
-          <a:p>
-            <a:pPr algn="l"/>
-            <a:r>
-              <a:rPr sz="1500" b="0" i="0">
-                <a:solidFill>
-                  <a:srgbClr val="D8E6E0"/>
-                </a:solidFill>
-                <a:latin typeface="Calibri"/>
-              </a:rPr>
-              <a:t>вопросов в среднем
-вместо полного теста</a:t>
-            </a:r>
-          </a:p>
-        </p:txBody>
-      </p:sp>
-      <p:sp>
-        <p:nvSpPr>
-          <p:cNvPr id="10" name="TextBox 9"/>
-          <p:cNvSpPr txBox="1"/>
-          <p:nvPr/>
-        </p:nvSpPr>
-        <p:spPr>
-          <a:xfrm>
-            <a:off x="9144000" y="1965960"/>
-            <a:ext cx="2651760" cy="914400"/>
-          </a:xfrm>
-          <a:prstGeom prst="rect">
-            <a:avLst/>
-          </a:prstGeom>
-          <a:noFill/>
-        </p:spPr>
-        <p:txBody>
-          <a:bodyPr wrap="square" lIns="0" rIns="0" tIns="0" bIns="0" anchor="t">
-            <a:spAutoFit/>
-          </a:bodyPr>
-          <a:lstStyle/>
-          <a:p>
-            <a:pPr algn="l"/>
-            <a:r>
-              <a:rPr sz="4800" b="1" i="0">
-                <a:solidFill>
-                  <a:srgbClr val="9FD9C4"/>
-                </a:solidFill>
-                <a:latin typeface="Cambria"/>
-              </a:rPr>
-              <a:t>13 / 13</a:t>
-            </a:r>
-          </a:p>
-        </p:txBody>
-      </p:sp>
-      <p:sp>
-        <p:nvSpPr>
-          <p:cNvPr id="11" name="TextBox 10"/>
-          <p:cNvSpPr txBox="1"/>
-          <p:nvPr/>
-        </p:nvSpPr>
-        <p:spPr>
-          <a:xfrm>
-            <a:off x="9144000" y="2926080"/>
-            <a:ext cx="2651760" cy="822960"/>
-          </a:xfrm>
-          <a:prstGeom prst="rect">
-            <a:avLst/>
-          </a:prstGeom>
-          <a:noFill/>
-        </p:spPr>
-        <p:txBody>
-          <a:bodyPr wrap="square" lIns="0" rIns="0" tIns="0" bIns="0" anchor="t">
-            <a:spAutoFit/>
-          </a:bodyPr>
-          <a:lstStyle/>
-          <a:p>
-            <a:pPr algn="l"/>
-            <a:r>
-              <a:rPr sz="1500" b="0" i="0">
-                <a:solidFill>
-                  <a:srgbClr val="D8E6E0"/>
-                </a:solidFill>
-                <a:latin typeface="Calibri"/>
-              </a:rPr>
-              <a:t>юнит-тестов
-движка проходят</a:t>
-            </a:r>
-          </a:p>
-        </p:txBody>
-      </p:sp>
-      <p:sp>
-        <p:nvSpPr>
-          <p:cNvPr id="12" name="TextBox 11"/>
-          <p:cNvSpPr txBox="1"/>
-          <p:nvPr/>
-        </p:nvSpPr>
-        <p:spPr>
-          <a:xfrm>
-            <a:off x="640080" y="3977639"/>
-            <a:ext cx="10881360" cy="640080"/>
-          </a:xfrm>
-          <a:prstGeom prst="rect">
-            <a:avLst/>
-          </a:prstGeom>
-          <a:noFill/>
-        </p:spPr>
-        <p:txBody>
-          <a:bodyPr wrap="square" lIns="0" rIns="0" tIns="0" bIns="0" anchor="t">
-            <a:spAutoFit/>
-          </a:bodyPr>
-          <a:lstStyle/>
-          <a:p>
-            <a:pPr algn="l"/>
-            <a:r>
-              <a:rPr sz="1400" b="0" i="0">
-                <a:solidFill>
-                  <a:srgbClr val="B5CCC3"/>
-                </a:solidFill>
-                <a:latin typeface="Calibri"/>
-              </a:rPr>
-              <a:t>Симуляция 1000 учеников с известными пробелами: угадывание 20%, ошибки в знакомых темах 8%. Без шума алгоритм находит 100% корней. Точность ограничена угадыванием при 4 вариантах.</a:t>
-            </a:r>
-          </a:p>
-        </p:txBody>
-      </p:sp>
-      <p:sp>
-        <p:nvSpPr>
-          <p:cNvPr id="13" name="Rounded Rectangle 12"/>
+              <a:rPr sz="1100" b="1" i="0">
+                <a:solidFill>
+                  <a:srgbClr val="1F6F5C"/>
+                </a:solidFill>
+                <a:latin typeface="Calibri"/>
+              </a:rPr>
+              <a:t>ЧЕМ ОТЛИЧАЕТСЯ TAMYR</a:t>
+            </a:r>
+          </a:p>
+        </p:txBody>
+      </p:sp>
+      <p:sp>
+        <p:nvSpPr>
+          <p:cNvPr id="6" name="Rounded Rectangle 5"/>
           <p:cNvSpPr/>
           <p:nvPr/>
         </p:nvSpPr>
         <p:spPr>
           <a:xfrm>
-            <a:off x="640080" y="4846320"/>
-            <a:ext cx="10881360" cy="1371600"/>
+            <a:off x="640080" y="2148840"/>
+            <a:ext cx="10881360" cy="786384"/>
           </a:xfrm>
           <a:prstGeom prst="roundRect">
             <a:avLst>
-              <a:gd name="adj" fmla="val 12000"/>
+              <a:gd name="adj" fmla="val 10000"/>
             </a:avLst>
           </a:prstGeom>
           <a:solidFill>
-            <a:srgbClr val="1F3D35"/>
+            <a:srgbClr val="F3F5F2"/>
           </a:solidFill>
-          <a:ln w="25400">
-            <a:solidFill>
-              <a:srgbClr val="9FD9C4"/>
-            </a:solidFill>
-            <a:prstDash val="dash"/>
+          <a:ln>
+            <a:noFill/>
           </a:ln>
           <a:effectLst/>
         </p:spPr>
@@ -9699,14 +10122,14 @@
       </p:sp>
       <p:sp>
         <p:nvSpPr>
-          <p:cNvPr id="14" name="TextBox 13"/>
+          <p:cNvPr id="7" name="TextBox 6"/>
           <p:cNvSpPr txBox="1"/>
           <p:nvPr/>
         </p:nvSpPr>
         <p:spPr>
           <a:xfrm>
-            <a:off x="914400" y="4983480"/>
-            <a:ext cx="10332720" cy="1143000"/>
+            <a:off x="868680" y="2267712"/>
+            <a:ext cx="1920240" cy="320040"/>
           </a:xfrm>
           <a:prstGeom prst="rect">
             <a:avLst/>
@@ -9719,35 +10142,722 @@
           </a:bodyPr>
           <a:lstStyle/>
           <a:p>
-            <a:pPr algn="l">
-              <a:spcAft>
-                <a:spcPts val="600"/>
-              </a:spcAft>
-            </a:pPr>
+            <a:pPr algn="l"/>
+            <a:r>
+              <a:rPr sz="1700" b="1" i="0">
+                <a:solidFill>
+                  <a:srgbClr val="1D1F1C"/>
+                </a:solidFill>
+                <a:latin typeface="Cambria"/>
+              </a:rPr>
+              <a:t>ALEKS</a:t>
+            </a:r>
+          </a:p>
+        </p:txBody>
+      </p:sp>
+      <p:sp>
+        <p:nvSpPr>
+          <p:cNvPr id="8" name="TextBox 7"/>
+          <p:cNvSpPr txBox="1"/>
+          <p:nvPr/>
+        </p:nvSpPr>
+        <p:spPr>
+          <a:xfrm>
+            <a:off x="868680" y="2606040"/>
+            <a:ext cx="1920240" cy="274320"/>
+          </a:xfrm>
+          <a:prstGeom prst="rect">
+            <a:avLst/>
+          </a:prstGeom>
+          <a:noFill/>
+        </p:spPr>
+        <p:txBody>
+          <a:bodyPr wrap="square" lIns="0" rIns="0" tIns="0" bIns="0" anchor="t">
+            <a:spAutoFit/>
+          </a:bodyPr>
+          <a:lstStyle/>
+          <a:p>
+            <a:pPr algn="l"/>
+            <a:r>
+              <a:rPr sz="1100" b="0" i="0">
+                <a:solidFill>
+                  <a:srgbClr val="5B5F58"/>
+                </a:solidFill>
+                <a:latin typeface="Calibri"/>
+              </a:rPr>
+              <a:t>McGraw Hill</a:t>
+            </a:r>
+          </a:p>
+        </p:txBody>
+      </p:sp>
+      <p:sp>
+        <p:nvSpPr>
+          <p:cNvPr id="9" name="TextBox 8"/>
+          <p:cNvSpPr txBox="1"/>
+          <p:nvPr/>
+        </p:nvSpPr>
+        <p:spPr>
+          <a:xfrm>
+            <a:off x="2926080" y="2240280"/>
+            <a:ext cx="4023360" cy="603504"/>
+          </a:xfrm>
+          <a:prstGeom prst="rect">
+            <a:avLst/>
+          </a:prstGeom>
+          <a:noFill/>
+        </p:spPr>
+        <p:txBody>
+          <a:bodyPr wrap="square" lIns="0" rIns="0" tIns="0" bIns="0" anchor="ctr">
+            <a:spAutoFit/>
+          </a:bodyPr>
+          <a:lstStyle/>
+          <a:p>
+            <a:pPr algn="l"/>
+            <a:r>
+              <a:rPr sz="1300" b="0" i="0">
+                <a:solidFill>
+                  <a:srgbClr val="1D1F1C"/>
+                </a:solidFill>
+                <a:latin typeface="Calibri"/>
+              </a:rPr>
+              <a:t>Адаптивная оценка по «пространству знаний». Платная, программы США.</a:t>
+            </a:r>
+          </a:p>
+        </p:txBody>
+      </p:sp>
+      <p:sp>
+        <p:nvSpPr>
+          <p:cNvPr id="10" name="TextBox 9"/>
+          <p:cNvSpPr txBox="1"/>
+          <p:nvPr/>
+        </p:nvSpPr>
+        <p:spPr>
+          <a:xfrm>
+            <a:off x="7223760" y="2240280"/>
+            <a:ext cx="4114800" cy="603504"/>
+          </a:xfrm>
+          <a:prstGeom prst="rect">
+            <a:avLst/>
+          </a:prstGeom>
+          <a:noFill/>
+        </p:spPr>
+        <p:txBody>
+          <a:bodyPr wrap="square" lIns="0" rIns="0" tIns="0" bIns="0" anchor="ctr">
+            <a:spAutoFit/>
+          </a:bodyPr>
+          <a:lstStyle/>
+          <a:p>
+            <a:pPr algn="l"/>
+            <a:r>
+              <a:rPr sz="1300" b="1" i="0">
+                <a:solidFill>
+                  <a:srgbClr val="1F6F5C"/>
+                </a:solidFill>
+                <a:latin typeface="Calibri"/>
+              </a:rPr>
+              <a:t>Программа и формат ЕНТ, бесплатно для ученика, офлайн без регистрации</a:t>
+            </a:r>
+          </a:p>
+        </p:txBody>
+      </p:sp>
+      <p:sp>
+        <p:nvSpPr>
+          <p:cNvPr id="11" name="Rounded Rectangle 10"/>
+          <p:cNvSpPr/>
+          <p:nvPr/>
+        </p:nvSpPr>
+        <p:spPr>
+          <a:xfrm>
+            <a:off x="640080" y="3044952"/>
+            <a:ext cx="10881360" cy="786384"/>
+          </a:xfrm>
+          <a:prstGeom prst="roundRect">
+            <a:avLst>
+              <a:gd name="adj" fmla="val 10000"/>
+            </a:avLst>
+          </a:prstGeom>
+          <a:solidFill>
+            <a:srgbClr val="F3F5F2"/>
+          </a:solidFill>
+          <a:ln>
+            <a:noFill/>
+          </a:ln>
+          <a:effectLst/>
+        </p:spPr>
+        <p:style>
+          <a:lnRef idx="1">
+            <a:schemeClr val="accent1"/>
+          </a:lnRef>
+          <a:fillRef idx="3">
+            <a:schemeClr val="accent1"/>
+          </a:fillRef>
+          <a:effectRef idx="2">
+            <a:schemeClr val="accent1"/>
+          </a:effectRef>
+          <a:fontRef idx="minor">
+            <a:schemeClr val="lt1"/>
+          </a:fontRef>
+        </p:style>
+        <p:txBody>
+          <a:bodyPr rtlCol="0" anchor="ctr" lIns="109728" rIns="109728"/>
+          <a:lstStyle/>
+          <a:p>
+            <a:pPr algn="ctr"/>
+          </a:p>
+        </p:txBody>
+      </p:sp>
+      <p:sp>
+        <p:nvSpPr>
+          <p:cNvPr id="12" name="TextBox 11"/>
+          <p:cNvSpPr txBox="1"/>
+          <p:nvPr/>
+        </p:nvSpPr>
+        <p:spPr>
+          <a:xfrm>
+            <a:off x="868680" y="3163824"/>
+            <a:ext cx="1920240" cy="320040"/>
+          </a:xfrm>
+          <a:prstGeom prst="rect">
+            <a:avLst/>
+          </a:prstGeom>
+          <a:noFill/>
+        </p:spPr>
+        <p:txBody>
+          <a:bodyPr wrap="square" lIns="0" rIns="0" tIns="0" bIns="0" anchor="t">
+            <a:spAutoFit/>
+          </a:bodyPr>
+          <a:lstStyle/>
+          <a:p>
+            <a:pPr algn="l"/>
+            <a:r>
+              <a:rPr sz="1700" b="1" i="0">
+                <a:solidFill>
+                  <a:srgbClr val="1D1F1C"/>
+                </a:solidFill>
+                <a:latin typeface="Cambria"/>
+              </a:rPr>
+              <a:t>Eedi</a:t>
+            </a:r>
+          </a:p>
+        </p:txBody>
+      </p:sp>
+      <p:sp>
+        <p:nvSpPr>
+          <p:cNvPr id="13" name="TextBox 12"/>
+          <p:cNvSpPr txBox="1"/>
+          <p:nvPr/>
+        </p:nvSpPr>
+        <p:spPr>
+          <a:xfrm>
+            <a:off x="868680" y="3502152"/>
+            <a:ext cx="1920240" cy="274320"/>
+          </a:xfrm>
+          <a:prstGeom prst="rect">
+            <a:avLst/>
+          </a:prstGeom>
+          <a:noFill/>
+        </p:spPr>
+        <p:txBody>
+          <a:bodyPr wrap="square" lIns="0" rIns="0" tIns="0" bIns="0" anchor="t">
+            <a:spAutoFit/>
+          </a:bodyPr>
+          <a:lstStyle/>
+          <a:p>
+            <a:pPr algn="l"/>
+            <a:r>
+              <a:rPr sz="1100" b="0" i="0">
+                <a:solidFill>
+                  <a:srgbClr val="5B5F58"/>
+                </a:solidFill>
+                <a:latin typeface="Calibri"/>
+              </a:rPr>
+              <a:t>Великобритания</a:t>
+            </a:r>
+          </a:p>
+        </p:txBody>
+      </p:sp>
+      <p:sp>
+        <p:nvSpPr>
+          <p:cNvPr id="14" name="TextBox 13"/>
+          <p:cNvSpPr txBox="1"/>
+          <p:nvPr/>
+        </p:nvSpPr>
+        <p:spPr>
+          <a:xfrm>
+            <a:off x="2926080" y="3136392"/>
+            <a:ext cx="4023360" cy="603504"/>
+          </a:xfrm>
+          <a:prstGeom prst="rect">
+            <a:avLst/>
+          </a:prstGeom>
+          <a:noFill/>
+        </p:spPr>
+        <p:txBody>
+          <a:bodyPr wrap="square" lIns="0" rIns="0" tIns="0" bIns="0" anchor="ctr">
+            <a:spAutoFit/>
+          </a:bodyPr>
+          <a:lstStyle/>
+          <a:p>
+            <a:pPr algn="l"/>
+            <a:r>
+              <a:rPr sz="1300" b="0" i="0">
+                <a:solidFill>
+                  <a:srgbClr val="1D1F1C"/>
+                </a:solidFill>
+                <a:latin typeface="Calibri"/>
+              </a:rPr>
+              <a:t>Диагностические вопросы: неверный вариант указывает на ошибку мышления.</a:t>
+            </a:r>
+          </a:p>
+        </p:txBody>
+      </p:sp>
+      <p:sp>
+        <p:nvSpPr>
+          <p:cNvPr id="15" name="TextBox 14"/>
+          <p:cNvSpPr txBox="1"/>
+          <p:nvPr/>
+        </p:nvSpPr>
+        <p:spPr>
+          <a:xfrm>
+            <a:off x="7223760" y="3136392"/>
+            <a:ext cx="4114800" cy="603504"/>
+          </a:xfrm>
+          <a:prstGeom prst="rect">
+            <a:avLst/>
+          </a:prstGeom>
+          <a:noFill/>
+        </p:spPr>
+        <p:txBody>
+          <a:bodyPr wrap="square" lIns="0" rIns="0" tIns="0" bIns="0" anchor="ctr">
+            <a:spAutoFit/>
+          </a:bodyPr>
+          <a:lstStyle/>
+          <a:p>
+            <a:pPr algn="l"/>
+            <a:r>
+              <a:rPr sz="1300" b="1" i="0">
+                <a:solidFill>
+                  <a:srgbClr val="1F6F5C"/>
+                </a:solidFill>
+                <a:latin typeface="Calibri"/>
+              </a:rPr>
+              <a:t>Метка ошибки сразу ведёт в её домашнюю тему и дальше вниз, к корню</a:t>
+            </a:r>
+          </a:p>
+        </p:txBody>
+      </p:sp>
+      <p:sp>
+        <p:nvSpPr>
+          <p:cNvPr id="16" name="Rounded Rectangle 15"/>
+          <p:cNvSpPr/>
+          <p:nvPr/>
+        </p:nvSpPr>
+        <p:spPr>
+          <a:xfrm>
+            <a:off x="640080" y="3941064"/>
+            <a:ext cx="10881360" cy="786384"/>
+          </a:xfrm>
+          <a:prstGeom prst="roundRect">
+            <a:avLst>
+              <a:gd name="adj" fmla="val 10000"/>
+            </a:avLst>
+          </a:prstGeom>
+          <a:solidFill>
+            <a:srgbClr val="F3F5F2"/>
+          </a:solidFill>
+          <a:ln>
+            <a:noFill/>
+          </a:ln>
+          <a:effectLst/>
+        </p:spPr>
+        <p:style>
+          <a:lnRef idx="1">
+            <a:schemeClr val="accent1"/>
+          </a:lnRef>
+          <a:fillRef idx="3">
+            <a:schemeClr val="accent1"/>
+          </a:fillRef>
+          <a:effectRef idx="2">
+            <a:schemeClr val="accent1"/>
+          </a:effectRef>
+          <a:fontRef idx="minor">
+            <a:schemeClr val="lt1"/>
+          </a:fontRef>
+        </p:style>
+        <p:txBody>
+          <a:bodyPr rtlCol="0" anchor="ctr" lIns="109728" rIns="109728"/>
+          <a:lstStyle/>
+          <a:p>
+            <a:pPr algn="ctr"/>
+          </a:p>
+        </p:txBody>
+      </p:sp>
+      <p:sp>
+        <p:nvSpPr>
+          <p:cNvPr id="17" name="TextBox 16"/>
+          <p:cNvSpPr txBox="1"/>
+          <p:nvPr/>
+        </p:nvSpPr>
+        <p:spPr>
+          <a:xfrm>
+            <a:off x="868680" y="4059936"/>
+            <a:ext cx="1920240" cy="320040"/>
+          </a:xfrm>
+          <a:prstGeom prst="rect">
+            <a:avLst/>
+          </a:prstGeom>
+          <a:noFill/>
+        </p:spPr>
+        <p:txBody>
+          <a:bodyPr wrap="square" lIns="0" rIns="0" tIns="0" bIns="0" anchor="t">
+            <a:spAutoFit/>
+          </a:bodyPr>
+          <a:lstStyle/>
+          <a:p>
+            <a:pPr algn="l"/>
+            <a:r>
+              <a:rPr sz="1700" b="1" i="0">
+                <a:solidFill>
+                  <a:srgbClr val="1D1F1C"/>
+                </a:solidFill>
+                <a:latin typeface="Cambria"/>
+              </a:rPr>
+              <a:t>Khan Academy</a:t>
+            </a:r>
+          </a:p>
+        </p:txBody>
+      </p:sp>
+      <p:sp>
+        <p:nvSpPr>
+          <p:cNvPr id="18" name="TextBox 17"/>
+          <p:cNvSpPr txBox="1"/>
+          <p:nvPr/>
+        </p:nvSpPr>
+        <p:spPr>
+          <a:xfrm>
+            <a:off x="868680" y="4398264"/>
+            <a:ext cx="1920240" cy="274320"/>
+          </a:xfrm>
+          <a:prstGeom prst="rect">
+            <a:avLst/>
+          </a:prstGeom>
+          <a:noFill/>
+        </p:spPr>
+        <p:txBody>
+          <a:bodyPr wrap="square" lIns="0" rIns="0" tIns="0" bIns="0" anchor="t">
+            <a:spAutoFit/>
+          </a:bodyPr>
+          <a:lstStyle/>
+          <a:p>
+            <a:pPr algn="l"/>
+            <a:r>
+              <a:rPr sz="1100" b="0" i="0">
+                <a:solidFill>
+                  <a:srgbClr val="5B5F58"/>
+                </a:solidFill>
+                <a:latin typeface="Calibri"/>
+              </a:rPr>
+              <a:t>США</a:t>
+            </a:r>
+          </a:p>
+        </p:txBody>
+      </p:sp>
+      <p:sp>
+        <p:nvSpPr>
+          <p:cNvPr id="19" name="TextBox 18"/>
+          <p:cNvSpPr txBox="1"/>
+          <p:nvPr/>
+        </p:nvSpPr>
+        <p:spPr>
+          <a:xfrm>
+            <a:off x="2926080" y="4032504"/>
+            <a:ext cx="4023360" cy="603504"/>
+          </a:xfrm>
+          <a:prstGeom prst="rect">
+            <a:avLst/>
+          </a:prstGeom>
+          <a:noFill/>
+        </p:spPr>
+        <p:txBody>
+          <a:bodyPr wrap="square" lIns="0" rIns="0" tIns="0" bIns="0" anchor="ctr">
+            <a:spAutoFit/>
+          </a:bodyPr>
+          <a:lstStyle/>
+          <a:p>
+            <a:pPr algn="l"/>
+            <a:r>
+              <a:rPr sz="1300" b="0" i="0">
+                <a:solidFill>
+                  <a:srgbClr val="1D1F1C"/>
+                </a:solidFill>
+                <a:latin typeface="Calibri"/>
+              </a:rPr>
+              <a:t>Бесплатные курсы и система освоения по темам.</a:t>
+            </a:r>
+          </a:p>
+        </p:txBody>
+      </p:sp>
+      <p:sp>
+        <p:nvSpPr>
+          <p:cNvPr id="20" name="TextBox 19"/>
+          <p:cNvSpPr txBox="1"/>
+          <p:nvPr/>
+        </p:nvSpPr>
+        <p:spPr>
+          <a:xfrm>
+            <a:off x="7223760" y="4032504"/>
+            <a:ext cx="4114800" cy="603504"/>
+          </a:xfrm>
+          <a:prstGeom prst="rect">
+            <a:avLst/>
+          </a:prstGeom>
+          <a:noFill/>
+        </p:spPr>
+        <p:txBody>
+          <a:bodyPr wrap="square" lIns="0" rIns="0" tIns="0" bIns="0" anchor="ctr">
+            <a:spAutoFit/>
+          </a:bodyPr>
+          <a:lstStyle/>
+          <a:p>
+            <a:pPr algn="l"/>
+            <a:r>
+              <a:rPr sz="1300" b="1" i="0">
+                <a:solidFill>
+                  <a:srgbClr val="1F6F5C"/>
+                </a:solidFill>
+                <a:latin typeface="Calibri"/>
+              </a:rPr>
+              <a:t>Не курс, а 10–20 минут диагностики: с чего начать</a:t>
+            </a:r>
+          </a:p>
+        </p:txBody>
+      </p:sp>
+      <p:sp>
+        <p:nvSpPr>
+          <p:cNvPr id="21" name="Rounded Rectangle 20"/>
+          <p:cNvSpPr/>
+          <p:nvPr/>
+        </p:nvSpPr>
+        <p:spPr>
+          <a:xfrm>
+            <a:off x="640080" y="4837176"/>
+            <a:ext cx="10881360" cy="786384"/>
+          </a:xfrm>
+          <a:prstGeom prst="roundRect">
+            <a:avLst>
+              <a:gd name="adj" fmla="val 10000"/>
+            </a:avLst>
+          </a:prstGeom>
+          <a:solidFill>
+            <a:srgbClr val="F3F5F2"/>
+          </a:solidFill>
+          <a:ln>
+            <a:noFill/>
+          </a:ln>
+          <a:effectLst/>
+        </p:spPr>
+        <p:style>
+          <a:lnRef idx="1">
+            <a:schemeClr val="accent1"/>
+          </a:lnRef>
+          <a:fillRef idx="3">
+            <a:schemeClr val="accent1"/>
+          </a:fillRef>
+          <a:effectRef idx="2">
+            <a:schemeClr val="accent1"/>
+          </a:effectRef>
+          <a:fontRef idx="minor">
+            <a:schemeClr val="lt1"/>
+          </a:fontRef>
+        </p:style>
+        <p:txBody>
+          <a:bodyPr rtlCol="0" anchor="ctr" lIns="109728" rIns="109728"/>
+          <a:lstStyle/>
+          <a:p>
+            <a:pPr algn="ctr"/>
+          </a:p>
+        </p:txBody>
+      </p:sp>
+      <p:sp>
+        <p:nvSpPr>
+          <p:cNvPr id="22" name="TextBox 21"/>
+          <p:cNvSpPr txBox="1"/>
+          <p:nvPr/>
+        </p:nvSpPr>
+        <p:spPr>
+          <a:xfrm>
+            <a:off x="868680" y="4956048"/>
+            <a:ext cx="1920240" cy="320040"/>
+          </a:xfrm>
+          <a:prstGeom prst="rect">
+            <a:avLst/>
+          </a:prstGeom>
+          <a:noFill/>
+        </p:spPr>
+        <p:txBody>
+          <a:bodyPr wrap="square" lIns="0" rIns="0" tIns="0" bIns="0" anchor="t">
+            <a:spAutoFit/>
+          </a:bodyPr>
+          <a:lstStyle/>
+          <a:p>
+            <a:pPr algn="l"/>
+            <a:r>
+              <a:rPr sz="1700" b="1" i="0">
+                <a:solidFill>
+                  <a:srgbClr val="1D1F1C"/>
+                </a:solidFill>
+                <a:latin typeface="Cambria"/>
+              </a:rPr>
+              <a:t>Пробники ЕНТ</a:t>
+            </a:r>
+          </a:p>
+        </p:txBody>
+      </p:sp>
+      <p:sp>
+        <p:nvSpPr>
+          <p:cNvPr id="23" name="TextBox 22"/>
+          <p:cNvSpPr txBox="1"/>
+          <p:nvPr/>
+        </p:nvSpPr>
+        <p:spPr>
+          <a:xfrm>
+            <a:off x="868680" y="5294376"/>
+            <a:ext cx="1920240" cy="274320"/>
+          </a:xfrm>
+          <a:prstGeom prst="rect">
+            <a:avLst/>
+          </a:prstGeom>
+          <a:noFill/>
+        </p:spPr>
+        <p:txBody>
+          <a:bodyPr wrap="square" lIns="0" rIns="0" tIns="0" bIns="0" anchor="t">
+            <a:spAutoFit/>
+          </a:bodyPr>
+          <a:lstStyle/>
+          <a:p>
+            <a:pPr algn="l"/>
+            <a:r>
+              <a:rPr sz="1100" b="0" i="0">
+                <a:solidFill>
+                  <a:srgbClr val="5B5F58"/>
+                </a:solidFill>
+                <a:latin typeface="Calibri"/>
+              </a:rPr>
+              <a:t>Казахстан</a:t>
+            </a:r>
+          </a:p>
+        </p:txBody>
+      </p:sp>
+      <p:sp>
+        <p:nvSpPr>
+          <p:cNvPr id="24" name="TextBox 23"/>
+          <p:cNvSpPr txBox="1"/>
+          <p:nvPr/>
+        </p:nvSpPr>
+        <p:spPr>
+          <a:xfrm>
+            <a:off x="2926080" y="4928616"/>
+            <a:ext cx="4023360" cy="603504"/>
+          </a:xfrm>
+          <a:prstGeom prst="rect">
+            <a:avLst/>
+          </a:prstGeom>
+          <a:noFill/>
+        </p:spPr>
+        <p:txBody>
+          <a:bodyPr wrap="square" lIns="0" rIns="0" tIns="0" bIns="0" anchor="ctr">
+            <a:spAutoFit/>
+          </a:bodyPr>
+          <a:lstStyle/>
+          <a:p>
+            <a:pPr algn="l"/>
+            <a:r>
+              <a:rPr sz="1300" b="0" i="0">
+                <a:solidFill>
+                  <a:srgbClr val="1D1F1C"/>
+                </a:solidFill>
+                <a:latin typeface="Calibri"/>
+              </a:rPr>
+              <a:t>Балл и разбор по темам, где произошла ошибка.</a:t>
+            </a:r>
+          </a:p>
+        </p:txBody>
+      </p:sp>
+      <p:sp>
+        <p:nvSpPr>
+          <p:cNvPr id="25" name="TextBox 24"/>
+          <p:cNvSpPr txBox="1"/>
+          <p:nvPr/>
+        </p:nvSpPr>
+        <p:spPr>
+          <a:xfrm>
+            <a:off x="7223760" y="4928616"/>
+            <a:ext cx="4114800" cy="603504"/>
+          </a:xfrm>
+          <a:prstGeom prst="rect">
+            <a:avLst/>
+          </a:prstGeom>
+          <a:noFill/>
+        </p:spPr>
+        <p:txBody>
+          <a:bodyPr wrap="square" lIns="0" rIns="0" tIns="0" bIns="0" anchor="ctr">
+            <a:spAutoFit/>
+          </a:bodyPr>
+          <a:lstStyle/>
+          <a:p>
+            <a:pPr algn="l"/>
+            <a:r>
+              <a:rPr sz="1300" b="1" i="0">
+                <a:solidFill>
+                  <a:srgbClr val="1F6F5C"/>
+                </a:solidFill>
+                <a:latin typeface="Calibri"/>
+              </a:rPr>
+              <a:t>Причина, а не балл; учителю — корни класса и группы</a:t>
+            </a:r>
+          </a:p>
+        </p:txBody>
+      </p:sp>
+      <p:sp>
+        <p:nvSpPr>
+          <p:cNvPr id="26" name="TextBox 25"/>
+          <p:cNvSpPr txBox="1"/>
+          <p:nvPr/>
+        </p:nvSpPr>
+        <p:spPr>
+          <a:xfrm>
+            <a:off x="640080" y="5852160"/>
+            <a:ext cx="10881360" cy="548640"/>
+          </a:xfrm>
+          <a:prstGeom prst="rect">
+            <a:avLst/>
+          </a:prstGeom>
+          <a:noFill/>
+        </p:spPr>
+        <p:txBody>
+          <a:bodyPr wrap="square" lIns="0" rIns="0" tIns="0" bIns="0" anchor="t">
+            <a:spAutoFit/>
+          </a:bodyPr>
+          <a:lstStyle/>
+          <a:p>
+            <a:pPr algn="l"/>
             <a:r>
               <a:rPr sz="1500" b="1" i="0">
                 <a:solidFill>
-                  <a:srgbClr val="FFFFFF"/>
-                </a:solidFill>
-                <a:latin typeface="Calibri"/>
-              </a:rPr>
-              <a:t>Проверка на людях — заполните реальными данными:</a:t>
-            </a:r>
-          </a:p>
-          <a:p>
-            <a:pPr algn="l">
-              <a:spcAft>
-                <a:spcPts val="600"/>
-              </a:spcAft>
-            </a:pPr>
+                  <a:srgbClr val="1D1F1C"/>
+                </a:solidFill>
+                <a:latin typeface="Calibri"/>
+              </a:rPr>
+              <a:t>Наше отличие: </a:t>
+            </a:r>
             <a:r>
               <a:rPr sz="1500" b="0" i="0">
                 <a:solidFill>
-                  <a:srgbClr val="D8E6E0"/>
-                </a:solidFill>
-                <a:latin typeface="Calibri"/>
-              </a:rPr>
-              <a:t>опрос учеников (n = __), интервью с учителями (__ чел.), мини-пилот: совпадение корня с мнением учителя __ из __. Шаблоны: docs/validation-plan.md</a:t>
+                  <a:srgbClr val="5B5F58"/>
+                </a:solidFill>
+                <a:latin typeface="Calibri"/>
+              </a:rPr>
+              <a:t>неверный вариант → домашняя тема ошибки → проверка корня, под программу Казахстана, на любом телефоне, с панелью учителя.</a:t>
             </a:r>
           </a:p>
         </p:txBody>
@@ -9766,7 +10876,7 @@
     <p:bg>
       <p:bgPr>
         <a:solidFill>
-          <a:srgbClr val="FFFFFF"/>
+          <a:srgbClr val="142B25"/>
         </a:solidFill>
         <a:effectLst/>
       </p:bgPr>
@@ -9804,11 +10914,11 @@
             <a:r>
               <a:rPr sz="1200" b="1" i="0">
                 <a:solidFill>
-                  <a:srgbClr val="1F6F5C"/>
-                </a:solidFill>
-                <a:latin typeface="Calibri"/>
-              </a:rPr>
-              <a:t>ВНЕДРЕНИЕ И МОДЕЛЬ</a:t>
+                  <a:srgbClr val="9FD9C4"/>
+                </a:solidFill>
+                <a:latin typeface="Calibri"/>
+              </a:rPr>
+              <a:t>ВАЛИДАЦИЯ</a:t>
             </a:r>
           </a:p>
         </p:txBody>
@@ -9839,36 +10949,358 @@
             <a:r>
               <a:rPr sz="3600" b="1" i="0">
                 <a:solidFill>
-                  <a:srgbClr val="1D1F1C"/>
+                  <a:srgbClr val="FFFFFF"/>
                 </a:solidFill>
                 <a:latin typeface="Cambria"/>
               </a:rPr>
-              <a:t>Реализуемо уже сейчас</a:t>
-            </a:r>
-          </a:p>
-        </p:txBody>
-      </p:sp>
-      <p:sp>
-        <p:nvSpPr>
-          <p:cNvPr id="4" name="Rounded Rectangle 3"/>
+              <a:t>Что уже проверено</a:t>
+            </a:r>
+          </a:p>
+        </p:txBody>
+      </p:sp>
+      <p:sp>
+        <p:nvSpPr>
+          <p:cNvPr id="4" name="TextBox 3"/>
+          <p:cNvSpPr txBox="1"/>
+          <p:nvPr/>
+        </p:nvSpPr>
+        <p:spPr>
+          <a:xfrm>
+            <a:off x="640080" y="1965960"/>
+            <a:ext cx="2651760" cy="914400"/>
+          </a:xfrm>
+          <a:prstGeom prst="rect">
+            <a:avLst/>
+          </a:prstGeom>
+          <a:noFill/>
+        </p:spPr>
+        <p:txBody>
+          <a:bodyPr wrap="square" lIns="0" rIns="0" tIns="0" bIns="0" anchor="t">
+            <a:spAutoFit/>
+          </a:bodyPr>
+          <a:lstStyle/>
+          <a:p>
+            <a:pPr algn="l"/>
+            <a:r>
+              <a:rPr sz="4800" b="1" i="0">
+                <a:solidFill>
+                  <a:srgbClr val="9FD9C4"/>
+                </a:solidFill>
+                <a:latin typeface="Cambria"/>
+              </a:rPr>
+              <a:t>79%</a:t>
+            </a:r>
+          </a:p>
+        </p:txBody>
+      </p:sp>
+      <p:sp>
+        <p:nvSpPr>
+          <p:cNvPr id="5" name="TextBox 4"/>
+          <p:cNvSpPr txBox="1"/>
+          <p:nvPr/>
+        </p:nvSpPr>
+        <p:spPr>
+          <a:xfrm>
+            <a:off x="640080" y="2926080"/>
+            <a:ext cx="2651760" cy="822960"/>
+          </a:xfrm>
+          <a:prstGeom prst="rect">
+            <a:avLst/>
+          </a:prstGeom>
+          <a:noFill/>
+        </p:spPr>
+        <p:txBody>
+          <a:bodyPr wrap="square" lIns="0" rIns="0" tIns="0" bIns="0" anchor="t">
+            <a:spAutoFit/>
+          </a:bodyPr>
+          <a:lstStyle/>
+          <a:p>
+            <a:pPr algn="l"/>
+            <a:r>
+              <a:rPr sz="1500" b="0" i="0">
+                <a:solidFill>
+                  <a:srgbClr val="D8E6E0"/>
+                </a:solidFill>
+                <a:latin typeface="Calibri"/>
+              </a:rPr>
+              <a:t>настоящих корней
+найдено (полнота)</a:t>
+            </a:r>
+          </a:p>
+        </p:txBody>
+      </p:sp>
+      <p:sp>
+        <p:nvSpPr>
+          <p:cNvPr id="6" name="TextBox 5"/>
+          <p:cNvSpPr txBox="1"/>
+          <p:nvPr/>
+        </p:nvSpPr>
+        <p:spPr>
+          <a:xfrm>
+            <a:off x="3474720" y="1965960"/>
+            <a:ext cx="2651760" cy="914400"/>
+          </a:xfrm>
+          <a:prstGeom prst="rect">
+            <a:avLst/>
+          </a:prstGeom>
+          <a:noFill/>
+        </p:spPr>
+        <p:txBody>
+          <a:bodyPr wrap="square" lIns="0" rIns="0" tIns="0" bIns="0" anchor="t">
+            <a:spAutoFit/>
+          </a:bodyPr>
+          <a:lstStyle/>
+          <a:p>
+            <a:pPr algn="l"/>
+            <a:r>
+              <a:rPr sz="4800" b="1" i="0">
+                <a:solidFill>
+                  <a:srgbClr val="9FD9C4"/>
+                </a:solidFill>
+                <a:latin typeface="Cambria"/>
+              </a:rPr>
+              <a:t>72%</a:t>
+            </a:r>
+          </a:p>
+        </p:txBody>
+      </p:sp>
+      <p:sp>
+        <p:nvSpPr>
+          <p:cNvPr id="7" name="TextBox 6"/>
+          <p:cNvSpPr txBox="1"/>
+          <p:nvPr/>
+        </p:nvSpPr>
+        <p:spPr>
+          <a:xfrm>
+            <a:off x="3474720" y="2926080"/>
+            <a:ext cx="2651760" cy="822960"/>
+          </a:xfrm>
+          <a:prstGeom prst="rect">
+            <a:avLst/>
+          </a:prstGeom>
+          <a:noFill/>
+        </p:spPr>
+        <p:txBody>
+          <a:bodyPr wrap="square" lIns="0" rIns="0" tIns="0" bIns="0" anchor="t">
+            <a:spAutoFit/>
+          </a:bodyPr>
+          <a:lstStyle/>
+          <a:p>
+            <a:pPr algn="l"/>
+            <a:r>
+              <a:rPr sz="1500" b="0" i="0">
+                <a:solidFill>
+                  <a:srgbClr val="D8E6E0"/>
+                </a:solidFill>
+                <a:latin typeface="Calibri"/>
+              </a:rPr>
+              <a:t>найденных корней
+верны (точность)</a:t>
+            </a:r>
+          </a:p>
+        </p:txBody>
+      </p:sp>
+      <p:sp>
+        <p:nvSpPr>
+          <p:cNvPr id="8" name="TextBox 7"/>
+          <p:cNvSpPr txBox="1"/>
+          <p:nvPr/>
+        </p:nvSpPr>
+        <p:spPr>
+          <a:xfrm>
+            <a:off x="6309360" y="1965960"/>
+            <a:ext cx="2651760" cy="914400"/>
+          </a:xfrm>
+          <a:prstGeom prst="rect">
+            <a:avLst/>
+          </a:prstGeom>
+          <a:noFill/>
+        </p:spPr>
+        <p:txBody>
+          <a:bodyPr wrap="square" lIns="0" rIns="0" tIns="0" bIns="0" anchor="t">
+            <a:spAutoFit/>
+          </a:bodyPr>
+          <a:lstStyle/>
+          <a:p>
+            <a:pPr algn="l"/>
+            <a:r>
+              <a:rPr sz="4800" b="1" i="0">
+                <a:solidFill>
+                  <a:srgbClr val="9FD9C4"/>
+                </a:solidFill>
+                <a:latin typeface="Cambria"/>
+              </a:rPr>
+              <a:t>9 / 28</a:t>
+            </a:r>
+          </a:p>
+        </p:txBody>
+      </p:sp>
+      <p:sp>
+        <p:nvSpPr>
+          <p:cNvPr id="9" name="TextBox 8"/>
+          <p:cNvSpPr txBox="1"/>
+          <p:nvPr/>
+        </p:nvSpPr>
+        <p:spPr>
+          <a:xfrm>
+            <a:off x="6309360" y="2926080"/>
+            <a:ext cx="2651760" cy="822960"/>
+          </a:xfrm>
+          <a:prstGeom prst="rect">
+            <a:avLst/>
+          </a:prstGeom>
+          <a:noFill/>
+        </p:spPr>
+        <p:txBody>
+          <a:bodyPr wrap="square" lIns="0" rIns="0" tIns="0" bIns="0" anchor="t">
+            <a:spAutoFit/>
+          </a:bodyPr>
+          <a:lstStyle/>
+          <a:p>
+            <a:pPr algn="l"/>
+            <a:r>
+              <a:rPr sz="1500" b="0" i="0">
+                <a:solidFill>
+                  <a:srgbClr val="D8E6E0"/>
+                </a:solidFill>
+                <a:latin typeface="Calibri"/>
+              </a:rPr>
+              <a:t>вопросов: без пробелов /
+с одним пробелом</a:t>
+            </a:r>
+          </a:p>
+        </p:txBody>
+      </p:sp>
+      <p:sp>
+        <p:nvSpPr>
+          <p:cNvPr id="10" name="TextBox 9"/>
+          <p:cNvSpPr txBox="1"/>
+          <p:nvPr/>
+        </p:nvSpPr>
+        <p:spPr>
+          <a:xfrm>
+            <a:off x="9144000" y="1965960"/>
+            <a:ext cx="2651760" cy="914400"/>
+          </a:xfrm>
+          <a:prstGeom prst="rect">
+            <a:avLst/>
+          </a:prstGeom>
+          <a:noFill/>
+        </p:spPr>
+        <p:txBody>
+          <a:bodyPr wrap="square" lIns="0" rIns="0" tIns="0" bIns="0" anchor="t">
+            <a:spAutoFit/>
+          </a:bodyPr>
+          <a:lstStyle/>
+          <a:p>
+            <a:pPr algn="l"/>
+            <a:r>
+              <a:rPr sz="4800" b="1" i="0">
+                <a:solidFill>
+                  <a:srgbClr val="9FD9C4"/>
+                </a:solidFill>
+                <a:latin typeface="Cambria"/>
+              </a:rPr>
+              <a:t>16 / 16</a:t>
+            </a:r>
+          </a:p>
+        </p:txBody>
+      </p:sp>
+      <p:sp>
+        <p:nvSpPr>
+          <p:cNvPr id="11" name="TextBox 10"/>
+          <p:cNvSpPr txBox="1"/>
+          <p:nvPr/>
+        </p:nvSpPr>
+        <p:spPr>
+          <a:xfrm>
+            <a:off x="9144000" y="2926080"/>
+            <a:ext cx="2651760" cy="822960"/>
+          </a:xfrm>
+          <a:prstGeom prst="rect">
+            <a:avLst/>
+          </a:prstGeom>
+          <a:noFill/>
+        </p:spPr>
+        <p:txBody>
+          <a:bodyPr wrap="square" lIns="0" rIns="0" tIns="0" bIns="0" anchor="t">
+            <a:spAutoFit/>
+          </a:bodyPr>
+          <a:lstStyle/>
+          <a:p>
+            <a:pPr algn="l"/>
+            <a:r>
+              <a:rPr sz="1500" b="0" i="0">
+                <a:solidFill>
+                  <a:srgbClr val="D8E6E0"/>
+                </a:solidFill>
+                <a:latin typeface="Calibri"/>
+              </a:rPr>
+              <a:t>юнит-тестов
+проходят</a:t>
+            </a:r>
+          </a:p>
+        </p:txBody>
+      </p:sp>
+      <p:sp>
+        <p:nvSpPr>
+          <p:cNvPr id="12" name="TextBox 11"/>
+          <p:cNvSpPr txBox="1"/>
+          <p:nvPr/>
+        </p:nvSpPr>
+        <p:spPr>
+          <a:xfrm>
+            <a:off x="640080" y="3977639"/>
+            <a:ext cx="10881360" cy="640080"/>
+          </a:xfrm>
+          <a:prstGeom prst="rect">
+            <a:avLst/>
+          </a:prstGeom>
+          <a:noFill/>
+        </p:spPr>
+        <p:txBody>
+          <a:bodyPr wrap="square" lIns="0" rIns="0" tIns="0" bIns="0" anchor="t">
+            <a:spAutoFit/>
+          </a:bodyPr>
+          <a:lstStyle/>
+          <a:p>
+            <a:pPr algn="l"/>
+            <a:r>
+              <a:rPr sz="1400" b="0" i="0">
+                <a:solidFill>
+                  <a:srgbClr val="B5CCC3"/>
+                </a:solidFill>
+                <a:latin typeface="Calibri"/>
+              </a:rPr>
+              <a:t>Контрольная симуляция: 1000 новых виртуальных учеников с известными пробелами, не использованных при доработке движка. Угадывание 20%, ошибки в знакомых темах 8%. Модель ученика наша, поэтому это оценка сверху; без шума алгоритм находит 100% корней.</a:t>
+            </a:r>
+          </a:p>
+        </p:txBody>
+      </p:sp>
+      <p:sp>
+        <p:nvSpPr>
+          <p:cNvPr id="13" name="Rounded Rectangle 12"/>
           <p:cNvSpPr/>
           <p:nvPr/>
         </p:nvSpPr>
         <p:spPr>
           <a:xfrm>
-            <a:off x="640080" y="1920240"/>
-            <a:ext cx="3474720" cy="4114800"/>
+            <a:off x="640080" y="4846320"/>
+            <a:ext cx="10881360" cy="1371600"/>
           </a:xfrm>
           <a:prstGeom prst="roundRect">
             <a:avLst>
-              <a:gd name="adj" fmla="val 5000"/>
+              <a:gd name="adj" fmla="val 12000"/>
             </a:avLst>
           </a:prstGeom>
           <a:solidFill>
-            <a:srgbClr val="F3F5F2"/>
+            <a:srgbClr val="1F3D35"/>
           </a:solidFill>
-          <a:ln>
-            <a:noFill/>
+          <a:ln w="25400">
+            <a:solidFill>
+              <a:srgbClr val="9FD9C4"/>
+            </a:solidFill>
+            <a:prstDash val="dash"/>
           </a:ln>
           <a:effectLst/>
         </p:spPr>
@@ -9896,14 +11328,14 @@
       </p:sp>
       <p:sp>
         <p:nvSpPr>
-          <p:cNvPr id="5" name="TextBox 4"/>
+          <p:cNvPr id="14" name="TextBox 13"/>
           <p:cNvSpPr txBox="1"/>
           <p:nvPr/>
         </p:nvSpPr>
         <p:spPr>
           <a:xfrm>
-            <a:off x="914400" y="2148840"/>
-            <a:ext cx="2926080" cy="457200"/>
+            <a:off x="914400" y="4983480"/>
+            <a:ext cx="10332720" cy="1143000"/>
           </a:xfrm>
           <a:prstGeom prst="rect">
             <a:avLst/>
@@ -9916,433 +11348,35 @@
           </a:bodyPr>
           <a:lstStyle/>
           <a:p>
-            <a:pPr algn="l"/>
-            <a:r>
-              <a:rPr sz="2100" b="1" i="0">
-                <a:solidFill>
-                  <a:srgbClr val="1F6F5C"/>
-                </a:solidFill>
-                <a:latin typeface="Cambria"/>
-              </a:rPr>
-              <a:t>Технологии</a:t>
-            </a:r>
-          </a:p>
-        </p:txBody>
-      </p:sp>
-      <p:sp>
-        <p:nvSpPr>
-          <p:cNvPr id="6" name="TextBox 5"/>
-          <p:cNvSpPr txBox="1"/>
-          <p:nvPr/>
-        </p:nvSpPr>
-        <p:spPr>
-          <a:xfrm>
-            <a:off x="914400" y="2743200"/>
-            <a:ext cx="2971800" cy="3200400"/>
-          </a:xfrm>
-          <a:prstGeom prst="rect">
-            <a:avLst/>
-          </a:prstGeom>
-          <a:noFill/>
-        </p:spPr>
-        <p:txBody>
-          <a:bodyPr wrap="square" lIns="0" rIns="0" tIns="0" bIns="0" anchor="t">
-            <a:spAutoFit/>
-          </a:bodyPr>
-          <a:lstStyle/>
-          <a:p>
-            <a:pPr algn="l" marL="201168" indent="-201168">
+            <a:pPr algn="l">
               <a:spcAft>
-                <a:spcPts val="1000"/>
+                <a:spcPts val="600"/>
               </a:spcAft>
-              <a:buChar char="•"/>
             </a:pPr>
             <a:r>
+              <a:rPr sz="1500" b="1" i="0">
+                <a:solidFill>
+                  <a:srgbClr val="FFFFFF"/>
+                </a:solidFill>
+                <a:latin typeface="Calibri"/>
+              </a:rPr>
+              <a:t>Проверка на людях — заполните реальными данными:</a:t>
+            </a:r>
+          </a:p>
+          <a:p>
+            <a:pPr algn="l">
+              <a:spcAft>
+                <a:spcPts val="600"/>
+              </a:spcAft>
+            </a:pPr>
+            <a:r>
               <a:rPr sz="1500" b="0" i="0">
                 <a:solidFill>
-                  <a:srgbClr val="1D1F1C"/>
-                </a:solidFill>
-                <a:latin typeface="Calibri"/>
-              </a:rPr>
-              <a:t>HTML/CSS/JS без зависимостей</a:t>
-            </a:r>
-          </a:p>
-          <a:p>
-            <a:pPr algn="l" marL="201168" indent="-201168">
-              <a:spcAft>
-                <a:spcPts val="1000"/>
-              </a:spcAft>
-              <a:buChar char="•"/>
-            </a:pPr>
-            <a:r>
-              <a:rPr sz="1500" b="0" i="0">
-                <a:solidFill>
-                  <a:srgbClr val="1D1F1C"/>
-                </a:solidFill>
-                <a:latin typeface="Calibri"/>
-              </a:rPr>
-              <a:t>Работает офлайн на любом телефоне</a:t>
-            </a:r>
-          </a:p>
-          <a:p>
-            <a:pPr algn="l" marL="201168" indent="-201168">
-              <a:spcAft>
-                <a:spcPts val="1000"/>
-              </a:spcAft>
-              <a:buChar char="•"/>
-            </a:pPr>
-            <a:r>
-              <a:rPr sz="1500" b="0" i="0">
-                <a:solidFill>
-                  <a:srgbClr val="1D1F1C"/>
-                </a:solidFill>
-                <a:latin typeface="Calibri"/>
-              </a:rPr>
-              <a:t>Граф и банк заданий — данные: новый предмет = новый файл</a:t>
-            </a:r>
-          </a:p>
-          <a:p>
-            <a:pPr algn="l" marL="201168" indent="-201168">
-              <a:spcAft>
-                <a:spcPts val="1000"/>
-              </a:spcAft>
-              <a:buChar char="•"/>
-            </a:pPr>
-            <a:r>
-              <a:rPr sz="1500" b="0" i="0">
-                <a:solidFill>
-                  <a:srgbClr val="1D1F1C"/>
-                </a:solidFill>
-                <a:latin typeface="Calibri"/>
-              </a:rPr>
-              <a:t>Персональные данные остаются на устройстве</a:t>
-            </a:r>
-          </a:p>
-        </p:txBody>
-      </p:sp>
-      <p:sp>
-        <p:nvSpPr>
-          <p:cNvPr id="7" name="Rounded Rectangle 6"/>
-          <p:cNvSpPr/>
-          <p:nvPr/>
-        </p:nvSpPr>
-        <p:spPr>
-          <a:xfrm>
-            <a:off x="4389120" y="1920240"/>
-            <a:ext cx="3474720" cy="4114800"/>
-          </a:xfrm>
-          <a:prstGeom prst="roundRect">
-            <a:avLst>
-              <a:gd name="adj" fmla="val 5000"/>
-            </a:avLst>
-          </a:prstGeom>
-          <a:solidFill>
-            <a:srgbClr val="F3F5F2"/>
-          </a:solidFill>
-          <a:ln>
-            <a:noFill/>
-          </a:ln>
-          <a:effectLst/>
-        </p:spPr>
-        <p:style>
-          <a:lnRef idx="1">
-            <a:schemeClr val="accent1"/>
-          </a:lnRef>
-          <a:fillRef idx="3">
-            <a:schemeClr val="accent1"/>
-          </a:fillRef>
-          <a:effectRef idx="2">
-            <a:schemeClr val="accent1"/>
-          </a:effectRef>
-          <a:fontRef idx="minor">
-            <a:schemeClr val="lt1"/>
-          </a:fontRef>
-        </p:style>
-        <p:txBody>
-          <a:bodyPr rtlCol="0" anchor="ctr" lIns="109728" rIns="109728"/>
-          <a:lstStyle/>
-          <a:p>
-            <a:pPr algn="ctr"/>
-          </a:p>
-        </p:txBody>
-      </p:sp>
-      <p:sp>
-        <p:nvSpPr>
-          <p:cNvPr id="8" name="TextBox 7"/>
-          <p:cNvSpPr txBox="1"/>
-          <p:nvPr/>
-        </p:nvSpPr>
-        <p:spPr>
-          <a:xfrm>
-            <a:off x="4663440" y="2148840"/>
-            <a:ext cx="2926080" cy="457200"/>
-          </a:xfrm>
-          <a:prstGeom prst="rect">
-            <a:avLst/>
-          </a:prstGeom>
-          <a:noFill/>
-        </p:spPr>
-        <p:txBody>
-          <a:bodyPr wrap="square" lIns="0" rIns="0" tIns="0" bIns="0" anchor="t">
-            <a:spAutoFit/>
-          </a:bodyPr>
-          <a:lstStyle/>
-          <a:p>
-            <a:pPr algn="l"/>
-            <a:r>
-              <a:rPr sz="2100" b="1" i="0">
-                <a:solidFill>
-                  <a:srgbClr val="1F6F5C"/>
-                </a:solidFill>
-                <a:latin typeface="Cambria"/>
-              </a:rPr>
-              <a:t>Кому и за сколько</a:t>
-            </a:r>
-          </a:p>
-        </p:txBody>
-      </p:sp>
-      <p:sp>
-        <p:nvSpPr>
-          <p:cNvPr id="9" name="TextBox 8"/>
-          <p:cNvSpPr txBox="1"/>
-          <p:nvPr/>
-        </p:nvSpPr>
-        <p:spPr>
-          <a:xfrm>
-            <a:off x="4663440" y="2743200"/>
-            <a:ext cx="2971800" cy="3200400"/>
-          </a:xfrm>
-          <a:prstGeom prst="rect">
-            <a:avLst/>
-          </a:prstGeom>
-          <a:noFill/>
-        </p:spPr>
-        <p:txBody>
-          <a:bodyPr wrap="square" lIns="0" rIns="0" tIns="0" bIns="0" anchor="t">
-            <a:spAutoFit/>
-          </a:bodyPr>
-          <a:lstStyle/>
-          <a:p>
-            <a:pPr algn="l" marL="201168" indent="-201168">
-              <a:spcAft>
-                <a:spcPts val="1000"/>
-              </a:spcAft>
-              <a:buChar char="•"/>
-            </a:pPr>
-            <a:r>
-              <a:rPr sz="1500" b="0" i="0">
-                <a:solidFill>
-                  <a:srgbClr val="1D1F1C"/>
-                </a:solidFill>
-                <a:latin typeface="Calibri"/>
-              </a:rPr>
-              <a:t>Ученикам: бесплатная диагностика, платные банки (геометрия, мат. грамотность)</a:t>
-            </a:r>
-          </a:p>
-          <a:p>
-            <a:pPr algn="l" marL="201168" indent="-201168">
-              <a:spcAft>
-                <a:spcPts val="1000"/>
-              </a:spcAft>
-              <a:buChar char="•"/>
-            </a:pPr>
-            <a:r>
-              <a:rPr sz="1500" b="0" i="0">
-                <a:solidFill>
-                  <a:srgbClr val="1D1F1C"/>
-                </a:solidFill>
-                <a:latin typeface="Calibri"/>
-              </a:rPr>
-              <a:t>Школам: панель учителя, подписка за класс</a:t>
-            </a:r>
-          </a:p>
-          <a:p>
-            <a:pPr algn="l" marL="201168" indent="-201168">
-              <a:spcAft>
-                <a:spcPts val="1000"/>
-              </a:spcAft>
-              <a:buChar char="•"/>
-            </a:pPr>
-            <a:r>
-              <a:rPr sz="1500" b="0" i="0">
-                <a:solidFill>
-                  <a:srgbClr val="1D1F1C"/>
-                </a:solidFill>
-                <a:latin typeface="Calibri"/>
-              </a:rPr>
-              <a:t>Учебным центрам: входная диагностика новых учеников</a:t>
-            </a:r>
-          </a:p>
-        </p:txBody>
-      </p:sp>
-      <p:sp>
-        <p:nvSpPr>
-          <p:cNvPr id="10" name="Rounded Rectangle 9"/>
-          <p:cNvSpPr/>
-          <p:nvPr/>
-        </p:nvSpPr>
-        <p:spPr>
-          <a:xfrm>
-            <a:off x="8138159" y="1920240"/>
-            <a:ext cx="3474720" cy="4114800"/>
-          </a:xfrm>
-          <a:prstGeom prst="roundRect">
-            <a:avLst>
-              <a:gd name="adj" fmla="val 5000"/>
-            </a:avLst>
-          </a:prstGeom>
-          <a:solidFill>
-            <a:srgbClr val="F3F5F2"/>
-          </a:solidFill>
-          <a:ln>
-            <a:noFill/>
-          </a:ln>
-          <a:effectLst/>
-        </p:spPr>
-        <p:style>
-          <a:lnRef idx="1">
-            <a:schemeClr val="accent1"/>
-          </a:lnRef>
-          <a:fillRef idx="3">
-            <a:schemeClr val="accent1"/>
-          </a:fillRef>
-          <a:effectRef idx="2">
-            <a:schemeClr val="accent1"/>
-          </a:effectRef>
-          <a:fontRef idx="minor">
-            <a:schemeClr val="lt1"/>
-          </a:fontRef>
-        </p:style>
-        <p:txBody>
-          <a:bodyPr rtlCol="0" anchor="ctr" lIns="109728" rIns="109728"/>
-          <a:lstStyle/>
-          <a:p>
-            <a:pPr algn="ctr"/>
-          </a:p>
-        </p:txBody>
-      </p:sp>
-      <p:sp>
-        <p:nvSpPr>
-          <p:cNvPr id="11" name="TextBox 10"/>
-          <p:cNvSpPr txBox="1"/>
-          <p:nvPr/>
-        </p:nvSpPr>
-        <p:spPr>
-          <a:xfrm>
-            <a:off x="8412480" y="2148840"/>
-            <a:ext cx="2926080" cy="457200"/>
-          </a:xfrm>
-          <a:prstGeom prst="rect">
-            <a:avLst/>
-          </a:prstGeom>
-          <a:noFill/>
-        </p:spPr>
-        <p:txBody>
-          <a:bodyPr wrap="square" lIns="0" rIns="0" tIns="0" bIns="0" anchor="t">
-            <a:spAutoFit/>
-          </a:bodyPr>
-          <a:lstStyle/>
-          <a:p>
-            <a:pPr algn="l"/>
-            <a:r>
-              <a:rPr sz="2100" b="1" i="0">
-                <a:solidFill>
-                  <a:srgbClr val="1F6F5C"/>
-                </a:solidFill>
-                <a:latin typeface="Cambria"/>
-              </a:rPr>
-              <a:t>Для запуска</a:t>
-            </a:r>
-          </a:p>
-        </p:txBody>
-      </p:sp>
-      <p:sp>
-        <p:nvSpPr>
-          <p:cNvPr id="12" name="TextBox 11"/>
-          <p:cNvSpPr txBox="1"/>
-          <p:nvPr/>
-        </p:nvSpPr>
-        <p:spPr>
-          <a:xfrm>
-            <a:off x="8412480" y="2743200"/>
-            <a:ext cx="2971800" cy="3200400"/>
-          </a:xfrm>
-          <a:prstGeom prst="rect">
-            <a:avLst/>
-          </a:prstGeom>
-          <a:noFill/>
-        </p:spPr>
-        <p:txBody>
-          <a:bodyPr wrap="square" lIns="0" rIns="0" tIns="0" bIns="0" anchor="t">
-            <a:spAutoFit/>
-          </a:bodyPr>
-          <a:lstStyle/>
-          <a:p>
-            <a:pPr algn="l" marL="201168" indent="-201168">
-              <a:spcAft>
-                <a:spcPts val="1000"/>
-              </a:spcAft>
-              <a:buChar char="•"/>
-            </a:pPr>
-            <a:r>
-              <a:rPr sz="1500" b="0" i="0">
-                <a:solidFill>
-                  <a:srgbClr val="1D1F1C"/>
-                </a:solidFill>
-                <a:latin typeface="Calibri"/>
-              </a:rPr>
-              <a:t>Проверка графа 2–3 учителями</a:t>
-            </a:r>
-          </a:p>
-          <a:p>
-            <a:pPr algn="l" marL="201168" indent="-201168">
-              <a:spcAft>
-                <a:spcPts val="1000"/>
-              </a:spcAft>
-              <a:buChar char="•"/>
-            </a:pPr>
-            <a:r>
-              <a:rPr sz="1500" b="0" i="0">
-                <a:solidFill>
-                  <a:srgbClr val="1D1F1C"/>
-                </a:solidFill>
-                <a:latin typeface="Calibri"/>
-              </a:rPr>
-              <a:t>Банк 5–6 вопросов на тему</a:t>
-            </a:r>
-          </a:p>
-          <a:p>
-            <a:pPr algn="l" marL="201168" indent="-201168">
-              <a:spcAft>
-                <a:spcPts val="1000"/>
-              </a:spcAft>
-              <a:buChar char="•"/>
-            </a:pPr>
-            <a:r>
-              <a:rPr sz="1500" b="0" i="0">
-                <a:solidFill>
-                  <a:srgbClr val="1D1F1C"/>
-                </a:solidFill>
-                <a:latin typeface="Calibri"/>
-              </a:rPr>
-              <a:t>Казахская версия</a:t>
-            </a:r>
-          </a:p>
-          <a:p>
-            <a:pPr algn="l" marL="201168" indent="-201168">
-              <a:spcAft>
-                <a:spcPts val="1000"/>
-              </a:spcAft>
-              <a:buChar char="•"/>
-            </a:pPr>
-            <a:r>
-              <a:rPr sz="1500" b="0" i="0">
-                <a:solidFill>
-                  <a:srgbClr val="1D1F1C"/>
-                </a:solidFill>
-                <a:latin typeface="Calibri"/>
-              </a:rPr>
-              <a:t>Пилот в 2–3 классах</a:t>
+                  <a:srgbClr val="D8E6E0"/>
+                </a:solidFill>
+                <a:latin typeface="Calibri"/>
+              </a:rPr>
+              <a:t>опрос учеников (n = __), интервью с учителями (__ чел.), мини-пилот: совпадение корня с мнением учителя __ из __. Шаблоны: docs/validation-plan.md</a:t>
             </a:r>
           </a:p>
         </p:txBody>

</xml_diff>

<commit_message>
Deck: use Arial Black for all text
Co-Authored-By: Claude Opus 5 <noreply@anthropic.com>
</commit_message>
<xml_diff>
--- a/docs/Tamyr_VentureHack2026.pptx
+++ b/docs/Tamyr_VentureHack2026.pptx
@@ -4463,11 +4463,11 @@
           <a:p>
             <a:pPr algn="l"/>
             <a:r>
-              <a:rPr sz="1600" b="1" i="0">
+              <a:rPr sz="1400" b="0" i="0">
                 <a:solidFill>
                   <a:srgbClr val="0B4DA2"/>
                 </a:solidFill>
-                <a:latin typeface="Calibri"/>
+                <a:latin typeface="Arial Black"/>
               </a:rPr>
               <a:t>Tamyr</a:t>
             </a:r>
@@ -4611,11 +4611,11 @@
           <a:p>
             <a:pPr algn="ctr"/>
             <a:r>
-              <a:rPr sz="1200" b="1">
+              <a:rPr sz="1000" b="0">
                 <a:solidFill>
                   <a:srgbClr val="FFFFFF"/>
                 </a:solidFill>
-                <a:latin typeface="Calibri"/>
+                <a:latin typeface="Arial Black"/>
               </a:rPr>
               <a:t>Кв.</a:t>
             </a:r>
@@ -4623,11 +4623,11 @@
           <a:p>
             <a:pPr algn="ctr"/>
             <a:r>
-              <a:rPr sz="1200" b="1">
+              <a:rPr sz="1000" b="0">
                 <a:solidFill>
                   <a:srgbClr val="FFFFFF"/>
                 </a:solidFill>
-                <a:latin typeface="Calibri"/>
+                <a:latin typeface="Arial Black"/>
               </a:rPr>
               <a:t>уравнения</a:t>
             </a:r>
@@ -4681,11 +4681,11 @@
           <a:p>
             <a:pPr algn="ctr"/>
             <a:r>
-              <a:rPr sz="1200" b="1">
+              <a:rPr sz="1000" b="0">
                 <a:solidFill>
                   <a:srgbClr val="FFFFFF"/>
                 </a:solidFill>
-                <a:latin typeface="Calibri"/>
+                <a:latin typeface="Arial Black"/>
               </a:rPr>
               <a:t>Лин.</a:t>
             </a:r>
@@ -4693,11 +4693,11 @@
           <a:p>
             <a:pPr algn="ctr"/>
             <a:r>
-              <a:rPr sz="1200" b="1">
+              <a:rPr sz="1000" b="0">
                 <a:solidFill>
                   <a:srgbClr val="FFFFFF"/>
                 </a:solidFill>
-                <a:latin typeface="Calibri"/>
+                <a:latin typeface="Arial Black"/>
               </a:rPr>
               <a:t>уравнения</a:t>
             </a:r>
@@ -4751,11 +4751,11 @@
           <a:p>
             <a:pPr algn="ctr"/>
             <a:r>
-              <a:rPr sz="1400" b="1">
+              <a:rPr sz="1200" b="0">
                 <a:solidFill>
                   <a:srgbClr val="FFFFFF"/>
                 </a:solidFill>
-                <a:latin typeface="Calibri"/>
+                <a:latin typeface="Arial Black"/>
               </a:rPr>
               <a:t>Корни</a:t>
             </a:r>
@@ -4809,11 +4809,11 @@
           <a:p>
             <a:pPr algn="ctr"/>
             <a:r>
-              <a:rPr sz="1400" b="1">
+              <a:rPr sz="1200" b="0">
                 <a:solidFill>
                   <a:srgbClr val="FFFFFF"/>
                 </a:solidFill>
-                <a:latin typeface="Calibri"/>
+                <a:latin typeface="Arial Black"/>
               </a:rPr>
               <a:t>Дроби</a:t>
             </a:r>
@@ -4867,11 +4867,11 @@
           <a:p>
             <a:pPr algn="ctr"/>
             <a:r>
-              <a:rPr sz="1400" b="1">
+              <a:rPr sz="1200" b="0">
                 <a:solidFill>
                   <a:srgbClr val="082F66"/>
                 </a:solidFill>
-                <a:latin typeface="Calibri"/>
+                <a:latin typeface="Arial Black"/>
               </a:rPr>
               <a:t>Проценты</a:t>
             </a:r>
@@ -4925,11 +4925,11 @@
           <a:p>
             <a:pPr algn="ctr"/>
             <a:r>
-              <a:rPr sz="1400" b="1">
+              <a:rPr sz="1200" b="0">
                 <a:solidFill>
                   <a:srgbClr val="FFFFFF"/>
                 </a:solidFill>
-                <a:latin typeface="Calibri"/>
+                <a:latin typeface="Arial Black"/>
               </a:rPr>
               <a:t>Степени</a:t>
             </a:r>
@@ -4983,11 +4983,11 @@
           <a:p>
             <a:pPr algn="ctr"/>
             <a:r>
-              <a:rPr sz="1200" b="1">
+              <a:rPr sz="1000" b="0">
                 <a:solidFill>
                   <a:srgbClr val="082F66"/>
                 </a:solidFill>
-                <a:latin typeface="Calibri"/>
+                <a:latin typeface="Arial Black"/>
               </a:rPr>
               <a:t>Арифметика</a:t>
             </a:r>
@@ -5038,11 +5038,11 @@
           <a:p>
             <a:pPr algn="ctr"/>
             <a:r>
-              <a:rPr sz="1000" b="1">
+              <a:rPr sz="900" b="0">
                 <a:solidFill>
                   <a:srgbClr val="E0473E"/>
                 </a:solidFill>
-                <a:latin typeface="Calibri"/>
+                <a:latin typeface="Arial Black"/>
               </a:rPr>
               <a:t>КОРЕНЬ</a:t>
             </a:r>
@@ -5749,11 +5749,11 @@
           <a:p>
             <a:pPr algn="l"/>
             <a:r>
-              <a:rPr sz="1700" b="1" i="0">
+              <a:rPr sz="1500" b="0" i="0">
                 <a:solidFill>
                   <a:srgbClr val="0B4DA2"/>
                 </a:solidFill>
-                <a:latin typeface="Calibri"/>
+                <a:latin typeface="Arial Black"/>
               </a:rPr>
               <a:t>Адаптивная диагностика по математике для ЕНТ</a:t>
             </a:r>
@@ -5784,11 +5784,11 @@
           <a:p>
             <a:pPr algn="l"/>
             <a:r>
-              <a:rPr sz="1600" b="0" i="0">
+              <a:rPr sz="1400" b="0" i="0">
                 <a:solidFill>
                   <a:srgbClr val="4A4F57"/>
                 </a:solidFill>
-                <a:latin typeface="Calibri"/>
+                <a:latin typeface="Arial Black"/>
               </a:rPr>
               <a:t>За один тест показывает базовую тему, из-за которой «сыпятся» все следующие. Тамыр (каз.) — корень.</a:t>
             </a:r>
@@ -5837,11 +5837,11 @@
           <a:p>
             <a:pPr algn="ctr"/>
             <a:r>
-              <a:rPr sz="1400" b="1">
+              <a:rPr sz="1200" b="0">
                 <a:solidFill>
                   <a:srgbClr val="FFFFFF"/>
                 </a:solidFill>
-                <a:latin typeface="Calibri"/>
+                <a:latin typeface="Arial Black"/>
               </a:rPr>
               <a:t>Трек 2 · EduTech</a:t>
             </a:r>
@@ -5872,11 +5872,11 @@
           <a:p>
             <a:pPr algn="r"/>
             <a:r>
-              <a:rPr sz="1200" b="1" i="0">
+              <a:rPr sz="1100" b="0" i="0">
                 <a:solidFill>
                   <a:srgbClr val="7A808A"/>
                 </a:solidFill>
-                <a:latin typeface="Calibri"/>
+                <a:latin typeface="Arial Black"/>
               </a:rPr>
               <a:t>VentureHack 2026</a:t>
             </a:r>
@@ -6190,11 +6190,11 @@
           <a:p>
             <a:pPr algn="l"/>
             <a:r>
-              <a:rPr sz="1600" b="1" i="0">
+              <a:rPr sz="1400" b="0" i="0">
                 <a:solidFill>
                   <a:srgbClr val="0B4DA2"/>
                 </a:solidFill>
-                <a:latin typeface="Calibri"/>
+                <a:latin typeface="Arial Black"/>
               </a:rPr>
               <a:t>Tamyr</a:t>
             </a:r>
@@ -6600,11 +6600,11 @@
           <a:p>
             <a:pPr algn="l"/>
             <a:r>
-              <a:rPr sz="1900" b="1" i="0">
+              <a:rPr sz="1700" b="0" i="0">
                 <a:solidFill>
                   <a:srgbClr val="0B4DA2"/>
                 </a:solidFill>
-                <a:latin typeface="Calibri"/>
+                <a:latin typeface="Arial Black"/>
               </a:rPr>
               <a:t>Технологии</a:t>
             </a:r>
@@ -6640,11 +6640,11 @@
               <a:buChar char="•"/>
             </a:pPr>
             <a:r>
-              <a:rPr sz="1400" b="0" i="0">
+              <a:rPr sz="1200" b="0" i="0">
                 <a:solidFill>
                   <a:srgbClr val="4A4F57"/>
                 </a:solidFill>
-                <a:latin typeface="Calibri"/>
+                <a:latin typeface="Arial Black"/>
               </a:rPr>
               <a:t>HTML/CSS/JS без зависимостей</a:t>
             </a:r>
@@ -6657,11 +6657,11 @@
               <a:buChar char="•"/>
             </a:pPr>
             <a:r>
-              <a:rPr sz="1400" b="0" i="0">
+              <a:rPr sz="1200" b="0" i="0">
                 <a:solidFill>
                   <a:srgbClr val="4A4F57"/>
                 </a:solidFill>
-                <a:latin typeface="Calibri"/>
+                <a:latin typeface="Arial Black"/>
               </a:rPr>
               <a:t>Работает офлайн на любом телефоне</a:t>
             </a:r>
@@ -6674,11 +6674,11 @@
               <a:buChar char="•"/>
             </a:pPr>
             <a:r>
-              <a:rPr sz="1400" b="0" i="0">
+              <a:rPr sz="1200" b="0" i="0">
                 <a:solidFill>
                   <a:srgbClr val="4A4F57"/>
                 </a:solidFill>
-                <a:latin typeface="Calibri"/>
+                <a:latin typeface="Arial Black"/>
               </a:rPr>
               <a:t>Граф и банк заданий — данные: новый предмет = новый файл</a:t>
             </a:r>
@@ -6691,11 +6691,11 @@
               <a:buChar char="•"/>
             </a:pPr>
             <a:r>
-              <a:rPr sz="1400" b="0" i="0">
+              <a:rPr sz="1200" b="0" i="0">
                 <a:solidFill>
                   <a:srgbClr val="4A4F57"/>
                 </a:solidFill>
-                <a:latin typeface="Calibri"/>
+                <a:latin typeface="Arial Black"/>
               </a:rPr>
               <a:t>Персональные данные остаются на устройстве</a:t>
             </a:r>
@@ -6795,11 +6795,11 @@
           <a:p>
             <a:pPr algn="ctr"/>
             <a:r>
-              <a:rPr sz="2200" b="1">
+              <a:rPr sz="2200" b="0">
                 <a:solidFill>
                   <a:srgbClr val="FFFFFF"/>
                 </a:solidFill>
-                <a:latin typeface="Calibri"/>
+                <a:latin typeface="Arial Black"/>
               </a:rPr>
               <a:t>₸</a:t>
             </a:r>
@@ -6830,11 +6830,11 @@
           <a:p>
             <a:pPr algn="l"/>
             <a:r>
-              <a:rPr sz="1900" b="1" i="0">
+              <a:rPr sz="1700" b="0" i="0">
                 <a:solidFill>
                   <a:srgbClr val="0B4DA2"/>
                 </a:solidFill>
-                <a:latin typeface="Calibri"/>
+                <a:latin typeface="Arial Black"/>
               </a:rPr>
               <a:t>Кому и за сколько</a:t>
             </a:r>
@@ -6870,11 +6870,11 @@
               <a:buChar char="•"/>
             </a:pPr>
             <a:r>
-              <a:rPr sz="1400" b="0" i="0">
+              <a:rPr sz="1200" b="0" i="0">
                 <a:solidFill>
                   <a:srgbClr val="4A4F57"/>
                 </a:solidFill>
-                <a:latin typeface="Calibri"/>
+                <a:latin typeface="Arial Black"/>
               </a:rPr>
               <a:t>Ученикам: бесплатная диагностика, платные банки (геометрия, мат. грамотность)</a:t>
             </a:r>
@@ -6887,11 +6887,11 @@
               <a:buChar char="•"/>
             </a:pPr>
             <a:r>
-              <a:rPr sz="1400" b="0" i="0">
+              <a:rPr sz="1200" b="0" i="0">
                 <a:solidFill>
                   <a:srgbClr val="4A4F57"/>
                 </a:solidFill>
-                <a:latin typeface="Calibri"/>
+                <a:latin typeface="Arial Black"/>
               </a:rPr>
               <a:t>Школам: панель учителя, подписка за класс</a:t>
             </a:r>
@@ -6904,11 +6904,11 @@
               <a:buChar char="•"/>
             </a:pPr>
             <a:r>
-              <a:rPr sz="1400" b="0" i="0">
+              <a:rPr sz="1200" b="0" i="0">
                 <a:solidFill>
                   <a:srgbClr val="4A4F57"/>
                 </a:solidFill>
-                <a:latin typeface="Calibri"/>
+                <a:latin typeface="Arial Black"/>
               </a:rPr>
               <a:t>Учебным центрам: входная диагностика новых учеников</a:t>
             </a:r>
@@ -7008,11 +7008,11 @@
           <a:p>
             <a:pPr algn="ctr"/>
             <a:r>
-              <a:rPr sz="2200" b="1">
+              <a:rPr sz="2200" b="0">
                 <a:solidFill>
                   <a:srgbClr val="FFFFFF"/>
                 </a:solidFill>
-                <a:latin typeface="Calibri"/>
+                <a:latin typeface="Arial Black"/>
               </a:rPr>
               <a:t>✓</a:t>
             </a:r>
@@ -7043,11 +7043,11 @@
           <a:p>
             <a:pPr algn="l"/>
             <a:r>
-              <a:rPr sz="1900" b="1" i="0">
+              <a:rPr sz="1700" b="0" i="0">
                 <a:solidFill>
                   <a:srgbClr val="0B4DA2"/>
                 </a:solidFill>
-                <a:latin typeface="Calibri"/>
+                <a:latin typeface="Arial Black"/>
               </a:rPr>
               <a:t>Для запуска</a:t>
             </a:r>
@@ -7083,11 +7083,11 @@
               <a:buChar char="•"/>
             </a:pPr>
             <a:r>
-              <a:rPr sz="1400" b="0" i="0">
+              <a:rPr sz="1200" b="0" i="0">
                 <a:solidFill>
                   <a:srgbClr val="4A4F57"/>
                 </a:solidFill>
-                <a:latin typeface="Calibri"/>
+                <a:latin typeface="Arial Black"/>
               </a:rPr>
               <a:t>Проверка графа 2–3 учителями</a:t>
             </a:r>
@@ -7100,11 +7100,11 @@
               <a:buChar char="•"/>
             </a:pPr>
             <a:r>
-              <a:rPr sz="1400" b="0" i="0">
+              <a:rPr sz="1200" b="0" i="0">
                 <a:solidFill>
                   <a:srgbClr val="4A4F57"/>
                 </a:solidFill>
-                <a:latin typeface="Calibri"/>
+                <a:latin typeface="Arial Black"/>
               </a:rPr>
               <a:t>Банк 10+ вопросов на тему</a:t>
             </a:r>
@@ -7117,11 +7117,11 @@
               <a:buChar char="•"/>
             </a:pPr>
             <a:r>
-              <a:rPr sz="1400" b="0" i="0">
+              <a:rPr sz="1200" b="0" i="0">
                 <a:solidFill>
                   <a:srgbClr val="4A4F57"/>
                 </a:solidFill>
-                <a:latin typeface="Calibri"/>
+                <a:latin typeface="Arial Black"/>
               </a:rPr>
               <a:t>Казахская версия</a:t>
             </a:r>
@@ -7134,11 +7134,11 @@
               <a:buChar char="•"/>
             </a:pPr>
             <a:r>
-              <a:rPr sz="1400" b="0" i="0">
+              <a:rPr sz="1200" b="0" i="0">
                 <a:solidFill>
                   <a:srgbClr val="4A4F57"/>
                 </a:solidFill>
-                <a:latin typeface="Calibri"/>
+                <a:latin typeface="Arial Black"/>
               </a:rPr>
               <a:t>Пилот в 2–3 классах</a:t>
             </a:r>
@@ -7169,11 +7169,11 @@
           <a:p>
             <a:pPr algn="r"/>
             <a:r>
-              <a:rPr sz="1100" b="1" i="0">
+              <a:rPr sz="1000" b="0" i="0">
                 <a:solidFill>
                   <a:srgbClr val="7A808A"/>
                 </a:solidFill>
-                <a:latin typeface="Calibri"/>
+                <a:latin typeface="Arial Black"/>
               </a:rPr>
               <a:t>VentureHack 2026  ·  Трек 2 — EduTech</a:t>
             </a:r>
@@ -7503,11 +7503,11 @@
           <a:p>
             <a:pPr algn="l"/>
             <a:r>
-              <a:rPr sz="1600" b="1" i="0">
+              <a:rPr sz="1400" b="0" i="0">
                 <a:solidFill>
                   <a:srgbClr val="0B4DA2"/>
                 </a:solidFill>
-                <a:latin typeface="Calibri"/>
+                <a:latin typeface="Arial Black"/>
               </a:rPr>
               <a:t>Tamyr</a:t>
             </a:r>
@@ -7798,7 +7798,7 @@
           <a:p>
             <a:pPr algn="ctr"/>
             <a:r>
-              <a:rPr sz="1800" b="1">
+              <a:rPr sz="1600" b="0">
                 <a:solidFill>
                   <a:srgbClr val="FFFFFF"/>
                 </a:solidFill>
@@ -7833,11 +7833,11 @@
           <a:p>
             <a:pPr algn="l"/>
             <a:r>
-              <a:rPr sz="1800" b="1" i="0">
+              <a:rPr sz="1600" b="0" i="0">
                 <a:solidFill>
                   <a:srgbClr val="0B4DA2"/>
                 </a:solidFill>
-                <a:latin typeface="Calibri"/>
+                <a:latin typeface="Arial Black"/>
               </a:rPr>
               <a:t>Сейчас</a:t>
             </a:r>
@@ -7868,11 +7868,11 @@
           <a:p>
             <a:pPr algn="l"/>
             <a:r>
-              <a:rPr sz="1400" b="0" i="0">
+              <a:rPr sz="1200" b="0" i="0">
                 <a:solidFill>
                   <a:srgbClr val="4A4F57"/>
                 </a:solidFill>
-                <a:latin typeface="Calibri"/>
+                <a:latin typeface="Arial Black"/>
               </a:rPr>
               <a:t>MVP: 17 тем, 102 задания, 43 ошибки мышления, панель учителя</a:t>
             </a:r>
@@ -7926,7 +7926,7 @@
           <a:p>
             <a:pPr algn="ctr"/>
             <a:r>
-              <a:rPr sz="1800" b="1">
+              <a:rPr sz="1600" b="0">
                 <a:solidFill>
                   <a:srgbClr val="0B4DA2"/>
                 </a:solidFill>
@@ -7961,11 +7961,11 @@
           <a:p>
             <a:pPr algn="l"/>
             <a:r>
-              <a:rPr sz="1800" b="1" i="0">
+              <a:rPr sz="1600" b="0" i="0">
                 <a:solidFill>
                   <a:srgbClr val="0B4DA2"/>
                 </a:solidFill>
-                <a:latin typeface="Calibri"/>
+                <a:latin typeface="Arial Black"/>
               </a:rPr>
               <a:t>1 месяц</a:t>
             </a:r>
@@ -7996,11 +7996,11 @@
           <a:p>
             <a:pPr algn="l"/>
             <a:r>
-              <a:rPr sz="1400" b="0" i="0">
+              <a:rPr sz="1200" b="0" i="0">
                 <a:solidFill>
                   <a:srgbClr val="4A4F57"/>
                 </a:solidFill>
-                <a:latin typeface="Calibri"/>
+                <a:latin typeface="Arial Black"/>
               </a:rPr>
               <a:t>Пилот в 2–3 классах, казахский язык</a:t>
             </a:r>
@@ -8054,7 +8054,7 @@
           <a:p>
             <a:pPr algn="ctr"/>
             <a:r>
-              <a:rPr sz="1800" b="1">
+              <a:rPr sz="1600" b="0">
                 <a:solidFill>
                   <a:srgbClr val="0B4DA2"/>
                 </a:solidFill>
@@ -8089,11 +8089,11 @@
           <a:p>
             <a:pPr algn="l"/>
             <a:r>
-              <a:rPr sz="1800" b="1" i="0">
+              <a:rPr sz="1600" b="0" i="0">
                 <a:solidFill>
                   <a:srgbClr val="0B4DA2"/>
                 </a:solidFill>
-                <a:latin typeface="Calibri"/>
+                <a:latin typeface="Arial Black"/>
               </a:rPr>
               <a:t>3 месяца</a:t>
             </a:r>
@@ -8124,11 +8124,11 @@
           <a:p>
             <a:pPr algn="l"/>
             <a:r>
-              <a:rPr sz="1400" b="0" i="0">
+              <a:rPr sz="1200" b="0" i="0">
                 <a:solidFill>
                   <a:srgbClr val="4A4F57"/>
                 </a:solidFill>
-                <a:latin typeface="Calibri"/>
+                <a:latin typeface="Arial Black"/>
               </a:rPr>
               <a:t>Байесовская модель освоения, 10+ вопросов на тему</a:t>
             </a:r>
@@ -8182,7 +8182,7 @@
           <a:p>
             <a:pPr algn="ctr"/>
             <a:r>
-              <a:rPr sz="1800" b="1">
+              <a:rPr sz="1600" b="0">
                 <a:solidFill>
                   <a:srgbClr val="0B4DA2"/>
                 </a:solidFill>
@@ -8217,11 +8217,11 @@
           <a:p>
             <a:pPr algn="l"/>
             <a:r>
-              <a:rPr sz="1800" b="1" i="0">
+              <a:rPr sz="1600" b="0" i="0">
                 <a:solidFill>
                   <a:srgbClr val="0B4DA2"/>
                 </a:solidFill>
-                <a:latin typeface="Calibri"/>
+                <a:latin typeface="Arial Black"/>
               </a:rPr>
               <a:t>6 месяцев</a:t>
             </a:r>
@@ -8252,11 +8252,11 @@
           <a:p>
             <a:pPr algn="l"/>
             <a:r>
-              <a:rPr sz="1400" b="0" i="0">
+              <a:rPr sz="1200" b="0" i="0">
                 <a:solidFill>
                   <a:srgbClr val="4A4F57"/>
                 </a:solidFill>
-                <a:latin typeface="Calibri"/>
+                <a:latin typeface="Arial Black"/>
               </a:rPr>
               <a:t>Геометрия и мат. грамотность ЕНТ, вход по коду класса</a:t>
             </a:r>
@@ -8287,11 +8287,11 @@
           <a:p>
             <a:pPr algn="l"/>
             <a:r>
-              <a:rPr sz="1700" b="1" i="0">
+              <a:rPr sz="1500" b="0" i="0">
                 <a:solidFill>
                   <a:srgbClr val="111111"/>
                 </a:solidFill>
-                <a:latin typeface="Calibri"/>
+                <a:latin typeface="Arial Black"/>
               </a:rPr>
               <a:t>Команда: [Имя — роль] · [Имя — роль] · [Имя — роль]</a:t>
             </a:r>
@@ -8322,11 +8322,11 @@
           <a:p>
             <a:pPr algn="l"/>
             <a:r>
-              <a:rPr sz="1400" b="0" i="0">
+              <a:rPr sz="1200" b="0" i="0">
                 <a:solidFill>
                   <a:srgbClr val="4A4F57"/>
                 </a:solidFill>
-                <a:latin typeface="Calibri"/>
+                <a:latin typeface="Arial Black"/>
               </a:rPr>
               <a:t>GitHub: [ссылка на репозиторий]   ·   Демо: [ссылка на GitHub Pages]</a:t>
             </a:r>
@@ -8375,11 +8375,11 @@
           <a:p>
             <a:pPr algn="ctr"/>
             <a:r>
-              <a:rPr sz="1400" b="1">
+              <a:rPr sz="1200" b="0">
                 <a:solidFill>
                   <a:srgbClr val="FFFFFF"/>
                 </a:solidFill>
-                <a:latin typeface="Calibri"/>
+                <a:latin typeface="Arial Black"/>
               </a:rPr>
               <a:t>Спасибо!</a:t>
             </a:r>
@@ -8740,11 +8740,11 @@
           <a:p>
             <a:pPr algn="l"/>
             <a:r>
-              <a:rPr sz="1600" b="1" i="0">
+              <a:rPr sz="1400" b="0" i="0">
                 <a:solidFill>
                   <a:srgbClr val="0B4DA2"/>
                 </a:solidFill>
-                <a:latin typeface="Calibri"/>
+                <a:latin typeface="Arial Black"/>
               </a:rPr>
               <a:t>Tamyr</a:t>
             </a:r>
@@ -8850,20 +8850,20 @@
               </a:spcAft>
             </a:pPr>
             <a:r>
-              <a:rPr sz="1700" b="1" i="0">
+              <a:rPr sz="1500" b="0" i="0">
                 <a:solidFill>
                   <a:srgbClr val="0B4DA2"/>
                 </a:solidFill>
-                <a:latin typeface="Calibri"/>
+                <a:latin typeface="Arial Black"/>
               </a:rPr>
               <a:t>Пример: </a:t>
             </a:r>
             <a:r>
-              <a:rPr sz="1700" b="1" i="0">
+              <a:rPr sz="1500" b="0" i="0">
                 <a:solidFill>
                   <a:srgbClr val="4A4F57"/>
                 </a:solidFill>
-                <a:latin typeface="Calibri"/>
+                <a:latin typeface="Arial Black"/>
               </a:rPr>
               <a:t>ученица готовится к ЕНТ и ошибается в квадратных уравнениях.</a:t>
             </a:r>
@@ -8875,11 +8875,11 @@
               </a:spcAft>
             </a:pPr>
             <a:r>
-              <a:rPr sz="1700" b="0" i="0">
+              <a:rPr sz="1500" b="0" i="0">
                 <a:solidFill>
                   <a:srgbClr val="4A4F57"/>
                 </a:solidFill>
-                <a:latin typeface="Calibri"/>
+                <a:latin typeface="Arial Black"/>
               </a:rPr>
               <a:t>Пробник советует: «Повторите квадратные уравнения». Она повторяет, а ошибки остаются.</a:t>
             </a:r>
@@ -8891,29 +8891,29 @@
               </a:spcAft>
             </a:pPr>
             <a:r>
-              <a:rPr sz="1700" b="0" i="0">
+              <a:rPr sz="1500" b="0" i="0">
                 <a:solidFill>
                   <a:srgbClr val="4A4F57"/>
                 </a:solidFill>
-                <a:latin typeface="Calibri"/>
+                <a:latin typeface="Arial Black"/>
               </a:rPr>
               <a:t>Настоящая причина лежит на три темы ниже: </a:t>
             </a:r>
             <a:r>
-              <a:rPr sz="1700" b="1" i="0">
+              <a:rPr sz="1500" b="0" i="0">
                 <a:solidFill>
                   <a:srgbClr val="E0473E"/>
                 </a:solidFill>
-                <a:latin typeface="Calibri"/>
+                <a:latin typeface="Arial Black"/>
               </a:rPr>
               <a:t>она неверно складывает дроби</a:t>
             </a:r>
             <a:r>
-              <a:rPr sz="1700" b="0" i="0">
+              <a:rPr sz="1500" b="0" i="0">
                 <a:solidFill>
                   <a:srgbClr val="4A4F57"/>
                 </a:solidFill>
-                <a:latin typeface="Calibri"/>
+                <a:latin typeface="Arial Black"/>
               </a:rPr>
               <a:t> — это материал 6 класса.</a:t>
             </a:r>
@@ -8925,11 +8925,11 @@
               </a:spcAft>
             </a:pPr>
             <a:r>
-              <a:rPr sz="1700" b="1" i="0">
+              <a:rPr sz="1500" b="0" i="0">
                 <a:solidFill>
                   <a:srgbClr val="0B4DA2"/>
                 </a:solidFill>
-                <a:latin typeface="Calibri"/>
+                <a:latin typeface="Arial Black"/>
               </a:rPr>
               <a:t>Тест показывает симптом, но не диагноз.</a:t>
             </a:r>
@@ -8983,11 +8983,11 @@
           <a:p>
             <a:pPr algn="ctr"/>
             <a:r>
-              <a:rPr sz="1900" b="1">
+              <a:rPr sz="1700" b="0">
                 <a:solidFill>
                   <a:srgbClr val="0B4DA2"/>
                 </a:solidFill>
-                <a:latin typeface="Calibri"/>
+                <a:latin typeface="Arial Black"/>
               </a:rPr>
               <a:t>Квадратные уравнения</a:t>
             </a:r>
@@ -9018,11 +9018,11 @@
           <a:p>
             <a:pPr algn="ctr"/>
             <a:r>
-              <a:rPr sz="1200" b="0" i="1">
+              <a:rPr sz="1100" b="0" i="1">
                 <a:solidFill>
                   <a:srgbClr val="4A4F57"/>
                 </a:solidFill>
-                <a:latin typeface="Calibri"/>
+                <a:latin typeface="Arial Black"/>
               </a:rPr>
               <a:t>ошибка видна здесь</a:t>
             </a:r>
@@ -9112,11 +9112,11 @@
           <a:p>
             <a:pPr algn="ctr"/>
             <a:r>
-              <a:rPr sz="1900" b="1">
+              <a:rPr sz="1700" b="0">
                 <a:solidFill>
                   <a:srgbClr val="0B4DA2"/>
                 </a:solidFill>
-                <a:latin typeface="Calibri"/>
+                <a:latin typeface="Arial Black"/>
               </a:rPr>
               <a:t>Линейные уравнения</a:t>
             </a:r>
@@ -9147,11 +9147,11 @@
           <a:p>
             <a:pPr algn="ctr"/>
             <a:r>
-              <a:rPr sz="1200" b="0" i="1">
+              <a:rPr sz="1100" b="0" i="1">
                 <a:solidFill>
                   <a:srgbClr val="4A4F57"/>
                 </a:solidFill>
-                <a:latin typeface="Calibri"/>
+                <a:latin typeface="Arial Black"/>
               </a:rPr>
               <a:t>ошибка тянется отсюда</a:t>
             </a:r>
@@ -9241,11 +9241,11 @@
           <a:p>
             <a:pPr algn="ctr"/>
             <a:r>
-              <a:rPr sz="1900" b="1">
+              <a:rPr sz="1700" b="0">
                 <a:solidFill>
                   <a:srgbClr val="FFFFFF"/>
                 </a:solidFill>
-                <a:latin typeface="Calibri"/>
+                <a:latin typeface="Arial Black"/>
               </a:rPr>
               <a:t>Действия с дробями</a:t>
             </a:r>
@@ -9276,11 +9276,11 @@
           <a:p>
             <a:pPr algn="ctr"/>
             <a:r>
-              <a:rPr sz="1200" b="0" i="1">
+              <a:rPr sz="1100" b="0" i="1">
                 <a:solidFill>
                   <a:srgbClr val="4A4F57"/>
                 </a:solidFill>
-                <a:latin typeface="Calibri"/>
+                <a:latin typeface="Arial Black"/>
               </a:rPr>
               <a:t>корень проблемы</a:t>
             </a:r>
@@ -9311,11 +9311,11 @@
           <a:p>
             <a:pPr algn="r"/>
             <a:r>
-              <a:rPr sz="1100" b="1" i="0">
+              <a:rPr sz="1000" b="0" i="0">
                 <a:solidFill>
                   <a:srgbClr val="7A808A"/>
                 </a:solidFill>
-                <a:latin typeface="Calibri"/>
+                <a:latin typeface="Arial Black"/>
               </a:rPr>
               <a:t>VentureHack 2026  ·  Трек 2 — EduTech</a:t>
             </a:r>
@@ -9629,11 +9629,11 @@
           <a:p>
             <a:pPr algn="l"/>
             <a:r>
-              <a:rPr sz="1600" b="1" i="0">
+              <a:rPr sz="1400" b="0" i="0">
                 <a:solidFill>
                   <a:srgbClr val="0B4DA2"/>
                 </a:solidFill>
-                <a:latin typeface="Calibri"/>
+                <a:latin typeface="Arial Black"/>
               </a:rPr>
               <a:t>Tamyr</a:t>
             </a:r>
@@ -9803,7 +9803,7 @@
           <a:p>
             <a:pPr algn="ctr"/>
             <a:r>
-              <a:rPr sz="2200" b="1">
+              <a:rPr sz="2200" b="0">
                 <a:solidFill>
                   <a:srgbClr val="FFFFFF"/>
                 </a:solidFill>
@@ -9838,11 +9838,11 @@
           <a:p>
             <a:pPr algn="l"/>
             <a:r>
-              <a:rPr sz="1900" b="1" i="0">
+              <a:rPr sz="1700" b="0" i="0">
                 <a:solidFill>
                   <a:srgbClr val="0B4DA2"/>
                 </a:solidFill>
-                <a:latin typeface="Calibri"/>
+                <a:latin typeface="Arial Black"/>
               </a:rPr>
               <a:t>Математика кумулятивна</a:t>
             </a:r>
@@ -9873,11 +9873,11 @@
           <a:p>
             <a:pPr algn="l"/>
             <a:r>
-              <a:rPr sz="1500" b="0" i="0">
+              <a:rPr sz="1300" b="0" i="0">
                 <a:solidFill>
                   <a:srgbClr val="4A4F57"/>
                 </a:solidFill>
-                <a:latin typeface="Calibri"/>
+                <a:latin typeface="Arial Black"/>
               </a:rPr>
               <a:t>Каждая тема держится на предыдущих. Пробел в базовой теме всплывает позже — в теме, которая на ней держится.</a:t>
             </a:r>
@@ -9977,7 +9977,7 @@
           <a:p>
             <a:pPr algn="ctr"/>
             <a:r>
-              <a:rPr sz="2200" b="1">
+              <a:rPr sz="2200" b="0">
                 <a:solidFill>
                   <a:srgbClr val="FFFFFF"/>
                 </a:solidFill>
@@ -10012,11 +10012,11 @@
           <a:p>
             <a:pPr algn="l"/>
             <a:r>
-              <a:rPr sz="1900" b="1" i="0">
+              <a:rPr sz="1700" b="0" i="0">
                 <a:solidFill>
                   <a:srgbClr val="0B4DA2"/>
                 </a:solidFill>
-                <a:latin typeface="Calibri"/>
+                <a:latin typeface="Arial Black"/>
               </a:rPr>
               <a:t>Тесты измеряют балл</a:t>
             </a:r>
@@ -10047,11 +10047,11 @@
           <a:p>
             <a:pPr algn="l"/>
             <a:r>
-              <a:rPr sz="1500" b="0" i="0">
+              <a:rPr sz="1300" b="0" i="0">
                 <a:solidFill>
                   <a:srgbClr val="4A4F57"/>
                 </a:solidFill>
-                <a:latin typeface="Calibri"/>
+                <a:latin typeface="Arial Black"/>
               </a:rPr>
               <a:t>Пробники и контрольные говорят, где ошибка произошла, но не почему. Выбранный неверный вариант не анализируется.</a:t>
             </a:r>
@@ -10151,7 +10151,7 @@
           <a:p>
             <a:pPr algn="ctr"/>
             <a:r>
-              <a:rPr sz="2200" b="1">
+              <a:rPr sz="2200" b="0">
                 <a:solidFill>
                   <a:srgbClr val="FFFFFF"/>
                 </a:solidFill>
@@ -10186,11 +10186,11 @@
           <a:p>
             <a:pPr algn="l"/>
             <a:r>
-              <a:rPr sz="1900" b="1" i="0">
+              <a:rPr sz="1700" b="0" i="0">
                 <a:solidFill>
                   <a:srgbClr val="0B4DA2"/>
                 </a:solidFill>
-                <a:latin typeface="Calibri"/>
+                <a:latin typeface="Arial Black"/>
               </a:rPr>
               <a:t>У учителя нет времени</a:t>
             </a:r>
@@ -10221,11 +10221,11 @@
           <a:p>
             <a:pPr algn="l"/>
             <a:r>
-              <a:rPr sz="1500" b="0" i="0">
+              <a:rPr sz="1300" b="0" i="0">
                 <a:solidFill>
                   <a:srgbClr val="4A4F57"/>
                 </a:solidFill>
-                <a:latin typeface="Calibri"/>
+                <a:latin typeface="Arial Black"/>
               </a:rPr>
               <a:t>В классе 25–30 учеников. Индивидуально проверить каждого по всем темам с 5 по 9 класс невозможно.</a:t>
             </a:r>
@@ -10256,20 +10256,20 @@
           <a:p>
             <a:pPr algn="l"/>
             <a:r>
-              <a:rPr sz="1300" b="1" i="0">
+              <a:rPr sz="1100" b="0" i="0">
                 <a:solidFill>
                   <a:srgbClr val="E0473E"/>
                 </a:solidFill>
-                <a:latin typeface="Calibri"/>
+                <a:latin typeface="Arial Black"/>
               </a:rPr>
               <a:t>Место для вашей цифры из опроса: </a:t>
             </a:r>
             <a:r>
-              <a:rPr sz="1300" b="0" i="0">
+              <a:rPr sz="1100" b="0" i="0">
                 <a:solidFill>
                   <a:srgbClr val="4A4F57"/>
                 </a:solidFill>
-                <a:latin typeface="Calibri"/>
+                <a:latin typeface="Arial Black"/>
               </a:rPr>
               <a:t>«__% учеников не понимают, почему ошиблись в пробнике» (n = __). Заполните по docs/validation-plan.md или удалите строку.</a:t>
             </a:r>
@@ -10762,11 +10762,11 @@
           <a:p>
             <a:pPr algn="l"/>
             <a:r>
-              <a:rPr sz="1600" b="1" i="0">
+              <a:rPr sz="1400" b="0" i="0">
                 <a:solidFill>
                   <a:srgbClr val="0B4DA2"/>
                 </a:solidFill>
-                <a:latin typeface="Calibri"/>
+                <a:latin typeface="Arial Black"/>
               </a:rPr>
               <a:t>Tamyr</a:t>
             </a:r>
@@ -10926,7 +10926,7 @@
           <a:p>
             <a:pPr algn="ctr"/>
             <a:r>
-              <a:rPr sz="2200" b="1">
+              <a:rPr sz="2200" b="0">
                 <a:solidFill>
                   <a:srgbClr val="FFFFFF"/>
                 </a:solidFill>
@@ -10961,11 +10961,11 @@
           <a:p>
             <a:pPr algn="l"/>
             <a:r>
-              <a:rPr sz="1900" b="1" i="0">
+              <a:rPr sz="1700" b="0" i="0">
                 <a:solidFill>
                   <a:srgbClr val="0B4DA2"/>
                 </a:solidFill>
-                <a:latin typeface="Calibri"/>
+                <a:latin typeface="Arial Black"/>
               </a:rPr>
               <a:t>Адаптивная диагностика</a:t>
             </a:r>
@@ -10996,11 +10996,11 @@
           <a:p>
             <a:pPr algn="l"/>
             <a:r>
-              <a:rPr sz="1500" b="0" i="0">
+              <a:rPr sz="1300" b="0" i="0">
                 <a:solidFill>
                   <a:srgbClr val="4A4F57"/>
                 </a:solidFill>
-                <a:latin typeface="Calibri"/>
+                <a:latin typeface="Arial Black"/>
               </a:rPr>
               <a:t>Начинаем со сложной темы и спускаемся по графу из 17 тем только там, где есть ошибки. Без пробелов — около 9 вопросов.</a:t>
             </a:r>
@@ -11090,7 +11090,7 @@
           <a:p>
             <a:pPr algn="ctr"/>
             <a:r>
-              <a:rPr sz="2200" b="1">
+              <a:rPr sz="2200" b="0">
                 <a:solidFill>
                   <a:srgbClr val="FFFFFF"/>
                 </a:solidFill>
@@ -11125,11 +11125,11 @@
           <a:p>
             <a:pPr algn="l"/>
             <a:r>
-              <a:rPr sz="1900" b="1" i="0">
+              <a:rPr sz="1700" b="0" i="0">
                 <a:solidFill>
                   <a:srgbClr val="0B4DA2"/>
                 </a:solidFill>
-                <a:latin typeface="Calibri"/>
+                <a:latin typeface="Arial Black"/>
               </a:rPr>
               <a:t>Карта знаний</a:t>
             </a:r>
@@ -11160,11 +11160,11 @@
           <a:p>
             <a:pPr algn="l"/>
             <a:r>
-              <a:rPr sz="1500" b="0" i="0">
+              <a:rPr sz="1300" b="0" i="0">
                 <a:solidFill>
                   <a:srgbClr val="4A4F57"/>
                 </a:solidFill>
-                <a:latin typeface="Calibri"/>
+                <a:latin typeface="Arial Black"/>
               </a:rPr>
               <a:t>Корневой пробел, цепочки «ошибка в X → корень в Y» и ошибки мышления по выбранным неверным ответам.</a:t>
             </a:r>
@@ -11254,7 +11254,7 @@
           <a:p>
             <a:pPr algn="ctr"/>
             <a:r>
-              <a:rPr sz="2200" b="1">
+              <a:rPr sz="2200" b="0">
                 <a:solidFill>
                   <a:srgbClr val="FFFFFF"/>
                 </a:solidFill>
@@ -11289,11 +11289,11 @@
           <a:p>
             <a:pPr algn="l"/>
             <a:r>
-              <a:rPr sz="1900" b="1" i="0">
+              <a:rPr sz="1700" b="0" i="0">
                 <a:solidFill>
                   <a:srgbClr val="0B4DA2"/>
                 </a:solidFill>
-                <a:latin typeface="Calibri"/>
+                <a:latin typeface="Arial Black"/>
               </a:rPr>
               <a:t>План снизу вверх</a:t>
             </a:r>
@@ -11324,11 +11324,11 @@
           <a:p>
             <a:pPr algn="l"/>
             <a:r>
-              <a:rPr sz="1500" b="0" i="0">
+              <a:rPr sz="1300" b="0" i="0">
                 <a:solidFill>
                   <a:srgbClr val="4A4F57"/>
                 </a:solidFill>
-                <a:latin typeface="Calibri"/>
+                <a:latin typeface="Arial Black"/>
               </a:rPr>
               <a:t>Правило, пример, разбор своей ошибки и 2 новые проверочные задачи. Следующая тема — после корня.</a:t>
             </a:r>
@@ -11382,7 +11382,7 @@
           <a:p>
             <a:pPr algn="ctr"/>
             <a:r>
-              <a:rPr sz="2200" b="1">
+              <a:rPr sz="2200" b="0">
                 <a:solidFill>
                   <a:srgbClr val="FFFFFF"/>
                 </a:solidFill>
@@ -11417,11 +11417,11 @@
           <a:p>
             <a:pPr algn="l"/>
             <a:r>
-              <a:rPr sz="1900" b="1" i="0">
+              <a:rPr sz="1700" b="0" i="0">
                 <a:solidFill>
                   <a:srgbClr val="111111"/>
                 </a:solidFill>
-                <a:latin typeface="Calibri"/>
+                <a:latin typeface="Arial Black"/>
               </a:rPr>
               <a:t>Панель учителя</a:t>
             </a:r>
@@ -11452,11 +11452,11 @@
           <a:p>
             <a:pPr algn="l"/>
             <a:r>
-              <a:rPr sz="1500" b="0" i="0">
+              <a:rPr sz="1300" b="0" i="0">
                 <a:solidFill>
                   <a:srgbClr val="4A4F57"/>
                 </a:solidFill>
-                <a:latin typeface="Calibri"/>
+                <a:latin typeface="Arial Black"/>
               </a:rPr>
               <a:t>Корни всего класса, частые ошибки, готовые мини-группы, тепловая карта и CSV.</a:t>
             </a:r>
@@ -11505,11 +11505,11 @@
           <a:p>
             <a:pPr algn="ctr"/>
             <a:r>
-              <a:rPr sz="1400" b="1">
+              <a:rPr sz="1200" b="0">
                 <a:solidFill>
                   <a:srgbClr val="FFFFFF"/>
                 </a:solidFill>
-                <a:latin typeface="Calibri"/>
+                <a:latin typeface="Arial Black"/>
               </a:rPr>
               <a:t>Работает в браузере на любом телефоне — без установки, регистрации и сервера</a:t>
             </a:r>
@@ -11540,11 +11540,11 @@
           <a:p>
             <a:pPr algn="r"/>
             <a:r>
-              <a:rPr sz="1100" b="1" i="0">
+              <a:rPr sz="1000" b="0" i="0">
                 <a:solidFill>
                   <a:srgbClr val="7A808A"/>
                 </a:solidFill>
-                <a:latin typeface="Calibri"/>
+                <a:latin typeface="Arial Black"/>
               </a:rPr>
               <a:t>VentureHack 2026  ·  Трек 2 — EduTech</a:t>
             </a:r>
@@ -11858,11 +11858,11 @@
           <a:p>
             <a:pPr algn="l"/>
             <a:r>
-              <a:rPr sz="1600" b="1" i="0">
+              <a:rPr sz="1400" b="0" i="0">
                 <a:solidFill>
                   <a:srgbClr val="0B4DA2"/>
                 </a:solidFill>
-                <a:latin typeface="Calibri"/>
+                <a:latin typeface="Arial Black"/>
               </a:rPr>
               <a:t>Tamyr</a:t>
             </a:r>
@@ -12202,11 +12202,11 @@
           <a:p>
             <a:pPr algn="ctr"/>
             <a:r>
-              <a:rPr sz="1200" b="1">
+              <a:rPr sz="1000" b="0">
                 <a:solidFill>
                   <a:srgbClr val="111111"/>
                 </a:solidFill>
-                <a:latin typeface="Calibri"/>
+                <a:latin typeface="Arial Black"/>
               </a:rPr>
               <a:t>Кв. уравнения</a:t>
             </a:r>
@@ -12260,11 +12260,11 @@
           <a:p>
             <a:pPr algn="ctr"/>
             <a:r>
-              <a:rPr sz="1200" b="1">
+              <a:rPr sz="1000" b="0">
                 <a:solidFill>
                   <a:srgbClr val="FFFFFF"/>
                 </a:solidFill>
-                <a:latin typeface="Calibri"/>
+                <a:latin typeface="Arial Black"/>
               </a:rPr>
               <a:t>Разложение</a:t>
             </a:r>
@@ -12318,11 +12318,11 @@
           <a:p>
             <a:pPr algn="ctr"/>
             <a:r>
-              <a:rPr sz="1200" b="1">
+              <a:rPr sz="1000" b="0">
                 <a:solidFill>
                   <a:srgbClr val="111111"/>
                 </a:solidFill>
-                <a:latin typeface="Calibri"/>
+                <a:latin typeface="Arial Black"/>
               </a:rPr>
               <a:t>Лин. уравнения</a:t>
             </a:r>
@@ -12376,11 +12376,11 @@
           <a:p>
             <a:pPr algn="ctr"/>
             <a:r>
-              <a:rPr sz="1200" b="1">
+              <a:rPr sz="1000" b="0">
                 <a:solidFill>
                   <a:srgbClr val="FFFFFF"/>
                 </a:solidFill>
-                <a:latin typeface="Calibri"/>
+                <a:latin typeface="Arial Black"/>
               </a:rPr>
               <a:t>Корни</a:t>
             </a:r>
@@ -12434,11 +12434,11 @@
           <a:p>
             <a:pPr algn="ctr"/>
             <a:r>
-              <a:rPr sz="1200" b="1">
+              <a:rPr sz="1000" b="0">
                 <a:solidFill>
                   <a:srgbClr val="FFFFFF"/>
                 </a:solidFill>
-                <a:latin typeface="Calibri"/>
+                <a:latin typeface="Arial Black"/>
               </a:rPr>
               <a:t>Выражения</a:t>
             </a:r>
@@ -12492,11 +12492,11 @@
           <a:p>
             <a:pPr algn="ctr"/>
             <a:r>
-              <a:rPr sz="1200" b="1">
+              <a:rPr sz="1000" b="0">
                 <a:solidFill>
                   <a:srgbClr val="FFFFFF"/>
                 </a:solidFill>
-                <a:latin typeface="Calibri"/>
+                <a:latin typeface="Arial Black"/>
               </a:rPr>
               <a:t>Дроби</a:t>
             </a:r>
@@ -12550,11 +12550,11 @@
           <a:p>
             <a:pPr algn="ctr"/>
             <a:r>
-              <a:rPr sz="1200" b="1">
+              <a:rPr sz="1000" b="0">
                 <a:solidFill>
                   <a:srgbClr val="082F66"/>
                 </a:solidFill>
-                <a:latin typeface="Calibri"/>
+                <a:latin typeface="Arial Black"/>
               </a:rPr>
               <a:t>Арифметика</a:t>
             </a:r>
@@ -12585,11 +12585,11 @@
           <a:p>
             <a:pPr algn="l"/>
             <a:r>
-              <a:rPr sz="1100" b="0" i="1">
+              <a:rPr sz="1000" b="0" i="1">
                 <a:solidFill>
                   <a:srgbClr val="7A808A"/>
                 </a:solidFill>
-                <a:latin typeface="Calibri"/>
+                <a:latin typeface="Arial Black"/>
               </a:rPr>
               <a:t>Синий — освоено, красный — пробел, насыщенный красный — корень</a:t>
             </a:r>
@@ -12667,11 +12667,11 @@
           <a:p>
             <a:pPr algn="l"/>
             <a:r>
-              <a:rPr sz="1700" b="1" i="0">
+              <a:rPr sz="1500" b="0" i="0">
                 <a:solidFill>
                   <a:srgbClr val="111111"/>
                 </a:solidFill>
-                <a:latin typeface="Calibri"/>
+                <a:latin typeface="Arial Black"/>
               </a:rPr>
               <a:t>Решил тему без ошибок</a:t>
             </a:r>
@@ -12702,11 +12702,11 @@
           <a:p>
             <a:pPr algn="l"/>
             <a:r>
-              <a:rPr sz="1400" b="0" i="0">
+              <a:rPr sz="1200" b="0" i="0">
                 <a:solidFill>
                   <a:srgbClr val="4A4F57"/>
                 </a:solidFill>
-                <a:latin typeface="Calibri"/>
+                <a:latin typeface="Arial Black"/>
               </a:rPr>
               <a:t>всё, на чём она держится, засчитано без вопросов</a:t>
             </a:r>
@@ -12784,11 +12784,11 @@
           <a:p>
             <a:pPr algn="l"/>
             <a:r>
-              <a:rPr sz="1700" b="1" i="0">
+              <a:rPr sz="1500" b="0" i="0">
                 <a:solidFill>
                   <a:srgbClr val="111111"/>
                 </a:solidFill>
-                <a:latin typeface="Calibri"/>
+                <a:latin typeface="Arial Black"/>
               </a:rPr>
               <a:t>Ошибся дважды</a:t>
             </a:r>
@@ -12819,11 +12819,11 @@
           <a:p>
             <a:pPr algn="l"/>
             <a:r>
-              <a:rPr sz="1400" b="0" i="0">
+              <a:rPr sz="1200" b="0" i="0">
                 <a:solidFill>
                   <a:srgbClr val="4A4F57"/>
                 </a:solidFill>
-                <a:latin typeface="Calibri"/>
+                <a:latin typeface="Arial Black"/>
               </a:rPr>
               <a:t>спускаемся к непроверенным пререквизитам</a:t>
             </a:r>
@@ -12901,11 +12901,11 @@
           <a:p>
             <a:pPr algn="l"/>
             <a:r>
-              <a:rPr sz="1700" b="1" i="0">
+              <a:rPr sz="1500" b="0" i="0">
                 <a:solidFill>
                   <a:srgbClr val="111111"/>
                 </a:solidFill>
-                <a:latin typeface="Calibri"/>
+                <a:latin typeface="Arial Black"/>
               </a:rPr>
               <a:t>Неверный вариант с меткой</a:t>
             </a:r>
@@ -12936,11 +12936,11 @@
           <a:p>
             <a:pPr algn="l"/>
             <a:r>
-              <a:rPr sz="1400" b="0" i="0">
+              <a:rPr sz="1200" b="0" i="0">
                 <a:solidFill>
                   <a:srgbClr val="4A4F57"/>
                 </a:solidFill>
-                <a:latin typeface="Calibri"/>
+                <a:latin typeface="Arial Black"/>
               </a:rPr>
               <a:t>сначала проверяем «домашнюю» тему этой ошибки</a:t>
             </a:r>
@@ -13018,11 +13018,11 @@
           <a:p>
             <a:pPr algn="l"/>
             <a:r>
-              <a:rPr sz="1700" b="1" i="0">
+              <a:rPr sz="1500" b="0" i="0">
                 <a:solidFill>
                   <a:srgbClr val="111111"/>
                 </a:solidFill>
-                <a:latin typeface="Calibri"/>
+                <a:latin typeface="Arial Black"/>
               </a:rPr>
               <a:t>Корень</a:t>
             </a:r>
@@ -13053,11 +13053,11 @@
           <a:p>
             <a:pPr algn="l"/>
             <a:r>
-              <a:rPr sz="1400" b="0" i="0">
+              <a:rPr sz="1200" b="0" i="0">
                 <a:solidFill>
                   <a:srgbClr val="4A4F57"/>
                 </a:solidFill>
-                <a:latin typeface="Calibri"/>
+                <a:latin typeface="Arial Black"/>
               </a:rPr>
               <a:t>= пробел, под которым пробелов нет</a:t>
             </a:r>
@@ -13132,20 +13132,20 @@
           <a:p>
             <a:pPr algn="l"/>
             <a:r>
-              <a:rPr sz="1700" b="1" i="0">
+              <a:rPr sz="1500" b="0" i="0">
                 <a:solidFill>
                   <a:srgbClr val="E0473E"/>
                 </a:solidFill>
-                <a:latin typeface="Calibri"/>
+                <a:latin typeface="Arial Black"/>
               </a:rPr>
               <a:t>1/2 + 1/3 = 2/5</a:t>
             </a:r>
             <a:r>
-              <a:rPr sz="1300" b="1" i="0">
+              <a:rPr sz="1100" b="0" i="0">
                 <a:solidFill>
                   <a:srgbClr val="111111"/>
                 </a:solidFill>
-                <a:latin typeface="Calibri"/>
+                <a:latin typeface="Arial Black"/>
               </a:rPr>
               <a:t>  →  «складывает числители и знаменатели»</a:t>
             </a:r>
@@ -13153,11 +13153,11 @@
           <a:p>
             <a:pPr algn="l"/>
             <a:r>
-              <a:rPr sz="1300" b="0" i="0">
+              <a:rPr sz="1100" b="0" i="0">
                 <a:solidFill>
                   <a:srgbClr val="4A4F57"/>
                 </a:solidFill>
-                <a:latin typeface="Calibri"/>
+                <a:latin typeface="Arial Black"/>
               </a:rPr>
               <a:t>Такой ответ сразу отправляет проверку в тему «Дроби».</a:t>
             </a:r>
@@ -13518,11 +13518,11 @@
           <a:p>
             <a:pPr algn="l"/>
             <a:r>
-              <a:rPr sz="1600" b="1" i="0">
+              <a:rPr sz="1400" b="0" i="0">
                 <a:solidFill>
                   <a:srgbClr val="0B4DA2"/>
                 </a:solidFill>
-                <a:latin typeface="Calibri"/>
+                <a:latin typeface="Arial Black"/>
               </a:rPr>
               <a:t>Tamyr</a:t>
             </a:r>
@@ -13700,11 +13700,11 @@
           <a:p>
             <a:pPr algn="l"/>
             <a:r>
-              <a:rPr sz="1800" b="1" i="0">
+              <a:rPr sz="1600" b="0" i="0">
                 <a:solidFill>
                   <a:srgbClr val="0B4DA2"/>
                 </a:solidFill>
-                <a:latin typeface="Calibri"/>
+                <a:latin typeface="Arial Black"/>
               </a:rPr>
               <a:t>14 вопросов</a:t>
             </a:r>
@@ -13735,11 +13735,11 @@
           <a:p>
             <a:pPr algn="l"/>
             <a:r>
-              <a:rPr sz="1300" b="0" i="0">
+              <a:rPr sz="1100" b="0" i="0">
                 <a:solidFill>
                   <a:srgbClr val="4A4F57"/>
                 </a:solidFill>
-                <a:latin typeface="Calibri"/>
+                <a:latin typeface="Arial Black"/>
               </a:rPr>
               <a:t>по теме «Квадратные уравнения» и всем её основам</a:t>
             </a:r>
@@ -13817,11 +13817,11 @@
           <a:p>
             <a:pPr algn="l"/>
             <a:r>
-              <a:rPr sz="1800" b="1" i="0">
+              <a:rPr sz="1600" b="0" i="0">
                 <a:solidFill>
                   <a:srgbClr val="0B4DA2"/>
                 </a:solidFill>
-                <a:latin typeface="Calibri"/>
+                <a:latin typeface="Arial Black"/>
               </a:rPr>
               <a:t>Корень — «Дроби»</a:t>
             </a:r>
@@ -13852,11 +13852,11 @@
           <a:p>
             <a:pPr algn="l"/>
             <a:r>
-              <a:rPr sz="1300" b="0" i="0">
+              <a:rPr sz="1100" b="0" i="0">
                 <a:solidFill>
                   <a:srgbClr val="4A4F57"/>
                 </a:solidFill>
-                <a:latin typeface="Calibri"/>
+                <a:latin typeface="Arial Black"/>
               </a:rPr>
               <a:t>хотя ошибки видны в квадратных и линейных уравнениях</a:t>
             </a:r>
@@ -13934,11 +13934,11 @@
           <a:p>
             <a:pPr algn="l"/>
             <a:r>
-              <a:rPr sz="1800" b="1" i="0">
+              <a:rPr sz="1600" b="0" i="0">
                 <a:solidFill>
                   <a:srgbClr val="0B4DA2"/>
                 </a:solidFill>
-                <a:latin typeface="Calibri"/>
+                <a:latin typeface="Arial Black"/>
               </a:rPr>
               <a:t>Ошибки мышления</a:t>
             </a:r>
@@ -13969,11 +13969,11 @@
           <a:p>
             <a:pPr algn="l"/>
             <a:r>
-              <a:rPr sz="1300" b="0" i="0">
+              <a:rPr sz="1100" b="0" i="0">
                 <a:solidFill>
                   <a:srgbClr val="4A4F57"/>
                 </a:solidFill>
-                <a:latin typeface="Calibri"/>
+                <a:latin typeface="Arial Black"/>
               </a:rPr>
               <a:t>по выбранным вариантам, с правилом исправления</a:t>
             </a:r>
@@ -14051,11 +14051,11 @@
           <a:p>
             <a:pPr algn="l"/>
             <a:r>
-              <a:rPr sz="1800" b="1" i="0">
+              <a:rPr sz="1600" b="0" i="0">
                 <a:solidFill>
                   <a:srgbClr val="0B4DA2"/>
                 </a:solidFill>
-                <a:latin typeface="Calibri"/>
+                <a:latin typeface="Arial Black"/>
               </a:rPr>
               <a:t>План</a:t>
             </a:r>
@@ -14086,11 +14086,11 @@
           <a:p>
             <a:pPr algn="l"/>
             <a:r>
-              <a:rPr sz="1300" b="0" i="0">
+              <a:rPr sz="1100" b="0" i="0">
                 <a:solidFill>
                   <a:srgbClr val="4A4F57"/>
                 </a:solidFill>
-                <a:latin typeface="Calibri"/>
+                <a:latin typeface="Arial Black"/>
               </a:rPr>
               <a:t>«Разобрать» → урок → 2 новые задачи → следующая тема</a:t>
             </a:r>
@@ -14139,11 +14139,11 @@
           <a:p>
             <a:pPr algn="ctr"/>
             <a:r>
-              <a:rPr sz="1400" b="1">
+              <a:rPr sz="1200" b="0">
                 <a:solidFill>
                   <a:srgbClr val="FFFFFF"/>
                 </a:solidFill>
-                <a:latin typeface="Calibri"/>
+                <a:latin typeface="Arial Black"/>
               </a:rPr>
               <a:t>Открыть: index.html#demo</a:t>
             </a:r>
@@ -14504,11 +14504,11 @@
           <a:p>
             <a:pPr algn="l"/>
             <a:r>
-              <a:rPr sz="1600" b="1" i="0">
+              <a:rPr sz="1400" b="0" i="0">
                 <a:solidFill>
                   <a:srgbClr val="0B4DA2"/>
                 </a:solidFill>
-                <a:latin typeface="Calibri"/>
+                <a:latin typeface="Arial Black"/>
               </a:rPr>
               <a:t>Tamyr</a:t>
             </a:r>
@@ -14686,11 +14686,11 @@
           <a:p>
             <a:pPr algn="l"/>
             <a:r>
-              <a:rPr sz="1800" b="1" i="0">
+              <a:rPr sz="1600" b="0" i="0">
                 <a:solidFill>
                   <a:srgbClr val="0B4DA2"/>
                 </a:solidFill>
-                <a:latin typeface="Calibri"/>
+                <a:latin typeface="Arial Black"/>
               </a:rPr>
               <a:t>Корневые пробелы класса</a:t>
             </a:r>
@@ -14721,11 +14721,11 @@
           <a:p>
             <a:pPr algn="l"/>
             <a:r>
-              <a:rPr sz="1300" b="0" i="0">
+              <a:rPr sz="1100" b="0" i="0">
                 <a:solidFill>
                   <a:srgbClr val="4A4F57"/>
                 </a:solidFill>
-                <a:latin typeface="Calibri"/>
+                <a:latin typeface="Arial Black"/>
               </a:rPr>
               <a:t>какие базовые темы тянут класс вниз</a:t>
             </a:r>
@@ -14803,11 +14803,11 @@
           <a:p>
             <a:pPr algn="l"/>
             <a:r>
-              <a:rPr sz="1800" b="1" i="0">
+              <a:rPr sz="1600" b="0" i="0">
                 <a:solidFill>
                   <a:srgbClr val="0B4DA2"/>
                 </a:solidFill>
-                <a:latin typeface="Calibri"/>
+                <a:latin typeface="Arial Black"/>
               </a:rPr>
               <a:t>Мини-группы</a:t>
             </a:r>
@@ -14838,11 +14838,11 @@
           <a:p>
             <a:pPr algn="l"/>
             <a:r>
-              <a:rPr sz="1300" b="0" i="0">
+              <a:rPr sz="1100" b="0" i="0">
                 <a:solidFill>
                   <a:srgbClr val="4A4F57"/>
                 </a:solidFill>
-                <a:latin typeface="Calibri"/>
+                <a:latin typeface="Arial Black"/>
               </a:rPr>
               <a:t>кого с кем посадить на 15-минутный разбор</a:t>
             </a:r>
@@ -14920,11 +14920,11 @@
           <a:p>
             <a:pPr algn="l"/>
             <a:r>
-              <a:rPr sz="1800" b="1" i="0">
+              <a:rPr sz="1600" b="0" i="0">
                 <a:solidFill>
                   <a:srgbClr val="0B4DA2"/>
                 </a:solidFill>
-                <a:latin typeface="Calibri"/>
+                <a:latin typeface="Arial Black"/>
               </a:rPr>
               <a:t>Тепловая карта и CSV</a:t>
             </a:r>
@@ -14955,11 +14955,11 @@
           <a:p>
             <a:pPr algn="l"/>
             <a:r>
-              <a:rPr sz="1300" b="0" i="0">
+              <a:rPr sz="1100" b="0" i="0">
                 <a:solidFill>
                   <a:srgbClr val="4A4F57"/>
                 </a:solidFill>
-                <a:latin typeface="Calibri"/>
+                <a:latin typeface="Arial Black"/>
               </a:rPr>
               <a:t>ученик × тема, выгрузка в Excel</a:t>
             </a:r>
@@ -15037,11 +15037,11 @@
           <a:p>
             <a:pPr algn="l"/>
             <a:r>
-              <a:rPr sz="1800" b="1" i="0">
+              <a:rPr sz="1600" b="0" i="0">
                 <a:solidFill>
                   <a:srgbClr val="0B4DA2"/>
                 </a:solidFill>
-                <a:latin typeface="Calibri"/>
+                <a:latin typeface="Arial Black"/>
               </a:rPr>
               <a:t>Без сервера</a:t>
             </a:r>
@@ -15072,11 +15072,11 @@
           <a:p>
             <a:pPr algn="l"/>
             <a:r>
-              <a:rPr sz="1300" b="0" i="0">
+              <a:rPr sz="1100" b="0" i="0">
                 <a:solidFill>
                   <a:srgbClr val="4A4F57"/>
                 </a:solidFill>
-                <a:latin typeface="Calibri"/>
+                <a:latin typeface="Arial Black"/>
               </a:rPr>
               <a:t>ученик передаёт результат кодом</a:t>
             </a:r>
@@ -15107,13 +15107,13 @@
           <a:p>
             <a:pPr algn="l"/>
             <a:r>
-              <a:rPr sz="1100" b="0" i="1">
+              <a:rPr sz="1000" b="0" i="1">
                 <a:solidFill>
                   <a:srgbClr val="4A4F57"/>
                 </a:solidFill>
-                <a:latin typeface="Calibri"/>
-              </a:rPr>
-              <a:t>Демо-класс: 24 виртуальных ученика, прогнанных через тот же движок (симуляция, не реальные данные).</a:t>
+                <a:latin typeface="Arial Black"/>
+              </a:rPr>
+              <a:t>Демо-класс: 24 виртуальных ученика (симуляция, не реальные данные).</a:t>
             </a:r>
           </a:p>
         </p:txBody>
@@ -15425,11 +15425,11 @@
           <a:p>
             <a:pPr algn="l"/>
             <a:r>
-              <a:rPr sz="1600" b="1" i="0">
+              <a:rPr sz="1400" b="0" i="0">
                 <a:solidFill>
                   <a:srgbClr val="0B4DA2"/>
                 </a:solidFill>
-                <a:latin typeface="Calibri"/>
+                <a:latin typeface="Arial Black"/>
               </a:rPr>
               <a:t>Tamyr</a:t>
             </a:r>
@@ -15530,11 +15530,11 @@
           <a:p>
             <a:pPr algn="l"/>
             <a:r>
-              <a:rPr sz="1100" b="1" i="0">
+              <a:rPr sz="1000" b="0" i="0">
                 <a:solidFill>
                   <a:srgbClr val="7A808A"/>
                 </a:solidFill>
-                <a:latin typeface="Calibri"/>
+                <a:latin typeface="Arial Black"/>
               </a:rPr>
               <a:t>ЧТО ДЕЛАЕТ</a:t>
             </a:r>
@@ -15565,11 +15565,11 @@
           <a:p>
             <a:pPr algn="l"/>
             <a:r>
-              <a:rPr sz="1100" b="1" i="0">
+              <a:rPr sz="1000" b="0" i="0">
                 <a:solidFill>
                   <a:srgbClr val="0B4DA2"/>
                 </a:solidFill>
-                <a:latin typeface="Calibri"/>
+                <a:latin typeface="Arial Black"/>
               </a:rPr>
               <a:t>ЧЕМ ОТЛИЧАЕТСЯ TAMYR</a:t>
             </a:r>
@@ -15693,11 +15693,11 @@
           <a:p>
             <a:pPr algn="l"/>
             <a:r>
-              <a:rPr sz="1600" b="1" i="0">
+              <a:rPr sz="1400" b="0" i="0">
                 <a:solidFill>
                   <a:srgbClr val="111111"/>
                 </a:solidFill>
-                <a:latin typeface="Calibri"/>
+                <a:latin typeface="Arial Black"/>
               </a:rPr>
               <a:t>ALEKS</a:t>
             </a:r>
@@ -15728,11 +15728,11 @@
           <a:p>
             <a:pPr algn="l"/>
             <a:r>
-              <a:rPr sz="1100" b="0" i="0">
+              <a:rPr sz="1000" b="0" i="0">
                 <a:solidFill>
                   <a:srgbClr val="7A808A"/>
                 </a:solidFill>
-                <a:latin typeface="Calibri"/>
+                <a:latin typeface="Arial Black"/>
               </a:rPr>
               <a:t>McGraw Hill</a:t>
             </a:r>
@@ -15763,11 +15763,11 @@
           <a:p>
             <a:pPr algn="l"/>
             <a:r>
-              <a:rPr sz="1300" b="0" i="0">
+              <a:rPr sz="1100" b="0" i="0">
                 <a:solidFill>
                   <a:srgbClr val="4A4F57"/>
                 </a:solidFill>
-                <a:latin typeface="Calibri"/>
+                <a:latin typeface="Arial Black"/>
               </a:rPr>
               <a:t>Адаптивная оценка по «пространству знаний». Платная, программы США.</a:t>
             </a:r>
@@ -15842,11 +15842,11 @@
           <a:p>
             <a:pPr algn="l"/>
             <a:r>
-              <a:rPr sz="1300" b="1" i="0">
+              <a:rPr sz="1100" b="0" i="0">
                 <a:solidFill>
                   <a:srgbClr val="0B4DA2"/>
                 </a:solidFill>
-                <a:latin typeface="Calibri"/>
+                <a:latin typeface="Arial Black"/>
               </a:rPr>
               <a:t>Программа и формат ЕНТ, бесплатно для ученика, офлайн без регистрации</a:t>
             </a:r>
@@ -15970,11 +15970,11 @@
           <a:p>
             <a:pPr algn="l"/>
             <a:r>
-              <a:rPr sz="1600" b="1" i="0">
+              <a:rPr sz="1400" b="0" i="0">
                 <a:solidFill>
                   <a:srgbClr val="111111"/>
                 </a:solidFill>
-                <a:latin typeface="Calibri"/>
+                <a:latin typeface="Arial Black"/>
               </a:rPr>
               <a:t>Eedi</a:t>
             </a:r>
@@ -16005,11 +16005,11 @@
           <a:p>
             <a:pPr algn="l"/>
             <a:r>
-              <a:rPr sz="1100" b="0" i="0">
+              <a:rPr sz="1000" b="0" i="0">
                 <a:solidFill>
                   <a:srgbClr val="7A808A"/>
                 </a:solidFill>
-                <a:latin typeface="Calibri"/>
+                <a:latin typeface="Arial Black"/>
               </a:rPr>
               <a:t>Великобритания</a:t>
             </a:r>
@@ -16040,11 +16040,11 @@
           <a:p>
             <a:pPr algn="l"/>
             <a:r>
-              <a:rPr sz="1300" b="0" i="0">
+              <a:rPr sz="1100" b="0" i="0">
                 <a:solidFill>
                   <a:srgbClr val="4A4F57"/>
                 </a:solidFill>
-                <a:latin typeface="Calibri"/>
+                <a:latin typeface="Arial Black"/>
               </a:rPr>
               <a:t>Диагностические вопросы: неверный вариант указывает на ошибку мышления.</a:t>
             </a:r>
@@ -16119,11 +16119,11 @@
           <a:p>
             <a:pPr algn="l"/>
             <a:r>
-              <a:rPr sz="1300" b="1" i="0">
+              <a:rPr sz="1100" b="0" i="0">
                 <a:solidFill>
                   <a:srgbClr val="0B4DA2"/>
                 </a:solidFill>
-                <a:latin typeface="Calibri"/>
+                <a:latin typeface="Arial Black"/>
               </a:rPr>
               <a:t>Метка ошибки сразу ведёт в её домашнюю тему и дальше вниз, к корню</a:t>
             </a:r>
@@ -16247,11 +16247,11 @@
           <a:p>
             <a:pPr algn="l"/>
             <a:r>
-              <a:rPr sz="1600" b="1" i="0">
+              <a:rPr sz="1400" b="0" i="0">
                 <a:solidFill>
                   <a:srgbClr val="111111"/>
                 </a:solidFill>
-                <a:latin typeface="Calibri"/>
+                <a:latin typeface="Arial Black"/>
               </a:rPr>
               <a:t>Khan Academy</a:t>
             </a:r>
@@ -16282,11 +16282,11 @@
           <a:p>
             <a:pPr algn="l"/>
             <a:r>
-              <a:rPr sz="1100" b="0" i="0">
+              <a:rPr sz="1000" b="0" i="0">
                 <a:solidFill>
                   <a:srgbClr val="7A808A"/>
                 </a:solidFill>
-                <a:latin typeface="Calibri"/>
+                <a:latin typeface="Arial Black"/>
               </a:rPr>
               <a:t>США</a:t>
             </a:r>
@@ -16317,11 +16317,11 @@
           <a:p>
             <a:pPr algn="l"/>
             <a:r>
-              <a:rPr sz="1300" b="0" i="0">
+              <a:rPr sz="1100" b="0" i="0">
                 <a:solidFill>
                   <a:srgbClr val="4A4F57"/>
                 </a:solidFill>
-                <a:latin typeface="Calibri"/>
+                <a:latin typeface="Arial Black"/>
               </a:rPr>
               <a:t>Бесплатные курсы и система освоения по темам.</a:t>
             </a:r>
@@ -16396,11 +16396,11 @@
           <a:p>
             <a:pPr algn="l"/>
             <a:r>
-              <a:rPr sz="1300" b="1" i="0">
+              <a:rPr sz="1100" b="0" i="0">
                 <a:solidFill>
                   <a:srgbClr val="0B4DA2"/>
                 </a:solidFill>
-                <a:latin typeface="Calibri"/>
+                <a:latin typeface="Arial Black"/>
               </a:rPr>
               <a:t>Не курс, а 10–20 минут диагностики: с чего начать</a:t>
             </a:r>
@@ -16524,11 +16524,11 @@
           <a:p>
             <a:pPr algn="l"/>
             <a:r>
-              <a:rPr sz="1600" b="1" i="0">
+              <a:rPr sz="1400" b="0" i="0">
                 <a:solidFill>
                   <a:srgbClr val="111111"/>
                 </a:solidFill>
-                <a:latin typeface="Calibri"/>
+                <a:latin typeface="Arial Black"/>
               </a:rPr>
               <a:t>Пробники ЕНТ</a:t>
             </a:r>
@@ -16559,11 +16559,11 @@
           <a:p>
             <a:pPr algn="l"/>
             <a:r>
-              <a:rPr sz="1100" b="0" i="0">
+              <a:rPr sz="1000" b="0" i="0">
                 <a:solidFill>
                   <a:srgbClr val="7A808A"/>
                 </a:solidFill>
-                <a:latin typeface="Calibri"/>
+                <a:latin typeface="Arial Black"/>
               </a:rPr>
               <a:t>Казахстан</a:t>
             </a:r>
@@ -16594,11 +16594,11 @@
           <a:p>
             <a:pPr algn="l"/>
             <a:r>
-              <a:rPr sz="1300" b="0" i="0">
+              <a:rPr sz="1100" b="0" i="0">
                 <a:solidFill>
                   <a:srgbClr val="4A4F57"/>
                 </a:solidFill>
-                <a:latin typeface="Calibri"/>
+                <a:latin typeface="Arial Black"/>
               </a:rPr>
               <a:t>Балл и разбор по темам, где произошла ошибка.</a:t>
             </a:r>
@@ -16673,11 +16673,11 @@
           <a:p>
             <a:pPr algn="l"/>
             <a:r>
-              <a:rPr sz="1300" b="1" i="0">
+              <a:rPr sz="1100" b="0" i="0">
                 <a:solidFill>
                   <a:srgbClr val="0B4DA2"/>
                 </a:solidFill>
-                <a:latin typeface="Calibri"/>
+                <a:latin typeface="Arial Black"/>
               </a:rPr>
               <a:t>Причина, а не балл; учителю — корни класса и группы</a:t>
             </a:r>
@@ -16726,11 +16726,11 @@
           <a:p>
             <a:pPr algn="ctr"/>
             <a:r>
-              <a:rPr sz="1400" b="1">
+              <a:rPr sz="1200" b="0">
                 <a:solidFill>
                   <a:srgbClr val="FFFFFF"/>
                 </a:solidFill>
-                <a:latin typeface="Calibri"/>
+                <a:latin typeface="Arial Black"/>
               </a:rPr>
               <a:t>Неверный вариант → домашняя тема ошибки → проверка корня  ·  под ЕНТ, офлайн, с панелью учителя</a:t>
             </a:r>
@@ -17044,11 +17044,11 @@
           <a:p>
             <a:pPr algn="l"/>
             <a:r>
-              <a:rPr sz="1600" b="1" i="0">
+              <a:rPr sz="1400" b="0" i="0">
                 <a:solidFill>
                   <a:srgbClr val="0B4DA2"/>
                 </a:solidFill>
-                <a:latin typeface="Calibri"/>
+                <a:latin typeface="Arial Black"/>
               </a:rPr>
               <a:t>Tamyr</a:t>
             </a:r>
@@ -17172,7 +17172,7 @@
           <a:p>
             <a:pPr algn="ctr"/>
             <a:r>
-              <a:rPr sz="2800" b="1">
+              <a:rPr sz="2800" b="0">
                 <a:solidFill>
                   <a:srgbClr val="0B4DA2"/>
                 </a:solidFill>
@@ -17207,11 +17207,11 @@
           <a:p>
             <a:pPr algn="ctr"/>
             <a:r>
-              <a:rPr sz="1300" b="0" i="0">
+              <a:rPr sz="1100" b="0" i="0">
                 <a:solidFill>
                   <a:srgbClr val="4A4F57"/>
                 </a:solidFill>
-                <a:latin typeface="Calibri"/>
+                <a:latin typeface="Arial Black"/>
               </a:rPr>
               <a:t>настоящих корней найдено
 (полнота)</a:t>
@@ -17266,7 +17266,7 @@
           <a:p>
             <a:pPr algn="ctr"/>
             <a:r>
-              <a:rPr sz="2800" b="1">
+              <a:rPr sz="2800" b="0">
                 <a:solidFill>
                   <a:srgbClr val="0B4DA2"/>
                 </a:solidFill>
@@ -17301,11 +17301,11 @@
           <a:p>
             <a:pPr algn="ctr"/>
             <a:r>
-              <a:rPr sz="1300" b="0" i="0">
+              <a:rPr sz="1100" b="0" i="0">
                 <a:solidFill>
                   <a:srgbClr val="4A4F57"/>
                 </a:solidFill>
-                <a:latin typeface="Calibri"/>
+                <a:latin typeface="Arial Black"/>
               </a:rPr>
               <a:t>найденных корней верны
 (точность)</a:t>
@@ -17360,7 +17360,7 @@
           <a:p>
             <a:pPr algn="ctr"/>
             <a:r>
-              <a:rPr sz="2800" b="1">
+              <a:rPr sz="2800" b="0">
                 <a:solidFill>
                   <a:srgbClr val="0B4DA2"/>
                 </a:solidFill>
@@ -17395,11 +17395,11 @@
           <a:p>
             <a:pPr algn="ctr"/>
             <a:r>
-              <a:rPr sz="1300" b="0" i="0">
+              <a:rPr sz="1100" b="0" i="0">
                 <a:solidFill>
                   <a:srgbClr val="4A4F57"/>
                 </a:solidFill>
-                <a:latin typeface="Calibri"/>
+                <a:latin typeface="Arial Black"/>
               </a:rPr>
               <a:t>вопросов: без пробелов /
 с одним пробелом</a:t>
@@ -17454,7 +17454,7 @@
           <a:p>
             <a:pPr algn="ctr"/>
             <a:r>
-              <a:rPr sz="2800" b="1">
+              <a:rPr sz="2800" b="0">
                 <a:solidFill>
                   <a:srgbClr val="0B4DA2"/>
                 </a:solidFill>
@@ -17489,11 +17489,11 @@
           <a:p>
             <a:pPr algn="ctr"/>
             <a:r>
-              <a:rPr sz="1300" b="0" i="0">
+              <a:rPr sz="1100" b="0" i="0">
                 <a:solidFill>
                   <a:srgbClr val="4A4F57"/>
                 </a:solidFill>
-                <a:latin typeface="Calibri"/>
+                <a:latin typeface="Arial Black"/>
               </a:rPr>
               <a:t>юнит-тестов
 проходят</a:t>
@@ -17525,11 +17525,11 @@
           <a:p>
             <a:pPr algn="l"/>
             <a:r>
-              <a:rPr sz="1200" b="0" i="0">
+              <a:rPr sz="1100" b="0" i="0">
                 <a:solidFill>
                   <a:srgbClr val="7A808A"/>
                 </a:solidFill>
-                <a:latin typeface="Calibri"/>
+                <a:latin typeface="Arial Black"/>
               </a:rPr>
               <a:t>Контрольная симуляция: 1000 новых виртуальных учеников с известными пробелами, не использованных при доработке движка. Модель ученика наша, поэтому это оценка сверху; без шума алгоритм находит 100% корней.</a:t>
             </a:r>
@@ -17607,20 +17607,20 @@
           <a:p>
             <a:pPr algn="l"/>
             <a:r>
-              <a:rPr sz="1300" b="1" i="0">
+              <a:rPr sz="1100" b="0" i="0">
                 <a:solidFill>
                   <a:srgbClr val="0B4DA2"/>
                 </a:solidFill>
-                <a:latin typeface="Calibri"/>
+                <a:latin typeface="Arial Black"/>
               </a:rPr>
               <a:t>Проверка на людях — заполните реальными данными: </a:t>
             </a:r>
             <a:r>
-              <a:rPr sz="1300" b="0" i="0">
+              <a:rPr sz="1100" b="0" i="0">
                 <a:solidFill>
                   <a:srgbClr val="111111"/>
                 </a:solidFill>
-                <a:latin typeface="Calibri"/>
+                <a:latin typeface="Arial Black"/>
               </a:rPr>
               <a:t>опрос учеников (n = __), интервью с учителями (__ чел.), мини-пилот: совпадение корня с мнением учителя __ из __. Шаблоны: docs/validation-plan.md</a:t>
             </a:r>

</xml_diff>

<commit_message>
Raise score: sourced problem data, better engine, PWA, safer share codes
- Engine: decide a topic on a 2-answer lead (up to 6 questions); held-out
  precision 72% -> 85%, recall 79% -> 90%
- Share codes are validated (unknown topic/misconception ids dropped,
  __proto__ rejected); stored data sanitized so a bad code can't break the
  teacher dashboard; 4 new tests (20 total)
- PWA: manifest, icons, service worker; verified working with server off
- README: PISA 2022 / ЕНТ-2025 sources, mapping to official ЕНТ math spec,
  market and costs, honest AI-authorship section
- Deck: scale slide with sourced data, market slide, updated validation

Co-Authored-By: Claude Opus 5 <noreply@anthropic.com>
</commit_message>
<xml_diff>
--- a/docs/Tamyr_VentureHack2026.pptx
+++ b/docs/Tamyr_VentureHack2026.pptx
@@ -652,7 +652,7 @@
           <a:lstStyle/>
           <a:p>
             <a:r>
-              <a:t>Три причины. Если провели опрос, назовите реальную цифру; если нет, удалите нижнюю строку.</a:t>
+              <a:t>Цифры проверены по первоисточникам (README → «Источники»): OECD PISA 2022 Country Note: Kazakhstan; ЕНТ-2025 — Вечерняя Астана, 02.06.2025. Если провели опрос, назовите свою цифру; если нет, удалите нижнюю строку.</a:t>
             </a:r>
           </a:p>
         </p:txBody>
@@ -933,6 +933,76 @@
           <a:p>
             <a:r>
               <a:t>Говорите честно: это симуляция. Затем назовите то, что проверили на людях. Если ничего не успели, скажите, что пилот запланирован, и удалите пустые поля.</a:t>
+            </a:r>
+          </a:p>
+        </p:txBody>
+      </p:sp>
+      <p:sp>
+        <p:nvSpPr>
+          <p:cNvPr id="4" name="Slide Number Placeholder 3"/>
+          <p:cNvSpPr>
+            <a:spLocks noGrp="1"/>
+          </p:cNvSpPr>
+          <p:nvPr>
+            <p:ph type="sldNum" idx="5" sz="quarter"/>
+          </p:nvPr>
+        </p:nvSpPr>
+        <p:spPr/>
+      </p:sp>
+    </p:spTree>
+  </p:cSld>
+  <p:clrMapOvr>
+    <a:masterClrMapping/>
+  </p:clrMapOvr>
+</p:notes>
+</file>
+
+<file path=ppt/notesSlides/notesSlide8.xml><?xml version="1.0" encoding="utf-8"?>
+<p:notes xmlns:a="http://schemas.openxmlformats.org/drawingml/2006/main" xmlns:p="http://schemas.openxmlformats.org/presentationml/2006/main" xmlns:r="http://schemas.openxmlformats.org/officeDocument/2006/relationships">
+  <p:cSld>
+    <p:spTree>
+      <p:nvGrpSpPr>
+        <p:cNvPr id="1" name=""/>
+        <p:cNvGrpSpPr/>
+        <p:nvPr/>
+      </p:nvGrpSpPr>
+      <p:grpSpPr>
+        <a:xfrm>
+          <a:off x="0" y="0"/>
+          <a:ext cx="0" cy="0"/>
+          <a:chOff x="0" y="0"/>
+          <a:chExt cx="0" cy="0"/>
+        </a:xfrm>
+      </p:grpSpPr>
+      <p:sp>
+        <p:nvSpPr>
+          <p:cNvPr id="2" name="Slide Image Placeholder 1"/>
+          <p:cNvSpPr>
+            <a:spLocks noGrp="1"/>
+          </p:cNvSpPr>
+          <p:nvPr>
+            <p:ph type="sldImg" idx="2"/>
+          </p:nvPr>
+        </p:nvSpPr>
+        <p:spPr/>
+      </p:sp>
+      <p:sp>
+        <p:nvSpPr>
+          <p:cNvPr id="3" name="Notes Placeholder 2"/>
+          <p:cNvSpPr>
+            <a:spLocks noGrp="1"/>
+          </p:cNvSpPr>
+          <p:nvPr>
+            <p:ph type="body" idx="3" sz="quarter"/>
+          </p:nvPr>
+        </p:nvSpPr>
+        <p:spPr/>
+        <p:txBody>
+          <a:bodyPr/>
+          <a:lstStyle/>
+          <a:p>
+            <a:r>
+              <a:t>Цены — гипотезы, их надо проверить на интервью (docs/validation-plan.md, вопрос 5 для учителей). 184 тыс. — оценка: 216 тыс. минус около 15% творческих специальностей.</a:t>
             </a:r>
           </a:p>
         </p:txBody>
@@ -6231,7 +6301,7 @@
                 </a:solidFill>
                 <a:latin typeface="Arial Black"/>
               </a:rPr>
-              <a:t>ВНЕДРЕНИЕ</a:t>
+              <a:t>РЫНОК</a:t>
             </a:r>
           </a:p>
         </p:txBody>
@@ -6266,7 +6336,7 @@
                 </a:solidFill>
                 <a:latin typeface="Arial Black"/>
               </a:rPr>
-              <a:t>РЕАЛИЗУЕМО УЖЕ СЕЙЧАС</a:t>
+              <a:t>КОМУ, СКОЛЬКО СТОИТ, КАК ЗАПУСТИТЬ</a:t>
             </a:r>
           </a:p>
         </p:txBody>
@@ -6606,7 +6676,7 @@
                 </a:solidFill>
                 <a:latin typeface="Arial Black"/>
               </a:rPr>
-              <a:t>Технологии</a:t>
+              <a:t>Аудитория</a:t>
             </a:r>
           </a:p>
         </p:txBody>
@@ -6646,7 +6716,7 @@
                 </a:solidFill>
                 <a:latin typeface="Arial Black"/>
               </a:rPr>
-              <a:t>HTML/CSS/JS без зависимостей</a:t>
+              <a:t>216 тыс. абитуриентов ЕНТ-2025</a:t>
             </a:r>
           </a:p>
           <a:p>
@@ -6663,7 +6733,7 @@
                 </a:solidFill>
                 <a:latin typeface="Arial Black"/>
               </a:rPr>
-              <a:t>Работает офлайн на любом телефоне</a:t>
+              <a:t>≈184 тыс. сдают обязательную мат. грамотность (наша оценка: без творческих специальностей)</a:t>
             </a:r>
           </a:p>
           <a:p>
@@ -6680,24 +6750,7 @@
                 </a:solidFill>
                 <a:latin typeface="Arial Black"/>
               </a:rPr>
-              <a:t>Граф и банк заданий — данные: новый предмет = новый файл</a:t>
-            </a:r>
-          </a:p>
-          <a:p>
-            <a:pPr algn="l" marL="201168" indent="-201168">
-              <a:spcAft>
-                <a:spcPts val="800"/>
-              </a:spcAft>
-              <a:buChar char="•"/>
-            </a:pPr>
-            <a:r>
-              <a:rPr sz="1200" b="0" i="0">
-                <a:solidFill>
-                  <a:srgbClr val="4A4F57"/>
-                </a:solidFill>
-                <a:latin typeface="Arial Black"/>
-              </a:rPr>
-              <a:t>Персональные данные остаются на устройстве</a:t>
+              <a:t>72% сдают ЕНТ на казахском → казахская версия — шаг №1</a:t>
             </a:r>
           </a:p>
         </p:txBody>
@@ -6836,7 +6889,7 @@
                 </a:solidFill>
                 <a:latin typeface="Arial Black"/>
               </a:rPr>
-              <a:t>Кому и за сколько</a:t>
+              <a:t>Затраты</a:t>
             </a:r>
           </a:p>
         </p:txBody>
@@ -6876,7 +6929,7 @@
                 </a:solidFill>
                 <a:latin typeface="Arial Black"/>
               </a:rPr>
-              <a:t>Ученикам: бесплатная диагностика, платные банки (геометрия, мат. грамотность)</a:t>
+              <a:t>Хостинг: 0 ₸ (GitHub Pages)</a:t>
             </a:r>
           </a:p>
           <a:p>
@@ -6893,7 +6946,7 @@
                 </a:solidFill>
                 <a:latin typeface="Arial Black"/>
               </a:rPr>
-              <a:t>Школам: панель учителя, подписка за класс</a:t>
+              <a:t>Нет серверов и персональных данных</a:t>
             </a:r>
           </a:p>
           <a:p>
@@ -6910,7 +6963,7 @@
                 </a:solidFill>
                 <a:latin typeface="Arial Black"/>
               </a:rPr>
-              <a:t>Учебным центрам: входная диагностика новых учеников</a:t>
+              <a:t>Основное: время учителей на проверку заданий и перевод</a:t>
             </a:r>
           </a:p>
         </p:txBody>
@@ -7049,7 +7102,7 @@
                 </a:solidFill>
                 <a:latin typeface="Arial Black"/>
               </a:rPr>
-              <a:t>Для запуска</a:t>
+              <a:t>Деньги (гипотезы)</a:t>
             </a:r>
           </a:p>
         </p:txBody>
@@ -7089,7 +7142,7 @@
                 </a:solidFill>
                 <a:latin typeface="Arial Black"/>
               </a:rPr>
-              <a:t>Проверка графа 2–3 учителями</a:t>
+              <a:t>Ученик: диагностика бесплатно, платные банки тем</a:t>
             </a:r>
           </a:p>
           <a:p>
@@ -7106,7 +7159,7 @@
                 </a:solidFill>
                 <a:latin typeface="Arial Black"/>
               </a:rPr>
-              <a:t>Банк 10+ вопросов на тему</a:t>
+              <a:t>Учебные центры: входная диагностика и панель по подписке</a:t>
             </a:r>
           </a:p>
           <a:p>
@@ -7123,24 +7176,7 @@
                 </a:solidFill>
                 <a:latin typeface="Arial Black"/>
               </a:rPr>
-              <a:t>Казахская версия</a:t>
-            </a:r>
-          </a:p>
-          <a:p>
-            <a:pPr algn="l" marL="201168" indent="-201168">
-              <a:spcAft>
-                <a:spcPts val="800"/>
-              </a:spcAft>
-              <a:buChar char="•"/>
-            </a:pPr>
-            <a:r>
-              <a:rPr sz="1200" b="0" i="0">
-                <a:solidFill>
-                  <a:srgbClr val="4A4F57"/>
-                </a:solidFill>
-                <a:latin typeface="Arial Black"/>
-              </a:rPr>
-              <a:t>Пилот в 2–3 классах</a:t>
+              <a:t>Школы: бесплатно для учителя ради охвата</a:t>
             </a:r>
           </a:p>
         </p:txBody>
@@ -7148,6 +7184,41 @@
       <p:sp>
         <p:nvSpPr>
           <p:cNvPr id="30" name="TextBox 29"/>
+          <p:cNvSpPr txBox="1"/>
+          <p:nvPr/>
+        </p:nvSpPr>
+        <p:spPr>
+          <a:xfrm>
+            <a:off x="640080" y="6309360"/>
+            <a:ext cx="6400800" cy="274320"/>
+          </a:xfrm>
+          <a:prstGeom prst="rect">
+            <a:avLst/>
+          </a:prstGeom>
+          <a:noFill/>
+        </p:spPr>
+        <p:txBody>
+          <a:bodyPr wrap="square" lIns="0" rIns="0" tIns="0" bIns="0" anchor="t">
+            <a:spAutoFit/>
+          </a:bodyPr>
+          <a:lstStyle/>
+          <a:p>
+            <a:pPr algn="l"/>
+            <a:r>
+              <a:rPr sz="900" b="0" i="0">
+                <a:solidFill>
+                  <a:srgbClr val="7A808A"/>
+                </a:solidFill>
+                <a:latin typeface="Arial Black"/>
+              </a:rPr>
+              <a:t>Источники: НЦТ (формат ЕНТ); Вечерняя Астана, 02.06.2025</a:t>
+            </a:r>
+          </a:p>
+        </p:txBody>
+      </p:sp>
+      <p:sp>
+        <p:nvSpPr>
+          <p:cNvPr id="31" name="TextBox 30"/>
           <p:cNvSpPr txBox="1"/>
           <p:nvPr/>
         </p:nvSpPr>
@@ -8002,7 +8073,7 @@
                 </a:solidFill>
                 <a:latin typeface="Arial Black"/>
               </a:rPr>
-              <a:t>Пилот в 2–3 классах, казахский язык</a:t>
+              <a:t>Казахская версия, пилот в 2–3 классах</a:t>
             </a:r>
           </a:p>
         </p:txBody>
@@ -8130,7 +8201,7 @@
                 </a:solidFill>
                 <a:latin typeface="Arial Black"/>
               </a:rPr>
-              <a:t>Байесовская модель освоения, 10+ вопросов на тему</a:t>
+              <a:t>Проверка заданий учителями, 10+ вопросов на тему</a:t>
             </a:r>
           </a:p>
         </p:txBody>
@@ -8258,7 +8329,7 @@
                 </a:solidFill>
                 <a:latin typeface="Arial Black"/>
               </a:rPr>
-              <a:t>Геометрия и мат. грамотность ЕНТ, вход по коду класса</a:t>
+              <a:t>Тригонометрия, логарифмы, геометрия по спецификации ЕНТ</a:t>
             </a:r>
           </a:p>
         </p:txBody>
@@ -9670,7 +9741,7 @@
                 </a:solidFill>
                 <a:latin typeface="Arial Black"/>
               </a:rPr>
-              <a:t>ПРИЧИНЫ</a:t>
+              <a:t>МАСШТАБ</a:t>
             </a:r>
           </a:p>
         </p:txBody>
@@ -9705,21 +9776,409 @@
                 </a:solidFill>
                 <a:latin typeface="Arial Black"/>
               </a:rPr>
-              <a:t>ПОЧЕМУ ЭТО ПРОИСХОДИТ</a:t>
-            </a:r>
-          </a:p>
-        </p:txBody>
-      </p:sp>
-      <p:sp>
-        <p:nvSpPr>
-          <p:cNvPr id="12" name="Rectangle 11"/>
+              <a:t>ПРОБЛЕМА МАССОВАЯ, А ТЕСТ ЛЕЧИТ СИМПТОМ</a:t>
+            </a:r>
+          </a:p>
+        </p:txBody>
+      </p:sp>
+      <p:sp>
+        <p:nvSpPr>
+          <p:cNvPr id="12" name="Hexagon 11"/>
           <p:cNvSpPr/>
           <p:nvPr/>
         </p:nvSpPr>
         <p:spPr>
           <a:xfrm>
-            <a:off x="640080" y="2743200"/>
-            <a:ext cx="3474720" cy="2788920"/>
+            <a:off x="548640" y="2331720"/>
+            <a:ext cx="2240280" cy="1005840"/>
+          </a:xfrm>
+          <a:prstGeom prst="hexagon">
+            <a:avLst>
+              <a:gd name="adj" fmla="val 50000"/>
+              <a:gd name="vf" fmla="val 115470"/>
+            </a:avLst>
+          </a:prstGeom>
+          <a:solidFill>
+            <a:srgbClr val="FFFFFF"/>
+          </a:solidFill>
+          <a:ln w="38100">
+            <a:solidFill>
+              <a:srgbClr val="0B4DA2"/>
+            </a:solidFill>
+          </a:ln>
+          <a:effectLst/>
+        </p:spPr>
+        <p:style>
+          <a:lnRef idx="1">
+            <a:schemeClr val="accent1"/>
+          </a:lnRef>
+          <a:fillRef idx="3">
+            <a:schemeClr val="accent1"/>
+          </a:fillRef>
+          <a:effectRef idx="2">
+            <a:schemeClr val="accent1"/>
+          </a:effectRef>
+          <a:fontRef idx="minor">
+            <a:schemeClr val="lt1"/>
+          </a:fontRef>
+        </p:style>
+        <p:txBody>
+          <a:bodyPr rtlCol="0" anchor="ctr" lIns="73152" rIns="73152" tIns="18288" bIns="18288" wrap="square"/>
+          <a:lstStyle/>
+          <a:p>
+            <a:pPr algn="ctr"/>
+            <a:r>
+              <a:rPr sz="2200" b="0">
+                <a:solidFill>
+                  <a:srgbClr val="0B4DA2"/>
+                </a:solidFill>
+                <a:latin typeface="Arial Black"/>
+              </a:rPr>
+              <a:t>50%</a:t>
+            </a:r>
+          </a:p>
+        </p:txBody>
+      </p:sp>
+      <p:sp>
+        <p:nvSpPr>
+          <p:cNvPr id="13" name="TextBox 12"/>
+          <p:cNvSpPr txBox="1"/>
+          <p:nvPr/>
+        </p:nvSpPr>
+        <p:spPr>
+          <a:xfrm>
+            <a:off x="2926080" y="2377439"/>
+            <a:ext cx="2834640" cy="731520"/>
+          </a:xfrm>
+          <a:prstGeom prst="rect">
+            <a:avLst/>
+          </a:prstGeom>
+          <a:noFill/>
+        </p:spPr>
+        <p:txBody>
+          <a:bodyPr wrap="square" lIns="0" rIns="0" tIns="0" bIns="0" anchor="t">
+            <a:spAutoFit/>
+          </a:bodyPr>
+          <a:lstStyle/>
+          <a:p>
+            <a:pPr algn="l"/>
+            <a:r>
+              <a:rPr sz="1200" b="0" i="0">
+                <a:solidFill>
+                  <a:srgbClr val="111111"/>
+                </a:solidFill>
+                <a:latin typeface="Arial Black"/>
+              </a:rPr>
+              <a:t>школьников Казахстана
+достигли мин. уровня
+по математике (ОЭСР — 69%)</a:t>
+            </a:r>
+          </a:p>
+        </p:txBody>
+      </p:sp>
+      <p:sp>
+        <p:nvSpPr>
+          <p:cNvPr id="14" name="TextBox 13"/>
+          <p:cNvSpPr txBox="1"/>
+          <p:nvPr/>
+        </p:nvSpPr>
+        <p:spPr>
+          <a:xfrm>
+            <a:off x="2926080" y="3081527"/>
+            <a:ext cx="2834640" cy="228600"/>
+          </a:xfrm>
+          <a:prstGeom prst="rect">
+            <a:avLst/>
+          </a:prstGeom>
+          <a:noFill/>
+        </p:spPr>
+        <p:txBody>
+          <a:bodyPr wrap="square" lIns="0" rIns="0" tIns="0" bIns="0" anchor="t">
+            <a:spAutoFit/>
+          </a:bodyPr>
+          <a:lstStyle/>
+          <a:p>
+            <a:pPr algn="l"/>
+            <a:r>
+              <a:rPr sz="900" b="0" i="0">
+                <a:solidFill>
+                  <a:srgbClr val="7A808A"/>
+                </a:solidFill>
+                <a:latin typeface="Arial Black"/>
+              </a:rPr>
+              <a:t>PISA 2022</a:t>
+            </a:r>
+          </a:p>
+        </p:txBody>
+      </p:sp>
+      <p:sp>
+        <p:nvSpPr>
+          <p:cNvPr id="15" name="Hexagon 14"/>
+          <p:cNvSpPr/>
+          <p:nvPr/>
+        </p:nvSpPr>
+        <p:spPr>
+          <a:xfrm>
+            <a:off x="548640" y="3520439"/>
+            <a:ext cx="2240280" cy="1005840"/>
+          </a:xfrm>
+          <a:prstGeom prst="hexagon">
+            <a:avLst>
+              <a:gd name="adj" fmla="val 50000"/>
+              <a:gd name="vf" fmla="val 115470"/>
+            </a:avLst>
+          </a:prstGeom>
+          <a:solidFill>
+            <a:srgbClr val="FFFFFF"/>
+          </a:solidFill>
+          <a:ln w="38100">
+            <a:solidFill>
+              <a:srgbClr val="0B4DA2"/>
+            </a:solidFill>
+          </a:ln>
+          <a:effectLst/>
+        </p:spPr>
+        <p:style>
+          <a:lnRef idx="1">
+            <a:schemeClr val="accent1"/>
+          </a:lnRef>
+          <a:fillRef idx="3">
+            <a:schemeClr val="accent1"/>
+          </a:fillRef>
+          <a:effectRef idx="2">
+            <a:schemeClr val="accent1"/>
+          </a:effectRef>
+          <a:fontRef idx="minor">
+            <a:schemeClr val="lt1"/>
+          </a:fontRef>
+        </p:style>
+        <p:txBody>
+          <a:bodyPr rtlCol="0" anchor="ctr" lIns="73152" rIns="73152" tIns="18288" bIns="18288" wrap="square"/>
+          <a:lstStyle/>
+          <a:p>
+            <a:pPr algn="ctr"/>
+            <a:r>
+              <a:rPr sz="2200" b="0">
+                <a:solidFill>
+                  <a:srgbClr val="0B4DA2"/>
+                </a:solidFill>
+                <a:latin typeface="Arial Black"/>
+              </a:rPr>
+              <a:t>216 тыс.</a:t>
+            </a:r>
+          </a:p>
+        </p:txBody>
+      </p:sp>
+      <p:sp>
+        <p:nvSpPr>
+          <p:cNvPr id="16" name="TextBox 15"/>
+          <p:cNvSpPr txBox="1"/>
+          <p:nvPr/>
+        </p:nvSpPr>
+        <p:spPr>
+          <a:xfrm>
+            <a:off x="2926080" y="3566159"/>
+            <a:ext cx="2834640" cy="731520"/>
+          </a:xfrm>
+          <a:prstGeom prst="rect">
+            <a:avLst/>
+          </a:prstGeom>
+          <a:noFill/>
+        </p:spPr>
+        <p:txBody>
+          <a:bodyPr wrap="square" lIns="0" rIns="0" tIns="0" bIns="0" anchor="t">
+            <a:spAutoFit/>
+          </a:bodyPr>
+          <a:lstStyle/>
+          <a:p>
+            <a:pPr algn="l"/>
+            <a:r>
+              <a:rPr sz="1200" b="0" i="0">
+                <a:solidFill>
+                  <a:srgbClr val="111111"/>
+                </a:solidFill>
+                <a:latin typeface="Arial Black"/>
+              </a:rPr>
+              <a:t>абитуриентов ЕНТ
+в 2025 году</a:t>
+            </a:r>
+          </a:p>
+        </p:txBody>
+      </p:sp>
+      <p:sp>
+        <p:nvSpPr>
+          <p:cNvPr id="17" name="TextBox 16"/>
+          <p:cNvSpPr txBox="1"/>
+          <p:nvPr/>
+        </p:nvSpPr>
+        <p:spPr>
+          <a:xfrm>
+            <a:off x="2926080" y="4270248"/>
+            <a:ext cx="2834640" cy="228600"/>
+          </a:xfrm>
+          <a:prstGeom prst="rect">
+            <a:avLst/>
+          </a:prstGeom>
+          <a:noFill/>
+        </p:spPr>
+        <p:txBody>
+          <a:bodyPr wrap="square" lIns="0" rIns="0" tIns="0" bIns="0" anchor="t">
+            <a:spAutoFit/>
+          </a:bodyPr>
+          <a:lstStyle/>
+          <a:p>
+            <a:pPr algn="l"/>
+            <a:r>
+              <a:rPr sz="900" b="0" i="0">
+                <a:solidFill>
+                  <a:srgbClr val="7A808A"/>
+                </a:solidFill>
+                <a:latin typeface="Arial Black"/>
+              </a:rPr>
+              <a:t>НЦТ / Вечерняя Астана</a:t>
+            </a:r>
+          </a:p>
+        </p:txBody>
+      </p:sp>
+      <p:sp>
+        <p:nvSpPr>
+          <p:cNvPr id="18" name="Hexagon 17"/>
+          <p:cNvSpPr/>
+          <p:nvPr/>
+        </p:nvSpPr>
+        <p:spPr>
+          <a:xfrm>
+            <a:off x="548640" y="4709160"/>
+            <a:ext cx="2240280" cy="1005840"/>
+          </a:xfrm>
+          <a:prstGeom prst="hexagon">
+            <a:avLst>
+              <a:gd name="adj" fmla="val 50000"/>
+              <a:gd name="vf" fmla="val 115470"/>
+            </a:avLst>
+          </a:prstGeom>
+          <a:solidFill>
+            <a:srgbClr val="FFFFFF"/>
+          </a:solidFill>
+          <a:ln w="38100">
+            <a:solidFill>
+              <a:srgbClr val="0B4DA2"/>
+            </a:solidFill>
+          </a:ln>
+          <a:effectLst/>
+        </p:spPr>
+        <p:style>
+          <a:lnRef idx="1">
+            <a:schemeClr val="accent1"/>
+          </a:lnRef>
+          <a:fillRef idx="3">
+            <a:schemeClr val="accent1"/>
+          </a:fillRef>
+          <a:effectRef idx="2">
+            <a:schemeClr val="accent1"/>
+          </a:effectRef>
+          <a:fontRef idx="minor">
+            <a:schemeClr val="lt1"/>
+          </a:fontRef>
+        </p:style>
+        <p:txBody>
+          <a:bodyPr rtlCol="0" anchor="ctr" lIns="73152" rIns="73152" tIns="18288" bIns="18288" wrap="square"/>
+          <a:lstStyle/>
+          <a:p>
+            <a:pPr algn="ctr"/>
+            <a:r>
+              <a:rPr sz="2200" b="0">
+                <a:solidFill>
+                  <a:srgbClr val="0B4DA2"/>
+                </a:solidFill>
+                <a:latin typeface="Arial Black"/>
+              </a:rPr>
+              <a:t>64/140</a:t>
+            </a:r>
+          </a:p>
+        </p:txBody>
+      </p:sp>
+      <p:sp>
+        <p:nvSpPr>
+          <p:cNvPr id="19" name="TextBox 18"/>
+          <p:cNvSpPr txBox="1"/>
+          <p:nvPr/>
+        </p:nvSpPr>
+        <p:spPr>
+          <a:xfrm>
+            <a:off x="2926080" y="4754880"/>
+            <a:ext cx="2834640" cy="731520"/>
+          </a:xfrm>
+          <a:prstGeom prst="rect">
+            <a:avLst/>
+          </a:prstGeom>
+          <a:noFill/>
+        </p:spPr>
+        <p:txBody>
+          <a:bodyPr wrap="square" lIns="0" rIns="0" tIns="0" bIns="0" anchor="t">
+            <a:spAutoFit/>
+          </a:bodyPr>
+          <a:lstStyle/>
+          <a:p>
+            <a:pPr algn="l"/>
+            <a:r>
+              <a:rPr sz="1200" b="0" i="0">
+                <a:solidFill>
+                  <a:srgbClr val="111111"/>
+                </a:solidFill>
+                <a:latin typeface="Arial Black"/>
+              </a:rPr>
+              <a:t>средний балл ЕНТ-2025
+по пяти предметам</a:t>
+            </a:r>
+          </a:p>
+        </p:txBody>
+      </p:sp>
+      <p:sp>
+        <p:nvSpPr>
+          <p:cNvPr id="20" name="TextBox 19"/>
+          <p:cNvSpPr txBox="1"/>
+          <p:nvPr/>
+        </p:nvSpPr>
+        <p:spPr>
+          <a:xfrm>
+            <a:off x="2926080" y="5458968"/>
+            <a:ext cx="2834640" cy="228600"/>
+          </a:xfrm>
+          <a:prstGeom prst="rect">
+            <a:avLst/>
+          </a:prstGeom>
+          <a:noFill/>
+        </p:spPr>
+        <p:txBody>
+          <a:bodyPr wrap="square" lIns="0" rIns="0" tIns="0" bIns="0" anchor="t">
+            <a:spAutoFit/>
+          </a:bodyPr>
+          <a:lstStyle/>
+          <a:p>
+            <a:pPr algn="l"/>
+            <a:r>
+              <a:rPr sz="900" b="0" i="0">
+                <a:solidFill>
+                  <a:srgbClr val="7A808A"/>
+                </a:solidFill>
+                <a:latin typeface="Arial Black"/>
+              </a:rPr>
+              <a:t>Вечерняя Астана, 02.06.2025</a:t>
+            </a:r>
+          </a:p>
+        </p:txBody>
+      </p:sp>
+      <p:sp>
+        <p:nvSpPr>
+          <p:cNvPr id="21" name="Rectangle 20"/>
+          <p:cNvSpPr/>
+          <p:nvPr/>
+        </p:nvSpPr>
+        <p:spPr>
+          <a:xfrm>
+            <a:off x="5989320" y="2286000"/>
+            <a:ext cx="5532120" cy="3520440"/>
           </a:xfrm>
           <a:prstGeom prst="rect">
             <a:avLst/>
@@ -9758,14 +10217,14 @@
       </p:sp>
       <p:sp>
         <p:nvSpPr>
-          <p:cNvPr id="13" name="Hexagon 12"/>
+          <p:cNvPr id="22" name="Hexagon 21"/>
           <p:cNvSpPr/>
           <p:nvPr/>
         </p:nvSpPr>
         <p:spPr>
           <a:xfrm>
-            <a:off x="914400" y="2395728"/>
-            <a:ext cx="868680" cy="752276"/>
+            <a:off x="6217920" y="2487168"/>
+            <a:ext cx="566928" cy="490959"/>
           </a:xfrm>
           <a:prstGeom prst="hexagon">
             <a:avLst>
@@ -9776,7 +10235,7 @@
           <a:solidFill>
             <a:srgbClr val="0B4DA2"/>
           </a:solidFill>
-          <a:ln w="38100">
+          <a:ln w="25400">
             <a:solidFill>
               <a:srgbClr val="FFFFFF"/>
             </a:solidFill>
@@ -9803,7 +10262,7 @@
           <a:p>
             <a:pPr algn="ctr"/>
             <a:r>
-              <a:rPr sz="2200" b="0">
+              <a:rPr sz="1200" b="0">
                 <a:solidFill>
                   <a:srgbClr val="FFFFFF"/>
                 </a:solidFill>
@@ -9816,14 +10275,14 @@
       </p:sp>
       <p:sp>
         <p:nvSpPr>
-          <p:cNvPr id="14" name="TextBox 13"/>
+          <p:cNvPr id="23" name="TextBox 22"/>
           <p:cNvSpPr txBox="1"/>
           <p:nvPr/>
         </p:nvSpPr>
         <p:spPr>
           <a:xfrm>
-            <a:off x="914400" y="3429000"/>
-            <a:ext cx="2926080" cy="731520"/>
+            <a:off x="6949440" y="2468880"/>
+            <a:ext cx="4389120" cy="365760"/>
           </a:xfrm>
           <a:prstGeom prst="rect">
             <a:avLst/>
@@ -9838,7 +10297,7 @@
           <a:p>
             <a:pPr algn="l"/>
             <a:r>
-              <a:rPr sz="1700" b="0" i="0">
+              <a:rPr sz="1500" b="0" i="0">
                 <a:solidFill>
                   <a:srgbClr val="0B4DA2"/>
                 </a:solidFill>
@@ -9851,14 +10310,14 @@
       </p:sp>
       <p:sp>
         <p:nvSpPr>
-          <p:cNvPr id="15" name="TextBox 14"/>
+          <p:cNvPr id="24" name="TextBox 23"/>
           <p:cNvSpPr txBox="1"/>
           <p:nvPr/>
         </p:nvSpPr>
         <p:spPr>
           <a:xfrm>
-            <a:off x="914400" y="4114800"/>
-            <a:ext cx="2926080" cy="1371600"/>
+            <a:off x="6949440" y="2816352"/>
+            <a:ext cx="4389120" cy="685800"/>
           </a:xfrm>
           <a:prstGeom prst="rect">
             <a:avLst/>
@@ -9873,73 +10332,27 @@
           <a:p>
             <a:pPr algn="l"/>
             <a:r>
-              <a:rPr sz="1300" b="0" i="0">
+              <a:rPr sz="1100" b="0" i="0">
                 <a:solidFill>
                   <a:srgbClr val="4A4F57"/>
                 </a:solidFill>
                 <a:latin typeface="Arial Black"/>
               </a:rPr>
-              <a:t>Каждая тема держится на предыдущих. Пробел в базовой теме всплывает позже — в теме, которая на ней держится.</a:t>
-            </a:r>
-          </a:p>
-        </p:txBody>
-      </p:sp>
-      <p:sp>
-        <p:nvSpPr>
-          <p:cNvPr id="16" name="Rectangle 15"/>
+              <a:t>Пробел в базовой теме всплывает позже — в теме, которая на ней держится.</a:t>
+            </a:r>
+          </a:p>
+        </p:txBody>
+      </p:sp>
+      <p:sp>
+        <p:nvSpPr>
+          <p:cNvPr id="25" name="Hexagon 24"/>
           <p:cNvSpPr/>
           <p:nvPr/>
         </p:nvSpPr>
         <p:spPr>
           <a:xfrm>
-            <a:off x="4389120" y="2743200"/>
-            <a:ext cx="3474720" cy="2788920"/>
-          </a:xfrm>
-          <a:prstGeom prst="rect">
-            <a:avLst/>
-          </a:prstGeom>
-          <a:solidFill>
-            <a:srgbClr val="FFFFFF"/>
-          </a:solidFill>
-          <a:ln w="12700">
-            <a:solidFill>
-              <a:srgbClr val="D5DDE8"/>
-            </a:solidFill>
-          </a:ln>
-          <a:effectLst/>
-        </p:spPr>
-        <p:style>
-          <a:lnRef idx="1">
-            <a:schemeClr val="accent1"/>
-          </a:lnRef>
-          <a:fillRef idx="3">
-            <a:schemeClr val="accent1"/>
-          </a:fillRef>
-          <a:effectRef idx="2">
-            <a:schemeClr val="accent1"/>
-          </a:effectRef>
-          <a:fontRef idx="minor">
-            <a:schemeClr val="lt1"/>
-          </a:fontRef>
-        </p:style>
-        <p:txBody>
-          <a:bodyPr rtlCol="0" anchor="ctr" lIns="73152" rIns="73152" tIns="18288" bIns="18288"/>
-          <a:lstStyle/>
-          <a:p>
-            <a:pPr algn="ctr"/>
-          </a:p>
-        </p:txBody>
-      </p:sp>
-      <p:sp>
-        <p:nvSpPr>
-          <p:cNvPr id="17" name="Hexagon 16"/>
-          <p:cNvSpPr/>
-          <p:nvPr/>
-        </p:nvSpPr>
-        <p:spPr>
-          <a:xfrm>
-            <a:off x="4663440" y="2395728"/>
-            <a:ext cx="868680" cy="752276"/>
+            <a:off x="6217920" y="3584448"/>
+            <a:ext cx="566928" cy="490959"/>
           </a:xfrm>
           <a:prstGeom prst="hexagon">
             <a:avLst>
@@ -9950,7 +10363,7 @@
           <a:solidFill>
             <a:srgbClr val="0B4DA2"/>
           </a:solidFill>
-          <a:ln w="38100">
+          <a:ln w="25400">
             <a:solidFill>
               <a:srgbClr val="FFFFFF"/>
             </a:solidFill>
@@ -9977,7 +10390,7 @@
           <a:p>
             <a:pPr algn="ctr"/>
             <a:r>
-              <a:rPr sz="2200" b="0">
+              <a:rPr sz="1200" b="0">
                 <a:solidFill>
                   <a:srgbClr val="FFFFFF"/>
                 </a:solidFill>
@@ -9990,14 +10403,14 @@
       </p:sp>
       <p:sp>
         <p:nvSpPr>
-          <p:cNvPr id="18" name="TextBox 17"/>
+          <p:cNvPr id="26" name="TextBox 25"/>
           <p:cNvSpPr txBox="1"/>
           <p:nvPr/>
         </p:nvSpPr>
         <p:spPr>
           <a:xfrm>
-            <a:off x="4663440" y="3429000"/>
-            <a:ext cx="2926080" cy="731520"/>
+            <a:off x="6949440" y="3566160"/>
+            <a:ext cx="4389120" cy="365760"/>
           </a:xfrm>
           <a:prstGeom prst="rect">
             <a:avLst/>
@@ -10012,27 +10425,27 @@
           <a:p>
             <a:pPr algn="l"/>
             <a:r>
-              <a:rPr sz="1700" b="0" i="0">
+              <a:rPr sz="1500" b="0" i="0">
                 <a:solidFill>
                   <a:srgbClr val="0B4DA2"/>
                 </a:solidFill>
                 <a:latin typeface="Arial Black"/>
               </a:rPr>
-              <a:t>Тесты измеряют балл</a:t>
-            </a:r>
-          </a:p>
-        </p:txBody>
-      </p:sp>
-      <p:sp>
-        <p:nvSpPr>
-          <p:cNvPr id="19" name="TextBox 18"/>
+              <a:t>Тест измеряет балл</a:t>
+            </a:r>
+          </a:p>
+        </p:txBody>
+      </p:sp>
+      <p:sp>
+        <p:nvSpPr>
+          <p:cNvPr id="27" name="TextBox 26"/>
           <p:cNvSpPr txBox="1"/>
           <p:nvPr/>
         </p:nvSpPr>
         <p:spPr>
           <a:xfrm>
-            <a:off x="4663440" y="4114800"/>
-            <a:ext cx="2926080" cy="1371600"/>
+            <a:off x="6949440" y="3913632"/>
+            <a:ext cx="4389120" cy="685800"/>
           </a:xfrm>
           <a:prstGeom prst="rect">
             <a:avLst/>
@@ -10047,73 +10460,27 @@
           <a:p>
             <a:pPr algn="l"/>
             <a:r>
-              <a:rPr sz="1300" b="0" i="0">
+              <a:rPr sz="1100" b="0" i="0">
                 <a:solidFill>
                   <a:srgbClr val="4A4F57"/>
                 </a:solidFill>
                 <a:latin typeface="Arial Black"/>
               </a:rPr>
-              <a:t>Пробники и контрольные говорят, где ошибка произошла, но не почему. Выбранный неверный вариант не анализируется.</a:t>
-            </a:r>
-          </a:p>
-        </p:txBody>
-      </p:sp>
-      <p:sp>
-        <p:nvSpPr>
-          <p:cNvPr id="20" name="Rectangle 19"/>
+              <a:t>Пробник говорит, где ошибка произошла, но не почему. Выбранный неверный вариант не анализируется.</a:t>
+            </a:r>
+          </a:p>
+        </p:txBody>
+      </p:sp>
+      <p:sp>
+        <p:nvSpPr>
+          <p:cNvPr id="28" name="Hexagon 27"/>
           <p:cNvSpPr/>
           <p:nvPr/>
         </p:nvSpPr>
         <p:spPr>
           <a:xfrm>
-            <a:off x="8138159" y="2743200"/>
-            <a:ext cx="3474720" cy="2788920"/>
-          </a:xfrm>
-          <a:prstGeom prst="rect">
-            <a:avLst/>
-          </a:prstGeom>
-          <a:solidFill>
-            <a:srgbClr val="FFFFFF"/>
-          </a:solidFill>
-          <a:ln w="12700">
-            <a:solidFill>
-              <a:srgbClr val="D5DDE8"/>
-            </a:solidFill>
-          </a:ln>
-          <a:effectLst/>
-        </p:spPr>
-        <p:style>
-          <a:lnRef idx="1">
-            <a:schemeClr val="accent1"/>
-          </a:lnRef>
-          <a:fillRef idx="3">
-            <a:schemeClr val="accent1"/>
-          </a:fillRef>
-          <a:effectRef idx="2">
-            <a:schemeClr val="accent1"/>
-          </a:effectRef>
-          <a:fontRef idx="minor">
-            <a:schemeClr val="lt1"/>
-          </a:fontRef>
-        </p:style>
-        <p:txBody>
-          <a:bodyPr rtlCol="0" anchor="ctr" lIns="73152" rIns="73152" tIns="18288" bIns="18288"/>
-          <a:lstStyle/>
-          <a:p>
-            <a:pPr algn="ctr"/>
-          </a:p>
-        </p:txBody>
-      </p:sp>
-      <p:sp>
-        <p:nvSpPr>
-          <p:cNvPr id="21" name="Hexagon 20"/>
-          <p:cNvSpPr/>
-          <p:nvPr/>
-        </p:nvSpPr>
-        <p:spPr>
-          <a:xfrm>
-            <a:off x="8412480" y="2395728"/>
-            <a:ext cx="868680" cy="752276"/>
+            <a:off x="6217920" y="4681728"/>
+            <a:ext cx="566928" cy="490959"/>
           </a:xfrm>
           <a:prstGeom prst="hexagon">
             <a:avLst>
@@ -10124,7 +10491,7 @@
           <a:solidFill>
             <a:srgbClr val="0B4DA2"/>
           </a:solidFill>
-          <a:ln w="38100">
+          <a:ln w="25400">
             <a:solidFill>
               <a:srgbClr val="FFFFFF"/>
             </a:solidFill>
@@ -10151,7 +10518,7 @@
           <a:p>
             <a:pPr algn="ctr"/>
             <a:r>
-              <a:rPr sz="2200" b="0">
+              <a:rPr sz="1200" b="0">
                 <a:solidFill>
                   <a:srgbClr val="FFFFFF"/>
                 </a:solidFill>
@@ -10164,14 +10531,14 @@
       </p:sp>
       <p:sp>
         <p:nvSpPr>
-          <p:cNvPr id="22" name="TextBox 21"/>
+          <p:cNvPr id="29" name="TextBox 28"/>
           <p:cNvSpPr txBox="1"/>
           <p:nvPr/>
         </p:nvSpPr>
         <p:spPr>
           <a:xfrm>
-            <a:off x="8412480" y="3429000"/>
-            <a:ext cx="2926080" cy="731520"/>
+            <a:off x="6949440" y="4663440"/>
+            <a:ext cx="4389120" cy="365760"/>
           </a:xfrm>
           <a:prstGeom prst="rect">
             <a:avLst/>
@@ -10186,7 +10553,7 @@
           <a:p>
             <a:pPr algn="l"/>
             <a:r>
-              <a:rPr sz="1700" b="0" i="0">
+              <a:rPr sz="1500" b="0" i="0">
                 <a:solidFill>
                   <a:srgbClr val="0B4DA2"/>
                 </a:solidFill>
@@ -10199,14 +10566,14 @@
       </p:sp>
       <p:sp>
         <p:nvSpPr>
-          <p:cNvPr id="23" name="TextBox 22"/>
+          <p:cNvPr id="30" name="TextBox 29"/>
           <p:cNvSpPr txBox="1"/>
           <p:nvPr/>
         </p:nvSpPr>
         <p:spPr>
           <a:xfrm>
-            <a:off x="8412480" y="4114800"/>
-            <a:ext cx="2926080" cy="1371600"/>
+            <a:off x="6949440" y="5010912"/>
+            <a:ext cx="4389120" cy="685800"/>
           </a:xfrm>
           <a:prstGeom prst="rect">
             <a:avLst/>
@@ -10221,27 +10588,27 @@
           <a:p>
             <a:pPr algn="l"/>
             <a:r>
-              <a:rPr sz="1300" b="0" i="0">
+              <a:rPr sz="1100" b="0" i="0">
                 <a:solidFill>
                   <a:srgbClr val="4A4F57"/>
                 </a:solidFill>
                 <a:latin typeface="Arial Black"/>
               </a:rPr>
-              <a:t>В классе 25–30 учеников. Индивидуально проверить каждого по всем темам с 5 по 9 класс невозможно.</a:t>
-            </a:r>
-          </a:p>
-        </p:txBody>
-      </p:sp>
-      <p:sp>
-        <p:nvSpPr>
-          <p:cNvPr id="24" name="TextBox 23"/>
+              <a:t>25–30 учеников в классе: проверить каждого по всем темам 5–9 классов невозможно.</a:t>
+            </a:r>
+          </a:p>
+        </p:txBody>
+      </p:sp>
+      <p:sp>
+        <p:nvSpPr>
+          <p:cNvPr id="31" name="TextBox 30"/>
           <p:cNvSpPr txBox="1"/>
           <p:nvPr/>
         </p:nvSpPr>
         <p:spPr>
           <a:xfrm>
-            <a:off x="640080" y="5806440"/>
-            <a:ext cx="10881360" cy="548640"/>
+            <a:off x="640080" y="5989320"/>
+            <a:ext cx="10881360" cy="457200"/>
           </a:xfrm>
           <a:prstGeom prst="rect">
             <a:avLst/>
@@ -10273,138 +10640,6 @@
               </a:rPr>
               <a:t>«__% учеников не понимают, почему ошиблись в пробнике» (n = __). Заполните по docs/validation-plan.md или удалите строку.</a:t>
             </a:r>
-          </a:p>
-        </p:txBody>
-      </p:sp>
-      <p:sp>
-        <p:nvSpPr>
-          <p:cNvPr id="25" name="Oval 24"/>
-          <p:cNvSpPr/>
-          <p:nvPr/>
-        </p:nvSpPr>
-        <p:spPr>
-          <a:xfrm>
-            <a:off x="11091672" y="1719072"/>
-            <a:ext cx="128016" cy="128016"/>
-          </a:xfrm>
-          <a:prstGeom prst="ellipse">
-            <a:avLst/>
-          </a:prstGeom>
-          <a:solidFill>
-            <a:srgbClr val="0B4DA2"/>
-          </a:solidFill>
-          <a:ln>
-            <a:noFill/>
-          </a:ln>
-          <a:effectLst/>
-        </p:spPr>
-        <p:style>
-          <a:lnRef idx="1">
-            <a:schemeClr val="accent1"/>
-          </a:lnRef>
-          <a:fillRef idx="3">
-            <a:schemeClr val="accent1"/>
-          </a:fillRef>
-          <a:effectRef idx="2">
-            <a:schemeClr val="accent1"/>
-          </a:effectRef>
-          <a:fontRef idx="minor">
-            <a:schemeClr val="lt1"/>
-          </a:fontRef>
-        </p:style>
-        <p:txBody>
-          <a:bodyPr rtlCol="0" anchor="ctr" lIns="73152" rIns="73152" tIns="18288" bIns="18288"/>
-          <a:lstStyle/>
-          <a:p>
-            <a:pPr algn="ctr"/>
-          </a:p>
-        </p:txBody>
-      </p:sp>
-      <p:sp>
-        <p:nvSpPr>
-          <p:cNvPr id="26" name="Oval 25"/>
-          <p:cNvSpPr/>
-          <p:nvPr/>
-        </p:nvSpPr>
-        <p:spPr>
-          <a:xfrm>
-            <a:off x="11521440" y="2057400"/>
-            <a:ext cx="91440" cy="91440"/>
-          </a:xfrm>
-          <a:prstGeom prst="ellipse">
-            <a:avLst/>
-          </a:prstGeom>
-          <a:solidFill>
-            <a:srgbClr val="0B4DA2"/>
-          </a:solidFill>
-          <a:ln>
-            <a:noFill/>
-          </a:ln>
-          <a:effectLst/>
-        </p:spPr>
-        <p:style>
-          <a:lnRef idx="1">
-            <a:schemeClr val="accent1"/>
-          </a:lnRef>
-          <a:fillRef idx="3">
-            <a:schemeClr val="accent1"/>
-          </a:fillRef>
-          <a:effectRef idx="2">
-            <a:schemeClr val="accent1"/>
-          </a:effectRef>
-          <a:fontRef idx="minor">
-            <a:schemeClr val="lt1"/>
-          </a:fontRef>
-        </p:style>
-        <p:txBody>
-          <a:bodyPr rtlCol="0" anchor="ctr" lIns="73152" rIns="73152" tIns="18288" bIns="18288"/>
-          <a:lstStyle/>
-          <a:p>
-            <a:pPr algn="ctr"/>
-          </a:p>
-        </p:txBody>
-      </p:sp>
-      <p:sp>
-        <p:nvSpPr>
-          <p:cNvPr id="27" name="Oval 26"/>
-          <p:cNvSpPr/>
-          <p:nvPr/>
-        </p:nvSpPr>
-        <p:spPr>
-          <a:xfrm>
-            <a:off x="10744200" y="2148840"/>
-            <a:ext cx="91440" cy="91440"/>
-          </a:xfrm>
-          <a:prstGeom prst="ellipse">
-            <a:avLst/>
-          </a:prstGeom>
-          <a:solidFill>
-            <a:srgbClr val="0B4DA2"/>
-          </a:solidFill>
-          <a:ln>
-            <a:noFill/>
-          </a:ln>
-          <a:effectLst/>
-        </p:spPr>
-        <p:style>
-          <a:lnRef idx="1">
-            <a:schemeClr val="accent1"/>
-          </a:lnRef>
-          <a:fillRef idx="3">
-            <a:schemeClr val="accent1"/>
-          </a:fillRef>
-          <a:effectRef idx="2">
-            <a:schemeClr val="accent1"/>
-          </a:effectRef>
-          <a:fontRef idx="minor">
-            <a:schemeClr val="lt1"/>
-          </a:fontRef>
-        </p:style>
-        <p:txBody>
-          <a:bodyPr rtlCol="0" anchor="ctr" lIns="73152" rIns="73152" tIns="18288" bIns="18288"/>
-          <a:lstStyle/>
-          <a:p>
-            <a:pPr algn="ctr"/>
           </a:p>
         </p:txBody>
       </p:sp>
@@ -11002,7 +11237,7 @@
                 </a:solidFill>
                 <a:latin typeface="Arial Black"/>
               </a:rPr>
-              <a:t>Начинаем со сложной темы и спускаемся по графу из 17 тем только там, где есть ошибки. Без пробелов — около 9 вопросов.</a:t>
+              <a:t>Начинаем со сложной темы и спускаемся по графу из 17 тем только там, где есть ошибки. Без пробелов — около 10 вопросов.</a:t>
             </a:r>
           </a:p>
         </p:txBody>
@@ -17178,7 +17413,7 @@
                 </a:solidFill>
                 <a:latin typeface="Arial Black"/>
               </a:rPr>
-              <a:t>79%</a:t>
+              <a:t>90%</a:t>
             </a:r>
           </a:p>
         </p:txBody>
@@ -17272,7 +17507,7 @@
                 </a:solidFill>
                 <a:latin typeface="Arial Black"/>
               </a:rPr>
-              <a:t>72%</a:t>
+              <a:t>85%</a:t>
             </a:r>
           </a:p>
         </p:txBody>
@@ -17366,7 +17601,7 @@
                 </a:solidFill>
                 <a:latin typeface="Arial Black"/>
               </a:rPr>
-              <a:t>9 / 28</a:t>
+              <a:t>7/18</a:t>
             </a:r>
           </a:p>
         </p:txBody>
@@ -17401,8 +17636,8 @@
                 </a:solidFill>
                 <a:latin typeface="Arial Black"/>
               </a:rPr>
-              <a:t>вопросов: без пробелов /
-с одним пробелом</a:t>
+              <a:t>тем спецификации ЕНТ
+покрыто (алгебра)</a:t>
             </a:r>
           </a:p>
         </p:txBody>
@@ -17460,7 +17695,7 @@
                 </a:solidFill>
                 <a:latin typeface="Arial Black"/>
               </a:rPr>
-              <a:t>16/16</a:t>
+              <a:t>20/20</a:t>
             </a:r>
           </a:p>
         </p:txBody>
@@ -17531,7 +17766,7 @@
                 </a:solidFill>
                 <a:latin typeface="Arial Black"/>
               </a:rPr>
-              <a:t>Контрольная симуляция: 1000 новых виртуальных учеников с известными пробелами, не использованных при доработке движка. Модель ученика наша, поэтому это оценка сверху; без шума алгоритм находит 100% корней.</a:t>
+              <a:t>Полнота и точность — контрольная симуляция: 1000 новых виртуальных учеников, не использованных при доработке (было 79% и 72% до правила «перевес в 2»). Модель ученика наша, поэтому это оценка сверху. Покрытие — сверка 17 тем с официальной спецификацией НЦТ (с 2026 г.).</a:t>
             </a:r>
           </a:p>
         </p:txBody>

</xml_diff>

<commit_message>
Fill in team, repo, and demo links on slide 11 and README
Co-Authored-By: Claude Sonnet 5 <noreply@anthropic.com>
</commit_message>
<xml_diff>
--- a/docs/Tamyr_VentureHack2026.pptx
+++ b/docs/Tamyr_VentureHack2026.pptx
@@ -8358,13 +8358,13 @@
           <a:p>
             <a:pPr algn="l"/>
             <a:r>
-              <a:rPr sz="1500" b="0" i="0">
+              <a:rPr sz="1400" b="0" i="0">
                 <a:solidFill>
                   <a:srgbClr val="111111"/>
                 </a:solidFill>
                 <a:latin typeface="Arial Black"/>
               </a:rPr>
-              <a:t>Команда: [Имя — роль] · [Имя — роль] · [Имя — роль]</a:t>
+              <a:t>Команда: Bolatbay Yersultan · Zharkynuly Eren · Kydyrkhan Olzhas</a:t>
             </a:r>
           </a:p>
         </p:txBody>
@@ -8393,13 +8393,13 @@
           <a:p>
             <a:pPr algn="l"/>
             <a:r>
-              <a:rPr sz="1200" b="0" i="0">
+              <a:rPr sz="1100" b="0" i="0">
                 <a:solidFill>
                   <a:srgbClr val="4A4F57"/>
                 </a:solidFill>
                 <a:latin typeface="Arial Black"/>
               </a:rPr>
-              <a:t>GitHub: [ссылка на репозиторий]   ·   Демо: [ссылка на GitHub Pages]</a:t>
+              <a:t>GitHub: github.com/sas1k00/hackathonchik   ·   Демо: sas1k00.github.io/hackathonchik</a:t>
             </a:r>
           </a:p>
         </p:txBody>

</xml_diff>

<commit_message>
Add real teacher interview data to validation, deck, README, pitch
Interviewed 4 teachers/tutors (school math, private tutor, learning
center, physics). All independently confirmed the core thesis: an
error in an advanced topic traces to a gap in an earlier one. Used
their quoted pricing (tutor 5-10k tg/mo, center 30-70k tg/mo or
500-1.5k/student) to replace the pure-hypothesis pricing on the
market slide, and their diagnosis-time estimates as a real comparison
against Tamyr's question count.

Student survey (n=30) NOT used: all responses arrived within a
49-second window, which does not look like organic collection and
risks reading as fabricated data under the hackathon's rules (5.4).
Noted transparently in validation-plan.md with the raw timing and a
path to redo it properly if time allows.

Co-Authored-By: Claude Sonnet 5 <noreply@anthropic.com>
</commit_message>
<xml_diff>
--- a/docs/Tamyr_VentureHack2026.pptx
+++ b/docs/Tamyr_VentureHack2026.pptx
@@ -932,7 +932,7 @@
           <a:lstStyle/>
           <a:p>
             <a:r>
-              <a:t>Говорите честно: это симуляция. Затем назовите то, что проверили на людях. Если ничего не успели, скажите, что пилот запланирован, и удалите пустые поля.</a:t>
+              <a:t>Говорите честно про симуляцию, затем — что реально проверили: 4 интервью (docs/validation-plan.md). Опрос учеников собран, но временные метки ответов не проходят проверку на подлинность — не выносите его на слайд, пока не подтверждено, как именно он собирался.</a:t>
             </a:r>
           </a:p>
         </p:txBody>
@@ -1002,7 +1002,7 @@
           <a:lstStyle/>
           <a:p>
             <a:r>
-              <a:t>Цены — гипотезы, их надо проверить на интервью (docs/validation-plan.md, вопрос 5 для учителей). 184 тыс. — оценка: 216 тыс. минус около 15% творческих специальностей.</a:t>
+              <a:t>Цены репетитора и центра — из 2 реальных интервью (не гипотеза), см. docs/validation-plan.md. Школьная цена — всё ещё гипотеза, честно так и скажите. 184 тыс. — оценка: 216 тыс. минус около 15% творческих специальностей.</a:t>
             </a:r>
           </a:p>
         </p:txBody>
@@ -7102,7 +7102,7 @@
                 </a:solidFill>
                 <a:latin typeface="Arial Black"/>
               </a:rPr>
-              <a:t>Деньги (гипотезы)</a:t>
+              <a:t>Деньги</a:t>
             </a:r>
           </a:p>
         </p:txBody>
@@ -7142,7 +7142,7 @@
                 </a:solidFill>
                 <a:latin typeface="Arial Black"/>
               </a:rPr>
-              <a:t>Ученик: диагностика бесплатно, платные банки тем</a:t>
+              <a:t>По интервью (n=4): репетитор — 5–10 тыс ₸/мес</a:t>
             </a:r>
           </a:p>
           <a:p>
@@ -7159,7 +7159,7 @@
                 </a:solidFill>
                 <a:latin typeface="Arial Black"/>
               </a:rPr>
-              <a:t>Учебные центры: входная диагностика и панель по подписке</a:t>
+              <a:t>Учебный центр: 30–70 тыс ₸/мес, либо 500–1 500 ₸/ученика</a:t>
             </a:r>
           </a:p>
           <a:p>
@@ -7176,7 +7176,7 @@
                 </a:solidFill>
                 <a:latin typeface="Arial Black"/>
               </a:rPr>
-              <a:t>Школы: бесплатно для учителя ради охвата</a:t>
+              <a:t>Школа: бесплатно для учителя ради охвата (гипотеза)</a:t>
             </a:r>
           </a:p>
         </p:txBody>
@@ -7190,7 +7190,7 @@
         <p:spPr>
           <a:xfrm>
             <a:off x="640080" y="6309360"/>
-            <a:ext cx="6400800" cy="274320"/>
+            <a:ext cx="8229600" cy="274320"/>
           </a:xfrm>
           <a:prstGeom prst="rect">
             <a:avLst/>
@@ -7211,7 +7211,7 @@
                 </a:solidFill>
                 <a:latin typeface="Arial Black"/>
               </a:rPr>
-              <a:t>Источники: НЦТ (формат ЕНТ); Вечерняя Астана, 02.06.2025</a:t>
+              <a:t>Источники: НЦТ (формат ЕНТ); Вечерняя Астана, 02.06.2025; интервью с 4 преподавателями, сентябрь 2026</a:t>
             </a:r>
           </a:p>
         </p:txBody>
@@ -17779,8 +17779,8 @@
         </p:nvSpPr>
         <p:spPr>
           <a:xfrm>
-            <a:off x="640080" y="5577840"/>
-            <a:ext cx="10881360" cy="777240"/>
+            <a:off x="640080" y="5532120"/>
+            <a:ext cx="10881360" cy="1005840"/>
           </a:xfrm>
           <a:prstGeom prst="rect">
             <a:avLst/>
@@ -17792,7 +17792,6 @@
             <a:solidFill>
               <a:srgbClr val="0B4DA2"/>
             </a:solidFill>
-            <a:prstDash val="dash"/>
           </a:ln>
           <a:effectLst/>
         </p:spPr>
@@ -17826,8 +17825,8 @@
         </p:nvSpPr>
         <p:spPr>
           <a:xfrm>
-            <a:off x="868680" y="5650992"/>
-            <a:ext cx="10424160" cy="640080"/>
+            <a:off x="868680" y="5614416"/>
+            <a:ext cx="10424160" cy="868680"/>
           </a:xfrm>
           <a:prstGeom prst="rect">
             <a:avLst/>
@@ -17840,7 +17839,11 @@
           </a:bodyPr>
           <a:lstStyle/>
           <a:p>
-            <a:pPr algn="l"/>
+            <a:pPr algn="l">
+              <a:spcAft>
+                <a:spcPts val="300"/>
+              </a:spcAft>
+            </a:pPr>
             <a:r>
               <a:rPr sz="1100" b="0" i="0">
                 <a:solidFill>
@@ -17848,7 +17851,7 @@
                 </a:solidFill>
                 <a:latin typeface="Arial Black"/>
               </a:rPr>
-              <a:t>Проверка на людях — заполните реальными данными: </a:t>
+              <a:t>Проверено на людях: </a:t>
             </a:r>
             <a:r>
               <a:rPr sz="1100" b="0" i="0">
@@ -17857,7 +17860,32 @@
                 </a:solidFill>
                 <a:latin typeface="Arial Black"/>
               </a:rPr>
-              <a:t>опрос учеников (n = __), интервью с учителями (__ чел.), мини-пилот: совпадение корня с мнением учителя __ из __. Шаблоны: docs/validation-plan.md</a:t>
+              <a:t>интервью с 4 преподавателями (учитель математики, репетитор, преподаватель учебного центра, учитель физики).</a:t>
+            </a:r>
+          </a:p>
+          <a:p>
+            <a:pPr algn="l">
+              <a:spcAft>
+                <a:spcPts val="300"/>
+              </a:spcAft>
+            </a:pPr>
+            <a:r>
+              <a:rPr sz="1100" b="0" i="1">
+                <a:solidFill>
+                  <a:srgbClr val="111111"/>
+                </a:solidFill>
+                <a:latin typeface="Arial Black"/>
+              </a:rPr>
+              <a:t>«Ученик не может решать квадратные уравнения, а проблема — в отрицательных числах, дробях или раскрытии скобок» — учитель математики. </a:t>
+            </a:r>
+            <a:r>
+              <a:rPr sz="1100" b="0" i="0">
+                <a:solidFill>
+                  <a:srgbClr val="111111"/>
+                </a:solidFill>
+                <a:latin typeface="Arial Black"/>
+              </a:rPr>
+              <a:t>Ручная диагностика занимает от одного занятия до недели; Tamyr — 10–34 вопроса.</a:t>
             </a:r>
           </a:p>
         </p:txBody>

</xml_diff>

<commit_message>
Use the clean subset of the student survey (n=13) on slide 3
43 total responses collected across two batches. The first 30 still
arrive in a 49-second window and are excluded, same as before. The
13 collected afterward have organic timing (minutes to hours apart,
one batch overnight) and include free-text answers a script wouldn't
produce ("hz", "nothing") plus natural variance missing from the
first batch (3/13 picked "почти всегда" vs 0/30). Used the n=13
figure (77% don't understand their mistakes) on slide 3 and recorded
the full breakdown and reasoning in validation-plan.md.

Co-Authored-By: Claude Sonnet 5 <noreply@anthropic.com>
</commit_message>
<xml_diff>
--- a/docs/Tamyr_VentureHack2026.pptx
+++ b/docs/Tamyr_VentureHack2026.pptx
@@ -652,7 +652,7 @@
           <a:lstStyle/>
           <a:p>
             <a:r>
-              <a:t>Цифры проверены по первоисточникам (README → «Источники»): OECD PISA 2022 Country Note: Kazakhstan; ЕНТ-2025 — Вечерняя Астана, 02.06.2025. Если провели опрос, назовите свою цифру; если нет, удалите нижнюю строку.</a:t>
+              <a:t>Цифры сверху проверены по первоисточникам (README → «Источники»): OECD PISA 2022 Country Note: Kazakhstan; ЕНТ-2025 — Вечерняя Астана, 02.06.2025. Нижняя строка — наш опрос, n=13: только ответы с правдоподобными по времени отметками. Ещё 30 ответов пришли за 49 секунд подряд и не используются — подробности в docs/validation-plan.md.</a:t>
             </a:r>
           </a:p>
         </p:txBody>
@@ -10625,20 +10625,20 @@
             <a:r>
               <a:rPr sz="1100" b="0" i="0">
                 <a:solidFill>
-                  <a:srgbClr val="E0473E"/>
-                </a:solidFill>
-                <a:latin typeface="Arial Black"/>
-              </a:rPr>
-              <a:t>Место для вашей цифры из опроса: </a:t>
+                  <a:srgbClr val="0B4DA2"/>
+                </a:solidFill>
+                <a:latin typeface="Arial Black"/>
+              </a:rPr>
+              <a:t>Наш опрос учеников (n = 13): </a:t>
             </a:r>
             <a:r>
               <a:rPr sz="1100" b="0" i="0">
                 <a:solidFill>
-                  <a:srgbClr val="4A4F57"/>
-                </a:solidFill>
-                <a:latin typeface="Arial Black"/>
-              </a:rPr>
-              <a:t>«__% учеников не понимают, почему ошиблись в пробнике» (n = __). Заполните по docs/validation-plan.md или удалите строку.</a:t>
+                  <a:srgbClr val="111111"/>
+                </a:solidFill>
+                <a:latin typeface="Arial Black"/>
+              </a:rPr>
+              <a:t>77% сказали, что «иногда» или «редко» понимают, почему ошиблись в пробнике.</a:t>
             </a:r>
           </a:p>
         </p:txBody>

</xml_diff>